<commit_message>
Add Week 5 module: Linux CLI & Wireshark presentation, CyberShark packet analyzer, and Challenge 0x02 PCAP
</commit_message>
<xml_diff>
--- a/week4/BaySec_Week4_Kickoff.pptx
+++ b/week4/BaySec_Week4_Kickoff.pptx
@@ -4,17 +4,20 @@
   <p:sldMasterIdLst>
     <p:sldMasterId id="2147483648" r:id="rId1"/>
   </p:sldMasterIdLst>
+  <p:notesMasterIdLst>
+    <p:notesMasterId r:id="rId10"/>
+  </p:notesMasterIdLst>
   <p:sldIdLst>
-    <p:sldId id="256" r:id="rId7"/>
-    <p:sldId id="257" r:id="rId9"/>
-    <p:sldId id="258" r:id="rId10"/>
-    <p:sldId id="259" r:id="rId11"/>
-    <p:sldId id="260" r:id="rId12"/>
-    <p:sldId id="261" r:id="rId13"/>
-    <p:sldId id="262" r:id="rId14"/>
-    <p:sldId id="263" r:id="rId15"/>
+    <p:sldId id="256" r:id="rId2"/>
+    <p:sldId id="257" r:id="rId3"/>
+    <p:sldId id="258" r:id="rId4"/>
+    <p:sldId id="259" r:id="rId5"/>
+    <p:sldId id="260" r:id="rId6"/>
+    <p:sldId id="261" r:id="rId7"/>
+    <p:sldId id="262" r:id="rId8"/>
+    <p:sldId id="263" r:id="rId9"/>
   </p:sldIdLst>
-  <p:sldSz cx="12191695" cy="6858000" type="screen4x3"/>
+  <p:sldSz cx="12192000" cy="6858000"/>
   <p:notesSz cx="6858000" cy="9144000"/>
   <p:defaultTextStyle>
     <a:defPPr>
@@ -111,11 +114,27 @@
       </a:defRPr>
     </a:lvl9pPr>
   </p:defaultTextStyle>
+  <p:extLst>
+    <p:ext uri="{EFAFB233-063F-42B5-8137-9DF3F51BA10A}">
+      <p15:sldGuideLst xmlns:p15="http://schemas.microsoft.com/office/powerpoint/2012/main">
+        <p15:guide id="1" orient="horz" pos="2160">
+          <p15:clr>
+            <a:srgbClr val="A4A3A4"/>
+          </p15:clr>
+        </p15:guide>
+        <p15:guide id="2" pos="2880">
+          <p15:clr>
+            <a:srgbClr val="A4A3A4"/>
+          </p15:clr>
+        </p15:guide>
+      </p15:sldGuideLst>
+    </p:ext>
+  </p:extLst>
 </p:presentation>
 </file>
 
 <file path=ppt/notesMasters/notesMaster1.xml><?xml version="1.0" encoding="utf-8"?>
-<p:notesMaster xmlns:a="http://schemas.openxmlformats.org/drawingml/2006/main" xmlns:p="http://schemas.openxmlformats.org/presentationml/2006/main" xmlns:r="http://schemas.openxmlformats.org/officeDocument/2006/relationships">
+<p:notesMaster xmlns:a="http://schemas.openxmlformats.org/drawingml/2006/main" xmlns:r="http://schemas.openxmlformats.org/officeDocument/2006/relationships" xmlns:p="http://schemas.openxmlformats.org/presentationml/2006/main">
   <p:cSld>
     <p:bg>
       <p:bgRef idx="1001">
@@ -136,241 +155,16 @@
           <a:chExt cx="0" cy="0"/>
         </a:xfrm>
       </p:grpSpPr>
-      <p:sp>
-        <p:nvSpPr>
-          <p:cNvPr id="2" name="Header Placeholder 1"/>
-          <p:cNvSpPr>
-            <a:spLocks noGrp="1"/>
-          </p:cNvSpPr>
-          <p:nvPr>
-            <p:ph type="hdr" sz="quarter"/>
-          </p:nvPr>
-        </p:nvSpPr>
-        <p:spPr>
-          <a:xfrm>
-            <a:off x="0" y="0"/>
-            <a:ext cx="2971800" cy="457200"/>
-          </a:xfrm>
-          <a:prstGeom prst="rect">
-            <a:avLst/>
-          </a:prstGeom>
-        </p:spPr>
-        <p:txBody>
-          <a:bodyPr vert="horz" lIns="91440" tIns="45720" rIns="91440" bIns="45720" rtlCol="0"/>
-          <a:lstStyle>
-            <a:lvl1pPr algn="l">
-              <a:defRPr sz="1200"/>
-            </a:lvl1pPr>
-          </a:lstStyle>
-          <a:p>
-            <a:endParaRPr lang="en-US"/>
-          </a:p>
-        </p:txBody>
-      </p:sp>
-      <p:sp>
-        <p:nvSpPr>
-          <p:cNvPr id="3" name="Date Placeholder 2"/>
-          <p:cNvSpPr>
-            <a:spLocks noGrp="1"/>
-          </p:cNvSpPr>
-          <p:nvPr>
-            <p:ph type="dt" idx="1"/>
-          </p:nvPr>
-        </p:nvSpPr>
-        <p:spPr>
-          <a:xfrm>
-            <a:off x="3884613" y="0"/>
-            <a:ext cx="2971800" cy="457200"/>
-          </a:xfrm>
-          <a:prstGeom prst="rect">
-            <a:avLst/>
-          </a:prstGeom>
-        </p:spPr>
-        <p:txBody>
-          <a:bodyPr vert="horz" lIns="91440" tIns="45720" rIns="91440" bIns="45720" rtlCol="0"/>
-          <a:lstStyle>
-            <a:lvl1pPr algn="r">
-              <a:defRPr sz="1200"/>
-            </a:lvl1pPr>
-          </a:lstStyle>
-          <a:p>
-            <a:fld id="{0F89C1C7-3DCD-1040-A9CF-14679D8B5DDD}" type="datetimeFigureOut">
-              <a:rPr lang="en-US" smtClean="0"/>
-              <a:t>10/17/16</a:t>
-            </a:fld>
-            <a:endParaRPr lang="en-US"/>
-          </a:p>
-        </p:txBody>
-      </p:sp>
-      <p:sp>
-        <p:nvSpPr>
-          <p:cNvPr id="4" name="Slide Image Placeholder 3"/>
-          <p:cNvSpPr>
-            <a:spLocks noGrp="1" noRot="1" noChangeAspect="1"/>
-          </p:cNvSpPr>
-          <p:nvPr>
-            <p:ph type="sldImg" idx="2"/>
-          </p:nvPr>
-        </p:nvSpPr>
-        <p:spPr>
-          <a:xfrm>
-            <a:off x="1143000" y="685800"/>
-            <a:ext cx="4572000" cy="3429000"/>
-          </a:xfrm>
-          <a:prstGeom prst="rect">
-            <a:avLst/>
-          </a:prstGeom>
-          <a:noFill/>
-          <a:ln w="12700">
-            <a:solidFill>
-              <a:prstClr val="black"/>
-            </a:solidFill>
-          </a:ln>
-        </p:spPr>
-        <p:txBody>
-          <a:bodyPr vert="horz" lIns="91440" tIns="45720" rIns="91440" bIns="45720" rtlCol="0" anchor="ctr"/>
-          <a:lstStyle/>
-          <a:p>
-            <a:endParaRPr lang="en-US"/>
-          </a:p>
-        </p:txBody>
-      </p:sp>
-      <p:sp>
-        <p:nvSpPr>
-          <p:cNvPr id="5" name="Notes Placeholder 4"/>
-          <p:cNvSpPr>
-            <a:spLocks noGrp="1"/>
-          </p:cNvSpPr>
-          <p:nvPr>
-            <p:ph type="body" sz="quarter" idx="3"/>
-          </p:nvPr>
-        </p:nvSpPr>
-        <p:spPr>
-          <a:xfrm>
-            <a:off x="685800" y="4343400"/>
-            <a:ext cx="5486400" cy="4114800"/>
-          </a:xfrm>
-          <a:prstGeom prst="rect">
-            <a:avLst/>
-          </a:prstGeom>
-        </p:spPr>
-        <p:txBody>
-          <a:bodyPr vert="horz" lIns="91440" tIns="45720" rIns="91440" bIns="45720" rtlCol="0"/>
-          <a:lstStyle/>
-          <a:p>
-            <a:pPr lvl="0"/>
-            <a:r>
-              <a:rPr lang="en-US" smtClean="0"/>
-              <a:t>Click to edit Master text styles</a:t>
-            </a:r>
-          </a:p>
-          <a:p>
-            <a:pPr lvl="1"/>
-            <a:r>
-              <a:rPr lang="en-US" smtClean="0"/>
-              <a:t>Second level</a:t>
-            </a:r>
-          </a:p>
-          <a:p>
-            <a:pPr lvl="2"/>
-            <a:r>
-              <a:rPr lang="en-US" smtClean="0"/>
-              <a:t>Third level</a:t>
-            </a:r>
-          </a:p>
-          <a:p>
-            <a:pPr lvl="3"/>
-            <a:r>
-              <a:rPr lang="en-US" smtClean="0"/>
-              <a:t>Fourth level</a:t>
-            </a:r>
-          </a:p>
-          <a:p>
-            <a:pPr lvl="4"/>
-            <a:r>
-              <a:rPr lang="en-US" smtClean="0"/>
-              <a:t>Fifth level</a:t>
-            </a:r>
-            <a:endParaRPr lang="en-US"/>
-          </a:p>
-        </p:txBody>
-      </p:sp>
-      <p:sp>
-        <p:nvSpPr>
-          <p:cNvPr id="6" name="Footer Placeholder 5"/>
-          <p:cNvSpPr>
-            <a:spLocks noGrp="1"/>
-          </p:cNvSpPr>
-          <p:nvPr>
-            <p:ph type="ftr" sz="quarter" idx="4"/>
-          </p:nvPr>
-        </p:nvSpPr>
-        <p:spPr>
-          <a:xfrm>
-            <a:off x="0" y="8685213"/>
-            <a:ext cx="2971800" cy="457200"/>
-          </a:xfrm>
-          <a:prstGeom prst="rect">
-            <a:avLst/>
-          </a:prstGeom>
-        </p:spPr>
-        <p:txBody>
-          <a:bodyPr vert="horz" lIns="91440" tIns="45720" rIns="91440" bIns="45720" rtlCol="0" anchor="b"/>
-          <a:lstStyle>
-            <a:lvl1pPr algn="l">
-              <a:defRPr sz="1200"/>
-            </a:lvl1pPr>
-          </a:lstStyle>
-          <a:p>
-            <a:endParaRPr lang="en-US"/>
-          </a:p>
-        </p:txBody>
-      </p:sp>
-      <p:sp>
-        <p:nvSpPr>
-          <p:cNvPr id="7" name="Slide Number Placeholder 6"/>
-          <p:cNvSpPr>
-            <a:spLocks noGrp="1"/>
-          </p:cNvSpPr>
-          <p:nvPr>
-            <p:ph type="sldNum" sz="quarter" idx="5"/>
-          </p:nvPr>
-        </p:nvSpPr>
-        <p:spPr>
-          <a:xfrm>
-            <a:off x="3884613" y="8685213"/>
-            <a:ext cx="2971800" cy="457200"/>
-          </a:xfrm>
-          <a:prstGeom prst="rect">
-            <a:avLst/>
-          </a:prstGeom>
-        </p:spPr>
-        <p:txBody>
-          <a:bodyPr vert="horz" lIns="91440" tIns="45720" rIns="91440" bIns="45720" rtlCol="0" anchor="b"/>
-          <a:lstStyle>
-            <a:lvl1pPr algn="r">
-              <a:defRPr sz="1200"/>
-            </a:lvl1pPr>
-          </a:lstStyle>
-          <a:p>
-            <a:fld id="{BB5E49A5-4136-284D-997B-48E1D791AD67}" type="slidenum">
-              <a:rPr lang="en-US" smtClean="0"/>
-              <a:t>‹#›</a:t>
-            </a:fld>
-            <a:endParaRPr lang="en-US"/>
-          </a:p>
-        </p:txBody>
-      </p:sp>
     </p:spTree>
     <p:extLst>
       <p:ext uri="{BB962C8B-B14F-4D97-AF65-F5344CB8AC3E}">
-        <p14:creationId xmlns:p14="http://schemas.microsoft.com/office/powerpoint/2010/main" val="2623252185"/>
+        <p14:creationId xmlns:p14="http://schemas.microsoft.com/office/powerpoint/2010/main" val="1366494735"/>
       </p:ext>
     </p:extLst>
   </p:cSld>
   <p:clrMap bg1="lt1" tx1="dk1" bg2="lt2" tx2="dk2" accent1="accent1" accent2="accent2" accent3="accent3" accent4="accent4" accent5="accent5" accent6="accent6" hlink="hlink" folHlink="folHlink"/>
   <p:notesStyle>
-    <a:lvl1pPr marL="0" algn="l" defTabSz="457200" rtl="0" eaLnBrk="1" latinLnBrk="0" hangingPunct="1">
+    <a:lvl1pPr marL="0" algn="l" defTabSz="914400" rtl="0" eaLnBrk="1" latinLnBrk="0" hangingPunct="1">
       <a:defRPr sz="1200" kern="1200">
         <a:solidFill>
           <a:schemeClr val="tx1"/>
@@ -380,7 +174,7 @@
         <a:cs typeface="+mn-cs"/>
       </a:defRPr>
     </a:lvl1pPr>
-    <a:lvl2pPr marL="457200" algn="l" defTabSz="457200" rtl="0" eaLnBrk="1" latinLnBrk="0" hangingPunct="1">
+    <a:lvl2pPr marL="457200" algn="l" defTabSz="914400" rtl="0" eaLnBrk="1" latinLnBrk="0" hangingPunct="1">
       <a:defRPr sz="1200" kern="1200">
         <a:solidFill>
           <a:schemeClr val="tx1"/>
@@ -390,7 +184,7 @@
         <a:cs typeface="+mn-cs"/>
       </a:defRPr>
     </a:lvl2pPr>
-    <a:lvl3pPr marL="914400" algn="l" defTabSz="457200" rtl="0" eaLnBrk="1" latinLnBrk="0" hangingPunct="1">
+    <a:lvl3pPr marL="914400" algn="l" defTabSz="914400" rtl="0" eaLnBrk="1" latinLnBrk="0" hangingPunct="1">
       <a:defRPr sz="1200" kern="1200">
         <a:solidFill>
           <a:schemeClr val="tx1"/>
@@ -400,7 +194,7 @@
         <a:cs typeface="+mn-cs"/>
       </a:defRPr>
     </a:lvl3pPr>
-    <a:lvl4pPr marL="1371600" algn="l" defTabSz="457200" rtl="0" eaLnBrk="1" latinLnBrk="0" hangingPunct="1">
+    <a:lvl4pPr marL="1371600" algn="l" defTabSz="914400" rtl="0" eaLnBrk="1" latinLnBrk="0" hangingPunct="1">
       <a:defRPr sz="1200" kern="1200">
         <a:solidFill>
           <a:schemeClr val="tx1"/>
@@ -410,7 +204,7 @@
         <a:cs typeface="+mn-cs"/>
       </a:defRPr>
     </a:lvl4pPr>
-    <a:lvl5pPr marL="1828800" algn="l" defTabSz="457200" rtl="0" eaLnBrk="1" latinLnBrk="0" hangingPunct="1">
+    <a:lvl5pPr marL="1828800" algn="l" defTabSz="914400" rtl="0" eaLnBrk="1" latinLnBrk="0" hangingPunct="1">
       <a:defRPr sz="1200" kern="1200">
         <a:solidFill>
           <a:schemeClr val="tx1"/>
@@ -420,7 +214,7 @@
         <a:cs typeface="+mn-cs"/>
       </a:defRPr>
     </a:lvl5pPr>
-    <a:lvl6pPr marL="2286000" algn="l" defTabSz="457200" rtl="0" eaLnBrk="1" latinLnBrk="0" hangingPunct="1">
+    <a:lvl6pPr marL="2286000" algn="l" defTabSz="914400" rtl="0" eaLnBrk="1" latinLnBrk="0" hangingPunct="1">
       <a:defRPr sz="1200" kern="1200">
         <a:solidFill>
           <a:schemeClr val="tx1"/>
@@ -430,7 +224,7 @@
         <a:cs typeface="+mn-cs"/>
       </a:defRPr>
     </a:lvl6pPr>
-    <a:lvl7pPr marL="2743200" algn="l" defTabSz="457200" rtl="0" eaLnBrk="1" latinLnBrk="0" hangingPunct="1">
+    <a:lvl7pPr marL="2743200" algn="l" defTabSz="914400" rtl="0" eaLnBrk="1" latinLnBrk="0" hangingPunct="1">
       <a:defRPr sz="1200" kern="1200">
         <a:solidFill>
           <a:schemeClr val="tx1"/>
@@ -440,7 +234,7 @@
         <a:cs typeface="+mn-cs"/>
       </a:defRPr>
     </a:lvl7pPr>
-    <a:lvl8pPr marL="3200400" algn="l" defTabSz="457200" rtl="0" eaLnBrk="1" latinLnBrk="0" hangingPunct="1">
+    <a:lvl8pPr marL="3200400" algn="l" defTabSz="914400" rtl="0" eaLnBrk="1" latinLnBrk="0" hangingPunct="1">
       <a:defRPr sz="1200" kern="1200">
         <a:solidFill>
           <a:schemeClr val="tx1"/>
@@ -450,7 +244,7 @@
         <a:cs typeface="+mn-cs"/>
       </a:defRPr>
     </a:lvl8pPr>
-    <a:lvl9pPr marL="3657600" algn="l" defTabSz="457200" rtl="0" eaLnBrk="1" latinLnBrk="0" hangingPunct="1">
+    <a:lvl9pPr marL="3657600" algn="l" defTabSz="914400" rtl="0" eaLnBrk="1" latinLnBrk="0" hangingPunct="1">
       <a:defRPr sz="1200" kern="1200">
         <a:solidFill>
           <a:schemeClr val="tx1"/>
@@ -465,7 +259,7 @@
 </file>
 
 <file path=ppt/notesSlides/notesSlide1.xml><?xml version="1.0" encoding="utf-8"?>
-<p:notes xmlns:a="http://schemas.openxmlformats.org/drawingml/2006/main" xmlns:p="http://schemas.openxmlformats.org/presentationml/2006/main" xmlns:r="http://schemas.openxmlformats.org/officeDocument/2006/relationships">
+<p:notes xmlns:a="http://schemas.openxmlformats.org/drawingml/2006/main" xmlns:r="http://schemas.openxmlformats.org/officeDocument/2006/relationships" xmlns:p="http://schemas.openxmlformats.org/presentationml/2006/main">
   <p:cSld>
     <p:spTree>
       <p:nvGrpSpPr>
@@ -485,43 +279,43 @@
         <p:nvSpPr>
           <p:cNvPr id="2" name="Slide Image Placeholder 1"/>
           <p:cNvSpPr>
+            <a:spLocks noGrp="1" noRot="1" noChangeAspect="1"/>
+          </p:cNvSpPr>
+          <p:nvPr>
+            <p:ph type="sldImg" idx="2"/>
+          </p:nvPr>
+        </p:nvSpPr>
+        <p:spPr/>
+      </p:sp>
+      <p:sp>
+        <p:nvSpPr>
+          <p:cNvPr id="3" name="Notes Placeholder 2"/>
+          <p:cNvSpPr>
             <a:spLocks noGrp="1"/>
           </p:cNvSpPr>
           <p:nvPr>
-            <p:ph type="sldImg" idx="2"/>
+            <p:ph type="body" sz="quarter" idx="3"/>
           </p:nvPr>
         </p:nvSpPr>
         <p:spPr/>
-      </p:sp>
-      <p:sp>
-        <p:nvSpPr>
-          <p:cNvPr id="3" name="Notes Placeholder 2"/>
+        <p:txBody>
+          <a:bodyPr/>
+          <a:lstStyle/>
+          <a:p>
+            <a:r>
+              <a:t>Welcome everyone to the official kickoff of BaySec @ SFBU! While everyone gets seated, take a moment to scan the QR codes on screen to mark your attendance and get plugged into our official WhatsApp group. That’s where we’ll drop lab resources, room updates, and CTF announcements.</a:t>
+            </a:r>
+          </a:p>
+        </p:txBody>
+      </p:sp>
+      <p:sp>
+        <p:nvSpPr>
+          <p:cNvPr id="4" name="Slide Number Placeholder 3"/>
           <p:cNvSpPr>
             <a:spLocks noGrp="1"/>
           </p:cNvSpPr>
           <p:nvPr>
-            <p:ph type="body" idx="3" sz="quarter"/>
-          </p:nvPr>
-        </p:nvSpPr>
-        <p:spPr/>
-        <p:txBody>
-          <a:bodyPr/>
-          <a:lstStyle/>
-          <a:p>
-            <a:r>
-              <a:t>Welcome everyone to the official kickoff of BaySec @ SFBU! While everyone gets seated, take a moment to scan the QR codes on screen to mark your attendance and get plugged into our official WhatsApp group. That’s where we’ll drop lab resources, room updates, and CTF announcements.</a:t>
-            </a:r>
-          </a:p>
-        </p:txBody>
-      </p:sp>
-      <p:sp>
-        <p:nvSpPr>
-          <p:cNvPr id="4" name="Slide Number Placeholder 3"/>
-          <p:cNvSpPr>
-            <a:spLocks noGrp="1"/>
-          </p:cNvSpPr>
-          <p:nvPr>
-            <p:ph type="sldNum" idx="5" sz="quarter"/>
+            <p:ph type="sldNum" sz="quarter" idx="5"/>
           </p:nvPr>
         </p:nvSpPr>
         <p:spPr/>
@@ -535,7 +329,7 @@
 </file>
 
 <file path=ppt/notesSlides/notesSlide2.xml><?xml version="1.0" encoding="utf-8"?>
-<p:notes xmlns:a="http://schemas.openxmlformats.org/drawingml/2006/main" xmlns:p="http://schemas.openxmlformats.org/presentationml/2006/main" xmlns:r="http://schemas.openxmlformats.org/officeDocument/2006/relationships">
+<p:notes xmlns:a="http://schemas.openxmlformats.org/drawingml/2006/main" xmlns:r="http://schemas.openxmlformats.org/officeDocument/2006/relationships" xmlns:p="http://schemas.openxmlformats.org/presentationml/2006/main">
   <p:cSld>
     <p:spTree>
       <p:nvGrpSpPr>
@@ -555,43 +349,43 @@
         <p:nvSpPr>
           <p:cNvPr id="2" name="Slide Image Placeholder 1"/>
           <p:cNvSpPr>
+            <a:spLocks noGrp="1" noRot="1" noChangeAspect="1"/>
+          </p:cNvSpPr>
+          <p:nvPr>
+            <p:ph type="sldImg" idx="2"/>
+          </p:nvPr>
+        </p:nvSpPr>
+        <p:spPr/>
+      </p:sp>
+      <p:sp>
+        <p:nvSpPr>
+          <p:cNvPr id="3" name="Notes Placeholder 2"/>
+          <p:cNvSpPr>
             <a:spLocks noGrp="1"/>
           </p:cNvSpPr>
           <p:nvPr>
-            <p:ph type="sldImg" idx="2"/>
+            <p:ph type="body" sz="quarter" idx="3"/>
           </p:nvPr>
         </p:nvSpPr>
         <p:spPr/>
-      </p:sp>
-      <p:sp>
-        <p:nvSpPr>
-          <p:cNvPr id="3" name="Notes Placeholder 2"/>
+        <p:txBody>
+          <a:bodyPr/>
+          <a:lstStyle/>
+          <a:p>
+            <a:r>
+              <a:t>If you saw our flyers around campus, you might have tackled the ciphers. Both the hexadecimal sequence and the ROT-13 text translated to 'BaySec is here.' Today, we’re officially here. Our goal is simple: take the concepts you study in class and apply them directly to live defense, penetration testing, and security tooling.</a:t>
+            </a:r>
+          </a:p>
+        </p:txBody>
+      </p:sp>
+      <p:sp>
+        <p:nvSpPr>
+          <p:cNvPr id="4" name="Slide Number Placeholder 3"/>
           <p:cNvSpPr>
             <a:spLocks noGrp="1"/>
           </p:cNvSpPr>
           <p:nvPr>
-            <p:ph type="body" idx="3" sz="quarter"/>
-          </p:nvPr>
-        </p:nvSpPr>
-        <p:spPr/>
-        <p:txBody>
-          <a:bodyPr/>
-          <a:lstStyle/>
-          <a:p>
-            <a:r>
-              <a:t>If you saw our flyers around campus, you might have tackled the ciphers. Both the hexadecimal sequence and the ROT-13 text translated to 'BaySec is here.' Today, we’re officially here. Our goal is simple: take the concepts you study in class and apply them directly to live defense, penetration testing, and security tooling.</a:t>
-            </a:r>
-          </a:p>
-        </p:txBody>
-      </p:sp>
-      <p:sp>
-        <p:nvSpPr>
-          <p:cNvPr id="4" name="Slide Number Placeholder 3"/>
-          <p:cNvSpPr>
-            <a:spLocks noGrp="1"/>
-          </p:cNvSpPr>
-          <p:nvPr>
-            <p:ph type="sldNum" idx="5" sz="quarter"/>
+            <p:ph type="sldNum" sz="quarter" idx="5"/>
           </p:nvPr>
         </p:nvSpPr>
         <p:spPr/>
@@ -605,7 +399,7 @@
 </file>
 
 <file path=ppt/notesSlides/notesSlide3.xml><?xml version="1.0" encoding="utf-8"?>
-<p:notes xmlns:a="http://schemas.openxmlformats.org/drawingml/2006/main" xmlns:p="http://schemas.openxmlformats.org/presentationml/2006/main" xmlns:r="http://schemas.openxmlformats.org/officeDocument/2006/relationships">
+<p:notes xmlns:a="http://schemas.openxmlformats.org/drawingml/2006/main" xmlns:r="http://schemas.openxmlformats.org/officeDocument/2006/relationships" xmlns:p="http://schemas.openxmlformats.org/presentationml/2006/main">
   <p:cSld>
     <p:spTree>
       <p:nvGrpSpPr>
@@ -625,43 +419,43 @@
         <p:nvSpPr>
           <p:cNvPr id="2" name="Slide Image Placeholder 1"/>
           <p:cNvSpPr>
+            <a:spLocks noGrp="1" noRot="1" noChangeAspect="1"/>
+          </p:cNvSpPr>
+          <p:nvPr>
+            <p:ph type="sldImg" idx="2"/>
+          </p:nvPr>
+        </p:nvSpPr>
+        <p:spPr/>
+      </p:sp>
+      <p:sp>
+        <p:nvSpPr>
+          <p:cNvPr id="3" name="Notes Placeholder 2"/>
+          <p:cNvSpPr>
             <a:spLocks noGrp="1"/>
           </p:cNvSpPr>
           <p:nvPr>
-            <p:ph type="sldImg" idx="2"/>
+            <p:ph type="body" sz="quarter" idx="3"/>
           </p:nvPr>
         </p:nvSpPr>
         <p:spPr/>
-      </p:sp>
-      <p:sp>
-        <p:nvSpPr>
-          <p:cNvPr id="3" name="Notes Placeholder 2"/>
+        <p:txBody>
+          <a:bodyPr/>
+          <a:lstStyle/>
+          <a:p>
+            <a:r>
+              <a:t>You don’t have to pick just one discipline. Whether you want to learn how attackers break into web apps, how SOC analysts hunt threats in network logs, or how prompt injection cracks AI systems, you can move between tracks based on what excites you.</a:t>
+            </a:r>
+          </a:p>
+        </p:txBody>
+      </p:sp>
+      <p:sp>
+        <p:nvSpPr>
+          <p:cNvPr id="4" name="Slide Number Placeholder 3"/>
           <p:cNvSpPr>
             <a:spLocks noGrp="1"/>
           </p:cNvSpPr>
           <p:nvPr>
-            <p:ph type="body" idx="3" sz="quarter"/>
-          </p:nvPr>
-        </p:nvSpPr>
-        <p:spPr/>
-        <p:txBody>
-          <a:bodyPr/>
-          <a:lstStyle/>
-          <a:p>
-            <a:r>
-              <a:t>You don’t have to pick just one discipline. Whether you want to learn how attackers break into web apps, how SOC analysts hunt threats in network logs, or how prompt injection cracks AI systems, you can move between tracks based on what excites you.</a:t>
-            </a:r>
-          </a:p>
-        </p:txBody>
-      </p:sp>
-      <p:sp>
-        <p:nvSpPr>
-          <p:cNvPr id="4" name="Slide Number Placeholder 3"/>
-          <p:cNvSpPr>
-            <a:spLocks noGrp="1"/>
-          </p:cNvSpPr>
-          <p:nvPr>
-            <p:ph type="sldNum" idx="5" sz="quarter"/>
+            <p:ph type="sldNum" sz="quarter" idx="5"/>
           </p:nvPr>
         </p:nvSpPr>
         <p:spPr/>
@@ -675,7 +469,7 @@
 </file>
 
 <file path=ppt/notesSlides/notesSlide4.xml><?xml version="1.0" encoding="utf-8"?>
-<p:notes xmlns:a="http://schemas.openxmlformats.org/drawingml/2006/main" xmlns:p="http://schemas.openxmlformats.org/presentationml/2006/main" xmlns:r="http://schemas.openxmlformats.org/officeDocument/2006/relationships">
+<p:notes xmlns:a="http://schemas.openxmlformats.org/drawingml/2006/main" xmlns:r="http://schemas.openxmlformats.org/officeDocument/2006/relationships" xmlns:p="http://schemas.openxmlformats.org/presentationml/2006/main">
   <p:cSld>
     <p:spTree>
       <p:nvGrpSpPr>
@@ -695,43 +489,43 @@
         <p:nvSpPr>
           <p:cNvPr id="2" name="Slide Image Placeholder 1"/>
           <p:cNvSpPr>
+            <a:spLocks noGrp="1" noRot="1" noChangeAspect="1"/>
+          </p:cNvSpPr>
+          <p:nvPr>
+            <p:ph type="sldImg" idx="2"/>
+          </p:nvPr>
+        </p:nvSpPr>
+        <p:spPr/>
+      </p:sp>
+      <p:sp>
+        <p:nvSpPr>
+          <p:cNvPr id="3" name="Notes Placeholder 2"/>
+          <p:cNvSpPr>
             <a:spLocks noGrp="1"/>
           </p:cNvSpPr>
           <p:nvPr>
-            <p:ph type="sldImg" idx="2"/>
+            <p:ph type="body" sz="quarter" idx="3"/>
           </p:nvPr>
         </p:nvSpPr>
         <p:spPr/>
-      </p:sp>
-      <p:sp>
-        <p:nvSpPr>
-          <p:cNvPr id="3" name="Notes Placeholder 2"/>
+        <p:txBody>
+          <a:bodyPr/>
+          <a:lstStyle/>
+          <a:p>
+            <a:r>
+              <a:t>Every session we host is designed to be hands-on. Instead of dry lectures, we run live walkthroughs, simulate defenses, and build practical skills. Later this term, we’ll host a campus-wide Security Open House and cap it off with our own BaySec CTF.</a:t>
+            </a:r>
+          </a:p>
+        </p:txBody>
+      </p:sp>
+      <p:sp>
+        <p:nvSpPr>
+          <p:cNvPr id="4" name="Slide Number Placeholder 3"/>
           <p:cNvSpPr>
             <a:spLocks noGrp="1"/>
           </p:cNvSpPr>
           <p:nvPr>
-            <p:ph type="body" idx="3" sz="quarter"/>
-          </p:nvPr>
-        </p:nvSpPr>
-        <p:spPr/>
-        <p:txBody>
-          <a:bodyPr/>
-          <a:lstStyle/>
-          <a:p>
-            <a:r>
-              <a:t>Every session we host is designed to be hands-on. Instead of dry lectures, we run live walkthroughs, simulate defenses, and build practical skills. Later this term, we’ll host a campus-wide Security Open House and cap it off with our own BaySec CTF.</a:t>
-            </a:r>
-          </a:p>
-        </p:txBody>
-      </p:sp>
-      <p:sp>
-        <p:nvSpPr>
-          <p:cNvPr id="4" name="Slide Number Placeholder 3"/>
-          <p:cNvSpPr>
-            <a:spLocks noGrp="1"/>
-          </p:cNvSpPr>
-          <p:nvPr>
-            <p:ph type="sldNum" idx="5" sz="quarter"/>
+            <p:ph type="sldNum" sz="quarter" idx="5"/>
           </p:nvPr>
         </p:nvSpPr>
         <p:spPr/>
@@ -745,7 +539,7 @@
 </file>
 
 <file path=ppt/notesSlides/notesSlide5.xml><?xml version="1.0" encoding="utf-8"?>
-<p:notes xmlns:a="http://schemas.openxmlformats.org/drawingml/2006/main" xmlns:p="http://schemas.openxmlformats.org/presentationml/2006/main" xmlns:r="http://schemas.openxmlformats.org/officeDocument/2006/relationships">
+<p:notes xmlns:a="http://schemas.openxmlformats.org/drawingml/2006/main" xmlns:r="http://schemas.openxmlformats.org/officeDocument/2006/relationships" xmlns:p="http://schemas.openxmlformats.org/presentationml/2006/main">
   <p:cSld>
     <p:spTree>
       <p:nvGrpSpPr>
@@ -765,43 +559,43 @@
         <p:nvSpPr>
           <p:cNvPr id="2" name="Slide Image Placeholder 1"/>
           <p:cNvSpPr>
+            <a:spLocks noGrp="1" noRot="1" noChangeAspect="1"/>
+          </p:cNvSpPr>
+          <p:nvPr>
+            <p:ph type="sldImg" idx="2"/>
+          </p:nvPr>
+        </p:nvSpPr>
+        <p:spPr/>
+      </p:sp>
+      <p:sp>
+        <p:nvSpPr>
+          <p:cNvPr id="3" name="Notes Placeholder 2"/>
+          <p:cNvSpPr>
             <a:spLocks noGrp="1"/>
           </p:cNvSpPr>
           <p:nvPr>
-            <p:ph type="sldImg" idx="2"/>
+            <p:ph type="body" sz="quarter" idx="3"/>
           </p:nvPr>
         </p:nvSpPr>
         <p:spPr/>
-      </p:sp>
-      <p:sp>
-        <p:nvSpPr>
-          <p:cNvPr id="3" name="Notes Placeholder 2"/>
+        <p:txBody>
+          <a:bodyPr/>
+          <a:lstStyle/>
+          <a:p>
+            <a:r>
+              <a:t>Security is a rep-based craft. You don’t need expensive certifications or paid subscriptions to start. TryHackMe's free tier, OverTheWire Bandit, and CyberChef are all you need to build muscle memory right now.</a:t>
+            </a:r>
+          </a:p>
+        </p:txBody>
+      </p:sp>
+      <p:sp>
+        <p:nvSpPr>
+          <p:cNvPr id="4" name="Slide Number Placeholder 3"/>
           <p:cNvSpPr>
             <a:spLocks noGrp="1"/>
           </p:cNvSpPr>
           <p:nvPr>
-            <p:ph type="body" idx="3" sz="quarter"/>
-          </p:nvPr>
-        </p:nvSpPr>
-        <p:spPr/>
-        <p:txBody>
-          <a:bodyPr/>
-          <a:lstStyle/>
-          <a:p>
-            <a:r>
-              <a:t>Security is a rep-based craft. You don’t need expensive certifications or paid subscriptions to start. TryHackMe's free tier, OverTheWire Bandit, and CyberChef are all you need to build muscle memory right now.</a:t>
-            </a:r>
-          </a:p>
-        </p:txBody>
-      </p:sp>
-      <p:sp>
-        <p:nvSpPr>
-          <p:cNvPr id="4" name="Slide Number Placeholder 3"/>
-          <p:cNvSpPr>
-            <a:spLocks noGrp="1"/>
-          </p:cNvSpPr>
-          <p:nvPr>
-            <p:ph type="sldNum" idx="5" sz="quarter"/>
+            <p:ph type="sldNum" sz="quarter" idx="5"/>
           </p:nvPr>
         </p:nvSpPr>
         <p:spPr/>
@@ -815,7 +609,7 @@
 </file>
 
 <file path=ppt/notesSlides/notesSlide6.xml><?xml version="1.0" encoding="utf-8"?>
-<p:notes xmlns:a="http://schemas.openxmlformats.org/drawingml/2006/main" xmlns:p="http://schemas.openxmlformats.org/presentationml/2006/main" xmlns:r="http://schemas.openxmlformats.org/officeDocument/2006/relationships">
+<p:notes xmlns:a="http://schemas.openxmlformats.org/drawingml/2006/main" xmlns:r="http://schemas.openxmlformats.org/officeDocument/2006/relationships" xmlns:p="http://schemas.openxmlformats.org/presentationml/2006/main">
   <p:cSld>
     <p:spTree>
       <p:nvGrpSpPr>
@@ -835,43 +629,43 @@
         <p:nvSpPr>
           <p:cNvPr id="2" name="Slide Image Placeholder 1"/>
           <p:cNvSpPr>
+            <a:spLocks noGrp="1" noRot="1" noChangeAspect="1"/>
+          </p:cNvSpPr>
+          <p:nvPr>
+            <p:ph type="sldImg" idx="2"/>
+          </p:nvPr>
+        </p:nvSpPr>
+        <p:spPr/>
+      </p:sp>
+      <p:sp>
+        <p:nvSpPr>
+          <p:cNvPr id="3" name="Notes Placeholder 2"/>
+          <p:cNvSpPr>
             <a:spLocks noGrp="1"/>
           </p:cNvSpPr>
           <p:nvPr>
-            <p:ph type="sldImg" idx="2"/>
+            <p:ph type="body" sz="quarter" idx="3"/>
           </p:nvPr>
         </p:nvSpPr>
         <p:spPr/>
-      </p:sp>
-      <p:sp>
-        <p:nvSpPr>
-          <p:cNvPr id="3" name="Notes Placeholder 2"/>
+        <p:txBody>
+          <a:bodyPr/>
+          <a:lstStyle/>
+          <a:p>
+            <a:r>
+              <a:t>Let's put this into practice immediately. Pull out your laptop or phone and go to the URL on screen. An operator left an authorization token lingering inside this page. Your mission is to find it and extract the flag. You have 5 minutes—go!</a:t>
+            </a:r>
+          </a:p>
+        </p:txBody>
+      </p:sp>
+      <p:sp>
+        <p:nvSpPr>
+          <p:cNvPr id="4" name="Slide Number Placeholder 3"/>
           <p:cNvSpPr>
             <a:spLocks noGrp="1"/>
           </p:cNvSpPr>
           <p:nvPr>
-            <p:ph type="body" idx="3" sz="quarter"/>
-          </p:nvPr>
-        </p:nvSpPr>
-        <p:spPr/>
-        <p:txBody>
-          <a:bodyPr/>
-          <a:lstStyle/>
-          <a:p>
-            <a:r>
-              <a:t>Let's put this into practice immediately. Pull out your laptop or phone and go to the URL on screen. An operator left an authorization token lingering inside this page. Your mission is to find it and extract the flag. You have 5 minutes—go!</a:t>
-            </a:r>
-          </a:p>
-        </p:txBody>
-      </p:sp>
-      <p:sp>
-        <p:nvSpPr>
-          <p:cNvPr id="4" name="Slide Number Placeholder 3"/>
-          <p:cNvSpPr>
-            <a:spLocks noGrp="1"/>
-          </p:cNvSpPr>
-          <p:nvPr>
-            <p:ph type="sldNum" idx="5" sz="quarter"/>
+            <p:ph type="sldNum" sz="quarter" idx="5"/>
           </p:nvPr>
         </p:nvSpPr>
         <p:spPr/>
@@ -885,7 +679,7 @@
 </file>
 
 <file path=ppt/notesSlides/notesSlide7.xml><?xml version="1.0" encoding="utf-8"?>
-<p:notes xmlns:a="http://schemas.openxmlformats.org/drawingml/2006/main" xmlns:p="http://schemas.openxmlformats.org/presentationml/2006/main" xmlns:r="http://schemas.openxmlformats.org/officeDocument/2006/relationships">
+<p:notes xmlns:a="http://schemas.openxmlformats.org/drawingml/2006/main" xmlns:r="http://schemas.openxmlformats.org/officeDocument/2006/relationships" xmlns:p="http://schemas.openxmlformats.org/presentationml/2006/main">
   <p:cSld>
     <p:spTree>
       <p:nvGrpSpPr>
@@ -905,43 +699,43 @@
         <p:nvSpPr>
           <p:cNvPr id="2" name="Slide Image Placeholder 1"/>
           <p:cNvSpPr>
+            <a:spLocks noGrp="1" noRot="1" noChangeAspect="1"/>
+          </p:cNvSpPr>
+          <p:nvPr>
+            <p:ph type="sldImg" idx="2"/>
+          </p:nvPr>
+        </p:nvSpPr>
+        <p:spPr/>
+      </p:sp>
+      <p:sp>
+        <p:nvSpPr>
+          <p:cNvPr id="3" name="Notes Placeholder 2"/>
+          <p:cNvSpPr>
             <a:spLocks noGrp="1"/>
           </p:cNvSpPr>
           <p:nvPr>
-            <p:ph type="sldImg" idx="2"/>
+            <p:ph type="body" sz="quarter" idx="3"/>
           </p:nvPr>
         </p:nvSpPr>
         <p:spPr/>
-      </p:sp>
-      <p:sp>
-        <p:nvSpPr>
-          <p:cNvPr id="3" name="Notes Placeholder 2"/>
+        <p:txBody>
+          <a:bodyPr/>
+          <a:lstStyle/>
+          <a:p>
+            <a:r>
+              <a:t>Great job to everyone who caught that! The core flaw here is trusting the client side. If it ships to the user's browser—even inside an HTML comment—it’s public knowledge. Base64 is encoding, not encryption.</a:t>
+            </a:r>
+          </a:p>
+        </p:txBody>
+      </p:sp>
+      <p:sp>
+        <p:nvSpPr>
+          <p:cNvPr id="4" name="Slide Number Placeholder 3"/>
           <p:cNvSpPr>
             <a:spLocks noGrp="1"/>
           </p:cNvSpPr>
           <p:nvPr>
-            <p:ph type="body" idx="3" sz="quarter"/>
-          </p:nvPr>
-        </p:nvSpPr>
-        <p:spPr/>
-        <p:txBody>
-          <a:bodyPr/>
-          <a:lstStyle/>
-          <a:p>
-            <a:r>
-              <a:t>Great job to everyone who caught that! The core flaw here is trusting the client side. If it ships to the user's browser—even inside an HTML comment—it’s public knowledge. Base64 is encoding, not encryption.</a:t>
-            </a:r>
-          </a:p>
-        </p:txBody>
-      </p:sp>
-      <p:sp>
-        <p:nvSpPr>
-          <p:cNvPr id="4" name="Slide Number Placeholder 3"/>
-          <p:cNvSpPr>
-            <a:spLocks noGrp="1"/>
-          </p:cNvSpPr>
-          <p:nvPr>
-            <p:ph type="sldNum" idx="5" sz="quarter"/>
+            <p:ph type="sldNum" sz="quarter" idx="5"/>
           </p:nvPr>
         </p:nvSpPr>
         <p:spPr/>
@@ -955,7 +749,7 @@
 </file>
 
 <file path=ppt/notesSlides/notesSlide8.xml><?xml version="1.0" encoding="utf-8"?>
-<p:notes xmlns:a="http://schemas.openxmlformats.org/drawingml/2006/main" xmlns:p="http://schemas.openxmlformats.org/presentationml/2006/main" xmlns:r="http://schemas.openxmlformats.org/officeDocument/2006/relationships">
+<p:notes xmlns:a="http://schemas.openxmlformats.org/drawingml/2006/main" xmlns:r="http://schemas.openxmlformats.org/officeDocument/2006/relationships" xmlns:p="http://schemas.openxmlformats.org/presentationml/2006/main">
   <p:cSld>
     <p:spTree>
       <p:nvGrpSpPr>
@@ -975,43 +769,43 @@
         <p:nvSpPr>
           <p:cNvPr id="2" name="Slide Image Placeholder 1"/>
           <p:cNvSpPr>
+            <a:spLocks noGrp="1" noRot="1" noChangeAspect="1"/>
+          </p:cNvSpPr>
+          <p:nvPr>
+            <p:ph type="sldImg" idx="2"/>
+          </p:nvPr>
+        </p:nvSpPr>
+        <p:spPr/>
+      </p:sp>
+      <p:sp>
+        <p:nvSpPr>
+          <p:cNvPr id="3" name="Notes Placeholder 2"/>
+          <p:cNvSpPr>
             <a:spLocks noGrp="1"/>
           </p:cNvSpPr>
           <p:nvPr>
-            <p:ph type="sldImg" idx="2"/>
+            <p:ph type="body" sz="quarter" idx="3"/>
           </p:nvPr>
         </p:nvSpPr>
         <p:spPr/>
-      </p:sp>
-      <p:sp>
-        <p:nvSpPr>
-          <p:cNvPr id="3" name="Notes Placeholder 2"/>
+        <p:txBody>
+          <a:bodyPr/>
+          <a:lstStyle/>
+          <a:p>
+            <a:r>
+              <a:t>Next week, we kick off Lab 01 with Linux CLI survival skills and packet sniffing in Wireshark. Watch WhatsApp for the locked-in room and time slot. Thank you for coming out, and let’s open up the floor for any questions!</a:t>
+            </a:r>
+          </a:p>
+        </p:txBody>
+      </p:sp>
+      <p:sp>
+        <p:nvSpPr>
+          <p:cNvPr id="4" name="Slide Number Placeholder 3"/>
           <p:cNvSpPr>
             <a:spLocks noGrp="1"/>
           </p:cNvSpPr>
           <p:nvPr>
-            <p:ph type="body" idx="3" sz="quarter"/>
-          </p:nvPr>
-        </p:nvSpPr>
-        <p:spPr/>
-        <p:txBody>
-          <a:bodyPr/>
-          <a:lstStyle/>
-          <a:p>
-            <a:r>
-              <a:t>Next week, we kick off Lab 01 with Linux CLI survival skills and packet sniffing in Wireshark. Watch WhatsApp for the locked-in room and time slot. Thank you for coming out, and let’s open up the floor for any questions!</a:t>
-            </a:r>
-          </a:p>
-        </p:txBody>
-      </p:sp>
-      <p:sp>
-        <p:nvSpPr>
-          <p:cNvPr id="4" name="Slide Number Placeholder 3"/>
-          <p:cNvSpPr>
-            <a:spLocks noGrp="1"/>
-          </p:cNvSpPr>
-          <p:nvPr>
-            <p:ph type="sldNum" idx="5" sz="quarter"/>
+            <p:ph type="sldNum" sz="quarter" idx="5"/>
           </p:nvPr>
         </p:nvSpPr>
         <p:spPr/>
@@ -1062,10 +856,9 @@
           <a:lstStyle/>
           <a:p>
             <a:r>
-              <a:rPr lang="en-US" smtClean="0"/>
+              <a:rPr lang="en-US"/>
               <a:t>Click to edit Master title style</a:t>
             </a:r>
-            <a:endParaRPr lang="en-US"/>
           </a:p>
         </p:txBody>
       </p:sp>
@@ -1181,10 +974,9 @@
           </a:lstStyle>
           <a:p>
             <a:r>
-              <a:rPr lang="en-US" smtClean="0"/>
+              <a:rPr lang="en-US"/>
               <a:t>Click to edit Master subtitle style</a:t>
             </a:r>
-            <a:endParaRPr lang="en-US"/>
           </a:p>
         </p:txBody>
       </p:sp>
@@ -1205,7 +997,7 @@
           <a:p>
             <a:fld id="{5BCAD085-E8A6-8845-BD4E-CB4CCA059FC4}" type="datetimeFigureOut">
               <a:rPr lang="en-US" smtClean="0"/>
-              <a:t>1/27/13</a:t>
+              <a:t>9/9/2026</a:t>
             </a:fld>
             <a:endParaRPr lang="en-US"/>
           </a:p>
@@ -1299,10 +1091,9 @@
           <a:lstStyle/>
           <a:p>
             <a:r>
-              <a:rPr lang="en-US" smtClean="0"/>
+              <a:rPr lang="en-US"/>
               <a:t>Click to edit Master title style</a:t>
             </a:r>
-            <a:endParaRPr lang="en-US"/>
           </a:p>
         </p:txBody>
       </p:sp>
@@ -1323,38 +1114,37 @@
           <a:p>
             <a:pPr lvl="0"/>
             <a:r>
-              <a:rPr lang="en-US" smtClean="0"/>
+              <a:rPr lang="en-US"/>
               <a:t>Click to edit Master text styles</a:t>
             </a:r>
           </a:p>
           <a:p>
             <a:pPr lvl="1"/>
             <a:r>
-              <a:rPr lang="en-US" smtClean="0"/>
+              <a:rPr lang="en-US"/>
               <a:t>Second level</a:t>
             </a:r>
           </a:p>
           <a:p>
             <a:pPr lvl="2"/>
             <a:r>
-              <a:rPr lang="en-US" smtClean="0"/>
+              <a:rPr lang="en-US"/>
               <a:t>Third level</a:t>
             </a:r>
           </a:p>
           <a:p>
             <a:pPr lvl="3"/>
             <a:r>
-              <a:rPr lang="en-US" smtClean="0"/>
+              <a:rPr lang="en-US"/>
               <a:t>Fourth level</a:t>
             </a:r>
           </a:p>
           <a:p>
             <a:pPr lvl="4"/>
             <a:r>
-              <a:rPr lang="en-US" smtClean="0"/>
+              <a:rPr lang="en-US"/>
               <a:t>Fifth level</a:t>
             </a:r>
-            <a:endParaRPr lang="en-US"/>
           </a:p>
         </p:txBody>
       </p:sp>
@@ -1375,7 +1165,7 @@
           <a:p>
             <a:fld id="{5BCAD085-E8A6-8845-BD4E-CB4CCA059FC4}" type="datetimeFigureOut">
               <a:rPr lang="en-US" smtClean="0"/>
-              <a:t>1/27/13</a:t>
+              <a:t>9/9/2026</a:t>
             </a:fld>
             <a:endParaRPr lang="en-US"/>
           </a:p>
@@ -1474,10 +1264,9 @@
           <a:lstStyle/>
           <a:p>
             <a:r>
-              <a:rPr lang="en-US" smtClean="0"/>
+              <a:rPr lang="en-US"/>
               <a:t>Click to edit Master title style</a:t>
             </a:r>
-            <a:endParaRPr lang="en-US"/>
           </a:p>
         </p:txBody>
       </p:sp>
@@ -1503,38 +1292,37 @@
           <a:p>
             <a:pPr lvl="0"/>
             <a:r>
-              <a:rPr lang="en-US" smtClean="0"/>
+              <a:rPr lang="en-US"/>
               <a:t>Click to edit Master text styles</a:t>
             </a:r>
           </a:p>
           <a:p>
             <a:pPr lvl="1"/>
             <a:r>
-              <a:rPr lang="en-US" smtClean="0"/>
+              <a:rPr lang="en-US"/>
               <a:t>Second level</a:t>
             </a:r>
           </a:p>
           <a:p>
             <a:pPr lvl="2"/>
             <a:r>
-              <a:rPr lang="en-US" smtClean="0"/>
+              <a:rPr lang="en-US"/>
               <a:t>Third level</a:t>
             </a:r>
           </a:p>
           <a:p>
             <a:pPr lvl="3"/>
             <a:r>
-              <a:rPr lang="en-US" smtClean="0"/>
+              <a:rPr lang="en-US"/>
               <a:t>Fourth level</a:t>
             </a:r>
           </a:p>
           <a:p>
             <a:pPr lvl="4"/>
             <a:r>
-              <a:rPr lang="en-US" smtClean="0"/>
+              <a:rPr lang="en-US"/>
               <a:t>Fifth level</a:t>
             </a:r>
-            <a:endParaRPr lang="en-US"/>
           </a:p>
         </p:txBody>
       </p:sp>
@@ -1555,7 +1343,7 @@
           <a:p>
             <a:fld id="{5BCAD085-E8A6-8845-BD4E-CB4CCA059FC4}" type="datetimeFigureOut">
               <a:rPr lang="en-US" smtClean="0"/>
-              <a:t>1/27/13</a:t>
+              <a:t>9/9/2026</a:t>
             </a:fld>
             <a:endParaRPr lang="en-US"/>
           </a:p>
@@ -1649,10 +1437,9 @@
           <a:lstStyle/>
           <a:p>
             <a:r>
-              <a:rPr lang="en-US" smtClean="0"/>
+              <a:rPr lang="en-US"/>
               <a:t>Click to edit Master title style</a:t>
             </a:r>
-            <a:endParaRPr lang="en-US"/>
           </a:p>
         </p:txBody>
       </p:sp>
@@ -1673,38 +1460,37 @@
           <a:p>
             <a:pPr lvl="0"/>
             <a:r>
-              <a:rPr lang="en-US" smtClean="0"/>
+              <a:rPr lang="en-US"/>
               <a:t>Click to edit Master text styles</a:t>
             </a:r>
           </a:p>
           <a:p>
             <a:pPr lvl="1"/>
             <a:r>
-              <a:rPr lang="en-US" smtClean="0"/>
+              <a:rPr lang="en-US"/>
               <a:t>Second level</a:t>
             </a:r>
           </a:p>
           <a:p>
             <a:pPr lvl="2"/>
             <a:r>
-              <a:rPr lang="en-US" smtClean="0"/>
+              <a:rPr lang="en-US"/>
               <a:t>Third level</a:t>
             </a:r>
           </a:p>
           <a:p>
             <a:pPr lvl="3"/>
             <a:r>
-              <a:rPr lang="en-US" smtClean="0"/>
+              <a:rPr lang="en-US"/>
               <a:t>Fourth level</a:t>
             </a:r>
           </a:p>
           <a:p>
             <a:pPr lvl="4"/>
             <a:r>
-              <a:rPr lang="en-US" smtClean="0"/>
+              <a:rPr lang="en-US"/>
               <a:t>Fifth level</a:t>
             </a:r>
-            <a:endParaRPr lang="en-US"/>
           </a:p>
         </p:txBody>
       </p:sp>
@@ -1725,7 +1511,7 @@
           <a:p>
             <a:fld id="{5BCAD085-E8A6-8845-BD4E-CB4CCA059FC4}" type="datetimeFigureOut">
               <a:rPr lang="en-US" smtClean="0"/>
-              <a:t>1/27/13</a:t>
+              <a:t>9/9/2026</a:t>
             </a:fld>
             <a:endParaRPr lang="en-US"/>
           </a:p>
@@ -1828,10 +1614,9 @@
           </a:lstStyle>
           <a:p>
             <a:r>
-              <a:rPr lang="en-US" smtClean="0"/>
+              <a:rPr lang="en-US"/>
               <a:t>Click to edit Master title style</a:t>
             </a:r>
-            <a:endParaRPr lang="en-US"/>
           </a:p>
         </p:txBody>
       </p:sp>
@@ -1948,7 +1733,7 @@
           <a:p>
             <a:pPr lvl="0"/>
             <a:r>
-              <a:rPr lang="en-US" smtClean="0"/>
+              <a:rPr lang="en-US"/>
               <a:t>Click to edit Master text styles</a:t>
             </a:r>
           </a:p>
@@ -1971,7 +1756,7 @@
           <a:p>
             <a:fld id="{5BCAD085-E8A6-8845-BD4E-CB4CCA059FC4}" type="datetimeFigureOut">
               <a:rPr lang="en-US" smtClean="0"/>
-              <a:t>1/27/13</a:t>
+              <a:t>9/9/2026</a:t>
             </a:fld>
             <a:endParaRPr lang="en-US"/>
           </a:p>
@@ -2065,10 +1850,9 @@
           <a:lstStyle/>
           <a:p>
             <a:r>
-              <a:rPr lang="en-US" smtClean="0"/>
+              <a:rPr lang="en-US"/>
               <a:t>Click to edit Master title style</a:t>
             </a:r>
-            <a:endParaRPr lang="en-US"/>
           </a:p>
         </p:txBody>
       </p:sp>
@@ -2122,38 +1906,37 @@
           <a:p>
             <a:pPr lvl="0"/>
             <a:r>
-              <a:rPr lang="en-US" smtClean="0"/>
+              <a:rPr lang="en-US"/>
               <a:t>Click to edit Master text styles</a:t>
             </a:r>
           </a:p>
           <a:p>
             <a:pPr lvl="1"/>
             <a:r>
-              <a:rPr lang="en-US" smtClean="0"/>
+              <a:rPr lang="en-US"/>
               <a:t>Second level</a:t>
             </a:r>
           </a:p>
           <a:p>
             <a:pPr lvl="2"/>
             <a:r>
-              <a:rPr lang="en-US" smtClean="0"/>
+              <a:rPr lang="en-US"/>
               <a:t>Third level</a:t>
             </a:r>
           </a:p>
           <a:p>
             <a:pPr lvl="3"/>
             <a:r>
-              <a:rPr lang="en-US" smtClean="0"/>
+              <a:rPr lang="en-US"/>
               <a:t>Fourth level</a:t>
             </a:r>
           </a:p>
           <a:p>
             <a:pPr lvl="4"/>
             <a:r>
-              <a:rPr lang="en-US" smtClean="0"/>
+              <a:rPr lang="en-US"/>
               <a:t>Fifth level</a:t>
             </a:r>
-            <a:endParaRPr lang="en-US"/>
           </a:p>
         </p:txBody>
       </p:sp>
@@ -2207,38 +1990,37 @@
           <a:p>
             <a:pPr lvl="0"/>
             <a:r>
-              <a:rPr lang="en-US" smtClean="0"/>
+              <a:rPr lang="en-US"/>
               <a:t>Click to edit Master text styles</a:t>
             </a:r>
           </a:p>
           <a:p>
             <a:pPr lvl="1"/>
             <a:r>
-              <a:rPr lang="en-US" smtClean="0"/>
+              <a:rPr lang="en-US"/>
               <a:t>Second level</a:t>
             </a:r>
           </a:p>
           <a:p>
             <a:pPr lvl="2"/>
             <a:r>
-              <a:rPr lang="en-US" smtClean="0"/>
+              <a:rPr lang="en-US"/>
               <a:t>Third level</a:t>
             </a:r>
           </a:p>
           <a:p>
             <a:pPr lvl="3"/>
             <a:r>
-              <a:rPr lang="en-US" smtClean="0"/>
+              <a:rPr lang="en-US"/>
               <a:t>Fourth level</a:t>
             </a:r>
           </a:p>
           <a:p>
             <a:pPr lvl="4"/>
             <a:r>
-              <a:rPr lang="en-US" smtClean="0"/>
+              <a:rPr lang="en-US"/>
               <a:t>Fifth level</a:t>
             </a:r>
-            <a:endParaRPr lang="en-US"/>
           </a:p>
         </p:txBody>
       </p:sp>
@@ -2259,7 +2041,7 @@
           <a:p>
             <a:fld id="{5BCAD085-E8A6-8845-BD4E-CB4CCA059FC4}" type="datetimeFigureOut">
               <a:rPr lang="en-US" smtClean="0"/>
-              <a:t>1/27/13</a:t>
+              <a:t>9/9/2026</a:t>
             </a:fld>
             <a:endParaRPr lang="en-US"/>
           </a:p>
@@ -2357,10 +2139,9 @@
           </a:lstStyle>
           <a:p>
             <a:r>
-              <a:rPr lang="en-US" smtClean="0"/>
+              <a:rPr lang="en-US"/>
               <a:t>Click to edit Master title style</a:t>
             </a:r>
-            <a:endParaRPr lang="en-US"/>
           </a:p>
         </p:txBody>
       </p:sp>
@@ -2423,7 +2204,7 @@
           <a:p>
             <a:pPr lvl="0"/>
             <a:r>
-              <a:rPr lang="en-US" smtClean="0"/>
+              <a:rPr lang="en-US"/>
               <a:t>Click to edit Master text styles</a:t>
             </a:r>
           </a:p>
@@ -2479,38 +2260,37 @@
           <a:p>
             <a:pPr lvl="0"/>
             <a:r>
-              <a:rPr lang="en-US" smtClean="0"/>
+              <a:rPr lang="en-US"/>
               <a:t>Click to edit Master text styles</a:t>
             </a:r>
           </a:p>
           <a:p>
             <a:pPr lvl="1"/>
             <a:r>
-              <a:rPr lang="en-US" smtClean="0"/>
+              <a:rPr lang="en-US"/>
               <a:t>Second level</a:t>
             </a:r>
           </a:p>
           <a:p>
             <a:pPr lvl="2"/>
             <a:r>
-              <a:rPr lang="en-US" smtClean="0"/>
+              <a:rPr lang="en-US"/>
               <a:t>Third level</a:t>
             </a:r>
           </a:p>
           <a:p>
             <a:pPr lvl="3"/>
             <a:r>
-              <a:rPr lang="en-US" smtClean="0"/>
+              <a:rPr lang="en-US"/>
               <a:t>Fourth level</a:t>
             </a:r>
           </a:p>
           <a:p>
             <a:pPr lvl="4"/>
             <a:r>
-              <a:rPr lang="en-US" smtClean="0"/>
+              <a:rPr lang="en-US"/>
               <a:t>Fifth level</a:t>
             </a:r>
-            <a:endParaRPr lang="en-US"/>
           </a:p>
         </p:txBody>
       </p:sp>
@@ -2573,7 +2353,7 @@
           <a:p>
             <a:pPr lvl="0"/>
             <a:r>
-              <a:rPr lang="en-US" smtClean="0"/>
+              <a:rPr lang="en-US"/>
               <a:t>Click to edit Master text styles</a:t>
             </a:r>
           </a:p>
@@ -2629,38 +2409,37 @@
           <a:p>
             <a:pPr lvl="0"/>
             <a:r>
-              <a:rPr lang="en-US" smtClean="0"/>
+              <a:rPr lang="en-US"/>
               <a:t>Click to edit Master text styles</a:t>
             </a:r>
           </a:p>
           <a:p>
             <a:pPr lvl="1"/>
             <a:r>
-              <a:rPr lang="en-US" smtClean="0"/>
+              <a:rPr lang="en-US"/>
               <a:t>Second level</a:t>
             </a:r>
           </a:p>
           <a:p>
             <a:pPr lvl="2"/>
             <a:r>
-              <a:rPr lang="en-US" smtClean="0"/>
+              <a:rPr lang="en-US"/>
               <a:t>Third level</a:t>
             </a:r>
           </a:p>
           <a:p>
             <a:pPr lvl="3"/>
             <a:r>
-              <a:rPr lang="en-US" smtClean="0"/>
+              <a:rPr lang="en-US"/>
               <a:t>Fourth level</a:t>
             </a:r>
           </a:p>
           <a:p>
             <a:pPr lvl="4"/>
             <a:r>
-              <a:rPr lang="en-US" smtClean="0"/>
+              <a:rPr lang="en-US"/>
               <a:t>Fifth level</a:t>
             </a:r>
-            <a:endParaRPr lang="en-US"/>
           </a:p>
         </p:txBody>
       </p:sp>
@@ -2681,7 +2460,7 @@
           <a:p>
             <a:fld id="{5BCAD085-E8A6-8845-BD4E-CB4CCA059FC4}" type="datetimeFigureOut">
               <a:rPr lang="en-US" smtClean="0"/>
-              <a:t>1/27/13</a:t>
+              <a:t>9/9/2026</a:t>
             </a:fld>
             <a:endParaRPr lang="en-US"/>
           </a:p>
@@ -2775,10 +2554,9 @@
           <a:lstStyle/>
           <a:p>
             <a:r>
-              <a:rPr lang="en-US" smtClean="0"/>
+              <a:rPr lang="en-US"/>
               <a:t>Click to edit Master title style</a:t>
             </a:r>
-            <a:endParaRPr lang="en-US"/>
           </a:p>
         </p:txBody>
       </p:sp>
@@ -2799,7 +2577,7 @@
           <a:p>
             <a:fld id="{5BCAD085-E8A6-8845-BD4E-CB4CCA059FC4}" type="datetimeFigureOut">
               <a:rPr lang="en-US" smtClean="0"/>
-              <a:t>1/27/13</a:t>
+              <a:t>9/9/2026</a:t>
             </a:fld>
             <a:endParaRPr lang="en-US"/>
           </a:p>
@@ -2894,7 +2672,7 @@
           <a:p>
             <a:fld id="{5BCAD085-E8A6-8845-BD4E-CB4CCA059FC4}" type="datetimeFigureOut">
               <a:rPr lang="en-US" smtClean="0"/>
-              <a:t>1/27/13</a:t>
+              <a:t>9/9/2026</a:t>
             </a:fld>
             <a:endParaRPr lang="en-US"/>
           </a:p>
@@ -2997,10 +2775,9 @@
           </a:lstStyle>
           <a:p>
             <a:r>
-              <a:rPr lang="en-US" smtClean="0"/>
+              <a:rPr lang="en-US"/>
               <a:t>Click to edit Master title style</a:t>
             </a:r>
-            <a:endParaRPr lang="en-US"/>
           </a:p>
         </p:txBody>
       </p:sp>
@@ -3054,38 +2831,37 @@
           <a:p>
             <a:pPr lvl="0"/>
             <a:r>
-              <a:rPr lang="en-US" smtClean="0"/>
+              <a:rPr lang="en-US"/>
               <a:t>Click to edit Master text styles</a:t>
             </a:r>
           </a:p>
           <a:p>
             <a:pPr lvl="1"/>
             <a:r>
-              <a:rPr lang="en-US" smtClean="0"/>
+              <a:rPr lang="en-US"/>
               <a:t>Second level</a:t>
             </a:r>
           </a:p>
           <a:p>
             <a:pPr lvl="2"/>
             <a:r>
-              <a:rPr lang="en-US" smtClean="0"/>
+              <a:rPr lang="en-US"/>
               <a:t>Third level</a:t>
             </a:r>
           </a:p>
           <a:p>
             <a:pPr lvl="3"/>
             <a:r>
-              <a:rPr lang="en-US" smtClean="0"/>
+              <a:rPr lang="en-US"/>
               <a:t>Fourth level</a:t>
             </a:r>
           </a:p>
           <a:p>
             <a:pPr lvl="4"/>
             <a:r>
-              <a:rPr lang="en-US" smtClean="0"/>
+              <a:rPr lang="en-US"/>
               <a:t>Fifth level</a:t>
             </a:r>
-            <a:endParaRPr lang="en-US"/>
           </a:p>
         </p:txBody>
       </p:sp>
@@ -3148,7 +2924,7 @@
           <a:p>
             <a:pPr lvl="0"/>
             <a:r>
-              <a:rPr lang="en-US" smtClean="0"/>
+              <a:rPr lang="en-US"/>
               <a:t>Click to edit Master text styles</a:t>
             </a:r>
           </a:p>
@@ -3171,7 +2947,7 @@
           <a:p>
             <a:fld id="{5BCAD085-E8A6-8845-BD4E-CB4CCA059FC4}" type="datetimeFigureOut">
               <a:rPr lang="en-US" smtClean="0"/>
-              <a:t>1/27/13</a:t>
+              <a:t>9/9/2026</a:t>
             </a:fld>
             <a:endParaRPr lang="en-US"/>
           </a:p>
@@ -3274,10 +3050,9 @@
           </a:lstStyle>
           <a:p>
             <a:r>
-              <a:rPr lang="en-US" smtClean="0"/>
+              <a:rPr lang="en-US"/>
               <a:t>Click to edit Master title style</a:t>
             </a:r>
-            <a:endParaRPr lang="en-US"/>
           </a:p>
         </p:txBody>
       </p:sp>
@@ -3401,7 +3176,7 @@
           <a:p>
             <a:pPr lvl="0"/>
             <a:r>
-              <a:rPr lang="en-US" smtClean="0"/>
+              <a:rPr lang="en-US"/>
               <a:t>Click to edit Master text styles</a:t>
             </a:r>
           </a:p>
@@ -3424,7 +3199,7 @@
           <a:p>
             <a:fld id="{5BCAD085-E8A6-8845-BD4E-CB4CCA059FC4}" type="datetimeFigureOut">
               <a:rPr lang="en-US" smtClean="0"/>
-              <a:t>1/27/13</a:t>
+              <a:t>9/9/2026</a:t>
             </a:fld>
             <a:endParaRPr lang="en-US"/>
           </a:p>
@@ -3533,10 +3308,9 @@
           <a:lstStyle/>
           <a:p>
             <a:r>
-              <a:rPr lang="en-US" smtClean="0"/>
+              <a:rPr lang="en-US"/>
               <a:t>Click to edit Master title style</a:t>
             </a:r>
-            <a:endParaRPr lang="en-US"/>
           </a:p>
         </p:txBody>
       </p:sp>
@@ -3567,38 +3341,37 @@
           <a:p>
             <a:pPr lvl="0"/>
             <a:r>
-              <a:rPr lang="en-US" smtClean="0"/>
+              <a:rPr lang="en-US"/>
               <a:t>Click to edit Master text styles</a:t>
             </a:r>
           </a:p>
           <a:p>
             <a:pPr lvl="1"/>
             <a:r>
-              <a:rPr lang="en-US" smtClean="0"/>
+              <a:rPr lang="en-US"/>
               <a:t>Second level</a:t>
             </a:r>
           </a:p>
           <a:p>
             <a:pPr lvl="2"/>
             <a:r>
-              <a:rPr lang="en-US" smtClean="0"/>
+              <a:rPr lang="en-US"/>
               <a:t>Third level</a:t>
             </a:r>
           </a:p>
           <a:p>
             <a:pPr lvl="3"/>
             <a:r>
-              <a:rPr lang="en-US" smtClean="0"/>
+              <a:rPr lang="en-US"/>
               <a:t>Fourth level</a:t>
             </a:r>
           </a:p>
           <a:p>
             <a:pPr lvl="4"/>
             <a:r>
-              <a:rPr lang="en-US" smtClean="0"/>
+              <a:rPr lang="en-US"/>
               <a:t>Fifth level</a:t>
             </a:r>
-            <a:endParaRPr lang="en-US"/>
           </a:p>
         </p:txBody>
       </p:sp>
@@ -3637,7 +3410,7 @@
           <a:p>
             <a:fld id="{5BCAD085-E8A6-8845-BD4E-CB4CCA059FC4}" type="datetimeFigureOut">
               <a:rPr lang="en-US" smtClean="0"/>
-              <a:t>1/27/13</a:t>
+              <a:t>9/9/2026</a:t>
             </a:fld>
             <a:endParaRPr lang="en-US"/>
           </a:p>
@@ -3996,7 +3769,7 @@
 </file>
 
 <file path=ppt/slides/slide1.xml><?xml version="1.0" encoding="utf-8"?>
-<p:sld xmlns:a="http://schemas.openxmlformats.org/drawingml/2006/main" xmlns:p="http://schemas.openxmlformats.org/presentationml/2006/main" xmlns:r="http://schemas.openxmlformats.org/officeDocument/2006/relationships">
+<p:sld xmlns:a="http://schemas.openxmlformats.org/drawingml/2006/main" xmlns:r="http://schemas.openxmlformats.org/officeDocument/2006/relationships" xmlns:p="http://schemas.openxmlformats.org/presentationml/2006/main">
   <p:cSld>
     <p:spTree>
       <p:nvGrpSpPr>
@@ -4004,7 +3777,14 @@
         <p:cNvGrpSpPr/>
         <p:nvPr/>
       </p:nvGrpSpPr>
-      <p:grpSpPr/>
+      <p:grpSpPr>
+        <a:xfrm>
+          <a:off x="0" y="0"/>
+          <a:ext cx="0" cy="0"/>
+          <a:chOff x="0" y="0"/>
+          <a:chExt cx="0" cy="0"/>
+        </a:xfrm>
+      </p:grpSpPr>
       <p:sp>
         <p:nvSpPr>
           <p:cNvPr id="2" name="Rectangle 1"/>
@@ -4045,6 +3825,7 @@
           <a:lstStyle/>
           <a:p>
             <a:pPr algn="ctr"/>
+            <a:endParaRPr/>
           </a:p>
         </p:txBody>
       </p:sp>
@@ -4184,7 +3965,7 @@
           <p:nvPr/>
         </p:nvPicPr>
         <p:blipFill>
-          <a:blip r:embed="rId2"/>
+          <a:blip r:embed="rId3"/>
           <a:stretch>
             <a:fillRect/>
           </a:stretch>
@@ -4208,7 +3989,7 @@
           <p:nvPr/>
         </p:nvPicPr>
         <p:blipFill>
-          <a:blip r:embed="rId3"/>
+          <a:blip r:embed="rId4"/>
           <a:stretch>
             <a:fillRect/>
           </a:stretch>
@@ -4231,8 +4012,8 @@
         </p:nvSpPr>
         <p:spPr>
           <a:xfrm>
-            <a:off x="2286000" y="4892040"/>
-            <a:ext cx="7619695" cy="731520"/>
+            <a:off x="3333174" y="4846320"/>
+            <a:ext cx="5799666" cy="523220"/>
           </a:xfrm>
           <a:prstGeom prst="rect">
             <a:avLst/>
@@ -4254,6 +4035,7 @@
               </a:defRPr>
             </a:pPr>
             <a:r>
+              <a:rPr dirty="0"/>
               <a:t>Welcome! Please scan the QR codes to check in and join our active channels while we set up.</a:t>
             </a:r>
           </a:p>
@@ -4301,6 +4083,7 @@
           <a:lstStyle/>
           <a:p>
             <a:pPr algn="ctr"/>
+            <a:endParaRPr/>
           </a:p>
         </p:txBody>
       </p:sp>
@@ -4313,7 +4096,7 @@
           <p:nvPr/>
         </p:nvPicPr>
         <p:blipFill>
-          <a:blip r:embed="rId4"/>
+          <a:blip r:embed="rId5"/>
           <a:stretch>
             <a:fillRect/>
           </a:stretch>
@@ -4406,6 +4189,7 @@
           <a:lstStyle/>
           <a:p>
             <a:pPr algn="ctr"/>
+            <a:endParaRPr/>
           </a:p>
         </p:txBody>
       </p:sp>
@@ -4418,7 +4202,7 @@
           <p:nvPr/>
         </p:nvPicPr>
         <p:blipFill>
-          <a:blip r:embed="rId5"/>
+          <a:blip r:embed="rId6"/>
           <a:stretch>
             <a:fillRect/>
           </a:stretch>
@@ -4478,7 +4262,7 @@
 </file>
 
 <file path=ppt/slides/slide2.xml><?xml version="1.0" encoding="utf-8"?>
-<p:sld xmlns:a="http://schemas.openxmlformats.org/drawingml/2006/main" xmlns:p="http://schemas.openxmlformats.org/presentationml/2006/main" xmlns:r="http://schemas.openxmlformats.org/officeDocument/2006/relationships">
+<p:sld xmlns:a="http://schemas.openxmlformats.org/drawingml/2006/main" xmlns:r="http://schemas.openxmlformats.org/officeDocument/2006/relationships" xmlns:p="http://schemas.openxmlformats.org/presentationml/2006/main">
   <p:cSld>
     <p:spTree>
       <p:nvGrpSpPr>
@@ -4486,7 +4270,14 @@
         <p:cNvGrpSpPr/>
         <p:nvPr/>
       </p:nvGrpSpPr>
-      <p:grpSpPr/>
+      <p:grpSpPr>
+        <a:xfrm>
+          <a:off x="0" y="0"/>
+          <a:ext cx="0" cy="0"/>
+          <a:chOff x="0" y="0"/>
+          <a:chExt cx="0" cy="0"/>
+        </a:xfrm>
+      </p:grpSpPr>
       <p:sp>
         <p:nvSpPr>
           <p:cNvPr id="2" name="Rectangle 1"/>
@@ -4527,6 +4318,7 @@
           <a:lstStyle/>
           <a:p>
             <a:pPr algn="ctr"/>
+            <a:endParaRPr/>
           </a:p>
         </p:txBody>
       </p:sp>
@@ -4659,7 +4451,7 @@
           </a:fontRef>
         </p:style>
         <p:txBody>
-          <a:bodyPr rtlCol="0" anchor="ctr" wrap="square" lIns="365760" rIns="365760" tIns="365760"/>
+          <a:bodyPr wrap="square" lIns="365760" tIns="365760" rIns="365760" rtlCol="0" anchor="ctr"/>
           <a:lstStyle/>
           <a:p>
             <a:pPr algn="ctr">
@@ -4804,7 +4596,7 @@
           </a:fontRef>
         </p:style>
         <p:txBody>
-          <a:bodyPr rtlCol="0" anchor="ctr" wrap="square" lIns="365760" rIns="365760" tIns="365760"/>
+          <a:bodyPr wrap="square" lIns="365760" tIns="365760" rIns="365760" rtlCol="0" anchor="ctr"/>
           <a:lstStyle/>
           <a:p>
             <a:pPr algn="ctr">
@@ -4946,7 +4738,7 @@
 </file>
 
 <file path=ppt/slides/slide3.xml><?xml version="1.0" encoding="utf-8"?>
-<p:sld xmlns:a="http://schemas.openxmlformats.org/drawingml/2006/main" xmlns:p="http://schemas.openxmlformats.org/presentationml/2006/main" xmlns:r="http://schemas.openxmlformats.org/officeDocument/2006/relationships">
+<p:sld xmlns:a="http://schemas.openxmlformats.org/drawingml/2006/main" xmlns:r="http://schemas.openxmlformats.org/officeDocument/2006/relationships" xmlns:p="http://schemas.openxmlformats.org/presentationml/2006/main">
   <p:cSld>
     <p:spTree>
       <p:nvGrpSpPr>
@@ -4954,7 +4746,14 @@
         <p:cNvGrpSpPr/>
         <p:nvPr/>
       </p:nvGrpSpPr>
-      <p:grpSpPr/>
+      <p:grpSpPr>
+        <a:xfrm>
+          <a:off x="0" y="0"/>
+          <a:ext cx="0" cy="0"/>
+          <a:chOff x="0" y="0"/>
+          <a:chExt cx="0" cy="0"/>
+        </a:xfrm>
+      </p:grpSpPr>
       <p:sp>
         <p:nvSpPr>
           <p:cNvPr id="2" name="Rectangle 1"/>
@@ -4995,6 +4794,7 @@
           <a:lstStyle/>
           <a:p>
             <a:pPr algn="ctr"/>
+            <a:endParaRPr/>
           </a:p>
         </p:txBody>
       </p:sp>
@@ -5127,7 +4927,7 @@
           </a:fontRef>
         </p:style>
         <p:txBody>
-          <a:bodyPr rtlCol="0" anchor="ctr" wrap="square" lIns="274320" rIns="274320" tIns="320040"/>
+          <a:bodyPr wrap="square" lIns="274320" tIns="320040" rIns="274320" rtlCol="0" anchor="ctr"/>
           <a:lstStyle/>
           <a:p>
             <a:pPr algn="ctr">
@@ -5262,7 +5062,7 @@
           </a:fontRef>
         </p:style>
         <p:txBody>
-          <a:bodyPr rtlCol="0" anchor="ctr" wrap="square" lIns="274320" rIns="274320" tIns="320040"/>
+          <a:bodyPr wrap="square" lIns="274320" tIns="320040" rIns="274320" rtlCol="0" anchor="ctr"/>
           <a:lstStyle/>
           <a:p>
             <a:pPr algn="ctr">
@@ -5397,7 +5197,7 @@
           </a:fontRef>
         </p:style>
         <p:txBody>
-          <a:bodyPr rtlCol="0" anchor="ctr" wrap="square" lIns="274320" rIns="274320" tIns="320040"/>
+          <a:bodyPr wrap="square" lIns="274320" tIns="320040" rIns="274320" rtlCol="0" anchor="ctr"/>
           <a:lstStyle/>
           <a:p>
             <a:pPr algn="ctr">
@@ -5558,7 +5358,7 @@
 </file>
 
 <file path=ppt/slides/slide4.xml><?xml version="1.0" encoding="utf-8"?>
-<p:sld xmlns:a="http://schemas.openxmlformats.org/drawingml/2006/main" xmlns:p="http://schemas.openxmlformats.org/presentationml/2006/main" xmlns:r="http://schemas.openxmlformats.org/officeDocument/2006/relationships">
+<p:sld xmlns:a="http://schemas.openxmlformats.org/drawingml/2006/main" xmlns:r="http://schemas.openxmlformats.org/officeDocument/2006/relationships" xmlns:p="http://schemas.openxmlformats.org/presentationml/2006/main">
   <p:cSld>
     <p:spTree>
       <p:nvGrpSpPr>
@@ -5566,7 +5366,14 @@
         <p:cNvGrpSpPr/>
         <p:nvPr/>
       </p:nvGrpSpPr>
-      <p:grpSpPr/>
+      <p:grpSpPr>
+        <a:xfrm>
+          <a:off x="0" y="0"/>
+          <a:ext cx="0" cy="0"/>
+          <a:chOff x="0" y="0"/>
+          <a:chExt cx="0" cy="0"/>
+        </a:xfrm>
+      </p:grpSpPr>
       <p:sp>
         <p:nvSpPr>
           <p:cNvPr id="2" name="Rectangle 1"/>
@@ -5607,6 +5414,7 @@
           <a:lstStyle/>
           <a:p>
             <a:pPr algn="ctr"/>
+            <a:endParaRPr/>
           </a:p>
         </p:txBody>
       </p:sp>
@@ -5739,7 +5547,7 @@
           </a:fontRef>
         </p:style>
         <p:txBody>
-          <a:bodyPr rtlCol="0" anchor="ctr" wrap="square" lIns="320040" rIns="320040" tIns="365760"/>
+          <a:bodyPr wrap="square" lIns="320040" tIns="365760" rIns="320040" rtlCol="0" anchor="ctr"/>
           <a:lstStyle/>
           <a:p>
             <a:pPr algn="ctr">
@@ -5829,7 +5637,7 @@
           </a:fontRef>
         </p:style>
         <p:txBody>
-          <a:bodyPr rtlCol="0" anchor="ctr" wrap="square" lIns="320040" rIns="320040" tIns="365760"/>
+          <a:bodyPr wrap="square" lIns="320040" tIns="365760" rIns="320040" rtlCol="0" anchor="ctr"/>
           <a:lstStyle/>
           <a:p>
             <a:pPr algn="ctr">
@@ -5919,7 +5727,7 @@
           </a:fontRef>
         </p:style>
         <p:txBody>
-          <a:bodyPr rtlCol="0" anchor="ctr" wrap="square" lIns="320040" rIns="320040" tIns="365760"/>
+          <a:bodyPr wrap="square" lIns="320040" tIns="365760" rIns="320040" rtlCol="0" anchor="ctr"/>
           <a:lstStyle/>
           <a:p>
             <a:pPr algn="ctr">
@@ -5980,7 +5788,7 @@
 </file>
 
 <file path=ppt/slides/slide5.xml><?xml version="1.0" encoding="utf-8"?>
-<p:sld xmlns:a="http://schemas.openxmlformats.org/drawingml/2006/main" xmlns:p="http://schemas.openxmlformats.org/presentationml/2006/main" xmlns:r="http://schemas.openxmlformats.org/officeDocument/2006/relationships">
+<p:sld xmlns:a="http://schemas.openxmlformats.org/drawingml/2006/main" xmlns:r="http://schemas.openxmlformats.org/officeDocument/2006/relationships" xmlns:p="http://schemas.openxmlformats.org/presentationml/2006/main">
   <p:cSld>
     <p:spTree>
       <p:nvGrpSpPr>
@@ -5988,7 +5796,14 @@
         <p:cNvGrpSpPr/>
         <p:nvPr/>
       </p:nvGrpSpPr>
-      <p:grpSpPr/>
+      <p:grpSpPr>
+        <a:xfrm>
+          <a:off x="0" y="0"/>
+          <a:ext cx="0" cy="0"/>
+          <a:chOff x="0" y="0"/>
+          <a:chExt cx="0" cy="0"/>
+        </a:xfrm>
+      </p:grpSpPr>
       <p:sp>
         <p:nvSpPr>
           <p:cNvPr id="2" name="Rectangle 1"/>
@@ -6029,6 +5844,7 @@
           <a:lstStyle/>
           <a:p>
             <a:pPr algn="ctr"/>
+            <a:endParaRPr/>
           </a:p>
         </p:txBody>
       </p:sp>
@@ -6197,7 +6013,7 @@
           </a:fontRef>
         </p:style>
         <p:txBody>
-          <a:bodyPr rtlCol="0" anchor="ctr" wrap="square" lIns="274320" rIns="274320" tIns="320040"/>
+          <a:bodyPr wrap="square" lIns="274320" tIns="320040" rIns="274320" rtlCol="0" anchor="ctr"/>
           <a:lstStyle/>
           <a:p>
             <a:pPr algn="ctr">
@@ -6284,7 +6100,7 @@
           </a:fontRef>
         </p:style>
         <p:txBody>
-          <a:bodyPr rtlCol="0" anchor="ctr" wrap="square" lIns="274320" rIns="274320" tIns="320040"/>
+          <a:bodyPr wrap="square" lIns="274320" tIns="320040" rIns="274320" rtlCol="0" anchor="ctr"/>
           <a:lstStyle/>
           <a:p>
             <a:pPr algn="ctr">
@@ -6371,7 +6187,7 @@
           </a:fontRef>
         </p:style>
         <p:txBody>
-          <a:bodyPr rtlCol="0" anchor="ctr" wrap="square" lIns="274320" rIns="274320" tIns="320040"/>
+          <a:bodyPr wrap="square" lIns="274320" tIns="320040" rIns="274320" rtlCol="0" anchor="ctr"/>
           <a:lstStyle/>
           <a:p>
             <a:pPr algn="ctr">
@@ -6484,7 +6300,7 @@
 </file>
 
 <file path=ppt/slides/slide6.xml><?xml version="1.0" encoding="utf-8"?>
-<p:sld xmlns:a="http://schemas.openxmlformats.org/drawingml/2006/main" xmlns:p="http://schemas.openxmlformats.org/presentationml/2006/main" xmlns:r="http://schemas.openxmlformats.org/officeDocument/2006/relationships">
+<p:sld xmlns:a="http://schemas.openxmlformats.org/drawingml/2006/main" xmlns:r="http://schemas.openxmlformats.org/officeDocument/2006/relationships" xmlns:p="http://schemas.openxmlformats.org/presentationml/2006/main">
   <p:cSld>
     <p:spTree>
       <p:nvGrpSpPr>
@@ -6492,7 +6308,14 @@
         <p:cNvGrpSpPr/>
         <p:nvPr/>
       </p:nvGrpSpPr>
-      <p:grpSpPr/>
+      <p:grpSpPr>
+        <a:xfrm>
+          <a:off x="0" y="0"/>
+          <a:ext cx="0" cy="0"/>
+          <a:chOff x="0" y="0"/>
+          <a:chExt cx="0" cy="0"/>
+        </a:xfrm>
+      </p:grpSpPr>
       <p:sp>
         <p:nvSpPr>
           <p:cNvPr id="2" name="Rectangle 1"/>
@@ -6533,6 +6356,7 @@
           <a:lstStyle/>
           <a:p>
             <a:pPr algn="ctr"/>
+            <a:endParaRPr/>
           </a:p>
         </p:txBody>
       </p:sp>
@@ -6665,7 +6489,7 @@
           </a:fontRef>
         </p:style>
         <p:txBody>
-          <a:bodyPr rtlCol="0" anchor="ctr" wrap="square" lIns="411480" rIns="411480" tIns="320040"/>
+          <a:bodyPr wrap="square" lIns="411480" tIns="320040" rIns="411480" rtlCol="0" anchor="ctr"/>
           <a:lstStyle/>
           <a:p>
             <a:pPr algn="ctr">
@@ -6820,6 +6644,7 @@
           <a:lstStyle/>
           <a:p>
             <a:pPr algn="ctr"/>
+            <a:endParaRPr/>
           </a:p>
         </p:txBody>
       </p:sp>
@@ -6900,7 +6725,7 @@
           <p:nvPr/>
         </p:nvPicPr>
         <p:blipFill>
-          <a:blip r:embed="rId2"/>
+          <a:blip r:embed="rId3"/>
           <a:stretch>
             <a:fillRect/>
           </a:stretch>
@@ -6973,7 +6798,7 @@
 </file>
 
 <file path=ppt/slides/slide7.xml><?xml version="1.0" encoding="utf-8"?>
-<p:sld xmlns:a="http://schemas.openxmlformats.org/drawingml/2006/main" xmlns:p="http://schemas.openxmlformats.org/presentationml/2006/main" xmlns:r="http://schemas.openxmlformats.org/officeDocument/2006/relationships">
+<p:sld xmlns:a="http://schemas.openxmlformats.org/drawingml/2006/main" xmlns:r="http://schemas.openxmlformats.org/officeDocument/2006/relationships" xmlns:p="http://schemas.openxmlformats.org/presentationml/2006/main">
   <p:cSld>
     <p:spTree>
       <p:nvGrpSpPr>
@@ -6981,7 +6806,14 @@
         <p:cNvGrpSpPr/>
         <p:nvPr/>
       </p:nvGrpSpPr>
-      <p:grpSpPr/>
+      <p:grpSpPr>
+        <a:xfrm>
+          <a:off x="0" y="0"/>
+          <a:ext cx="0" cy="0"/>
+          <a:chOff x="0" y="0"/>
+          <a:chExt cx="0" cy="0"/>
+        </a:xfrm>
+      </p:grpSpPr>
       <p:sp>
         <p:nvSpPr>
           <p:cNvPr id="2" name="Rectangle 1"/>
@@ -7022,6 +6854,7 @@
           <a:lstStyle/>
           <a:p>
             <a:pPr algn="ctr"/>
+            <a:endParaRPr/>
           </a:p>
         </p:txBody>
       </p:sp>
@@ -7154,7 +6987,7 @@
           </a:fontRef>
         </p:style>
         <p:txBody>
-          <a:bodyPr rtlCol="0" anchor="ctr" wrap="square" lIns="365760" rIns="365760" tIns="320040"/>
+          <a:bodyPr wrap="square" lIns="365760" tIns="320040" rIns="365760" rtlCol="0" anchor="ctr"/>
           <a:lstStyle/>
           <a:p>
             <a:pPr algn="ctr">
@@ -7277,7 +7110,7 @@
           </a:fontRef>
         </p:style>
         <p:txBody>
-          <a:bodyPr rtlCol="0" anchor="ctr" wrap="square" lIns="365760" rIns="365760" tIns="320040"/>
+          <a:bodyPr wrap="square" lIns="365760" tIns="320040" rIns="365760" rtlCol="0" anchor="ctr"/>
           <a:lstStyle/>
           <a:p>
             <a:pPr algn="ctr">
@@ -7445,7 +7278,7 @@
 </file>
 
 <file path=ppt/slides/slide8.xml><?xml version="1.0" encoding="utf-8"?>
-<p:sld xmlns:a="http://schemas.openxmlformats.org/drawingml/2006/main" xmlns:p="http://schemas.openxmlformats.org/presentationml/2006/main" xmlns:r="http://schemas.openxmlformats.org/officeDocument/2006/relationships">
+<p:sld xmlns:a="http://schemas.openxmlformats.org/drawingml/2006/main" xmlns:r="http://schemas.openxmlformats.org/officeDocument/2006/relationships" xmlns:p="http://schemas.openxmlformats.org/presentationml/2006/main">
   <p:cSld>
     <p:spTree>
       <p:nvGrpSpPr>
@@ -7453,7 +7286,14 @@
         <p:cNvGrpSpPr/>
         <p:nvPr/>
       </p:nvGrpSpPr>
-      <p:grpSpPr/>
+      <p:grpSpPr>
+        <a:xfrm>
+          <a:off x="0" y="0"/>
+          <a:ext cx="0" cy="0"/>
+          <a:chOff x="0" y="0"/>
+          <a:chExt cx="0" cy="0"/>
+        </a:xfrm>
+      </p:grpSpPr>
       <p:sp>
         <p:nvSpPr>
           <p:cNvPr id="2" name="Rectangle 1"/>
@@ -7494,6 +7334,7 @@
           <a:lstStyle/>
           <a:p>
             <a:pPr algn="ctr"/>
+            <a:endParaRPr/>
           </a:p>
         </p:txBody>
       </p:sp>
@@ -7626,7 +7467,7 @@
           </a:fontRef>
         </p:style>
         <p:txBody>
-          <a:bodyPr rtlCol="0" anchor="ctr" wrap="square" lIns="365760" rIns="365760" tIns="320040"/>
+          <a:bodyPr wrap="square" lIns="365760" tIns="320040" rIns="365760" rtlCol="0" anchor="ctr"/>
           <a:lstStyle/>
           <a:p>
             <a:pPr algn="ctr">
@@ -7797,7 +7638,7 @@
           </a:fontRef>
         </p:style>
         <p:txBody>
-          <a:bodyPr rtlCol="0" anchor="ctr" wrap="square" tIns="320040"/>
+          <a:bodyPr wrap="square" tIns="320040" rtlCol="0" anchor="ctr"/>
           <a:lstStyle/>
           <a:p>
             <a:pPr algn="ctr">
@@ -7823,7 +7664,7 @@
           <p:nvPr/>
         </p:nvPicPr>
         <p:blipFill>
-          <a:blip r:embed="rId2"/>
+          <a:blip r:embed="rId3"/>
           <a:stretch>
             <a:fillRect/>
           </a:stretch>
@@ -8226,44 +8067,44 @@
         <a:sysClr val="window" lastClr="FFFFFF"/>
       </a:lt1>
       <a:dk2>
-        <a:srgbClr val="1F497D"/>
+        <a:srgbClr val="0E2841"/>
       </a:dk2>
       <a:lt2>
-        <a:srgbClr val="EEECE1"/>
+        <a:srgbClr val="E8E8E8"/>
       </a:lt2>
       <a:accent1>
-        <a:srgbClr val="4F81BD"/>
+        <a:srgbClr val="156082"/>
       </a:accent1>
       <a:accent2>
-        <a:srgbClr val="C0504D"/>
+        <a:srgbClr val="E97132"/>
       </a:accent2>
       <a:accent3>
-        <a:srgbClr val="9BBB59"/>
+        <a:srgbClr val="196B24"/>
       </a:accent3>
       <a:accent4>
-        <a:srgbClr val="8064A2"/>
+        <a:srgbClr val="0F9ED5"/>
       </a:accent4>
       <a:accent5>
-        <a:srgbClr val="4BACC6"/>
+        <a:srgbClr val="A02B93"/>
       </a:accent5>
       <a:accent6>
-        <a:srgbClr val="F79646"/>
+        <a:srgbClr val="4EA72E"/>
       </a:accent6>
       <a:hlink>
-        <a:srgbClr val="0000FF"/>
+        <a:srgbClr val="467886"/>
       </a:hlink>
       <a:folHlink>
-        <a:srgbClr val="800080"/>
+        <a:srgbClr val="96607D"/>
       </a:folHlink>
     </a:clrScheme>
     <a:fontScheme name="Office">
       <a:majorFont>
-        <a:latin typeface="Calibri"/>
+        <a:latin typeface="Aptos Display" panose="02110004020202020204"/>
         <a:ea typeface=""/>
         <a:cs typeface=""/>
-        <a:font script="Jpan" typeface="ＭＳ Ｐゴシック"/>
+        <a:font script="Jpan" typeface="游ゴシック Light"/>
         <a:font script="Hang" typeface="맑은 고딕"/>
-        <a:font script="Hans" typeface="宋体"/>
+        <a:font script="Hans" typeface="等线 Light"/>
         <a:font script="Hant" typeface="新細明體"/>
         <a:font script="Arab" typeface="Times New Roman"/>
         <a:font script="Hebr" typeface="Times New Roman"/>
@@ -8291,14 +8132,31 @@
         <a:font script="Viet" typeface="Times New Roman"/>
         <a:font script="Uigh" typeface="Microsoft Uighur"/>
         <a:font script="Geor" typeface="Sylfaen"/>
+        <a:font script="Armn" typeface="Arial"/>
+        <a:font script="Bugi" typeface="Leelawadee UI"/>
+        <a:font script="Bopo" typeface="Microsoft JhengHei"/>
+        <a:font script="Java" typeface="Javanese Text"/>
+        <a:font script="Lisu" typeface="Segoe UI"/>
+        <a:font script="Mymr" typeface="Myanmar Text"/>
+        <a:font script="Nkoo" typeface="Ebrima"/>
+        <a:font script="Olck" typeface="Nirmala UI"/>
+        <a:font script="Osma" typeface="Ebrima"/>
+        <a:font script="Phag" typeface="Phagspa"/>
+        <a:font script="Syrn" typeface="Estrangelo Edessa"/>
+        <a:font script="Syrj" typeface="Estrangelo Edessa"/>
+        <a:font script="Syre" typeface="Estrangelo Edessa"/>
+        <a:font script="Sora" typeface="Nirmala UI"/>
+        <a:font script="Tale" typeface="Microsoft Tai Le"/>
+        <a:font script="Talu" typeface="Microsoft New Tai Lue"/>
+        <a:font script="Tfng" typeface="Ebrima"/>
       </a:majorFont>
       <a:minorFont>
-        <a:latin typeface="Calibri"/>
+        <a:latin typeface="Aptos" panose="02110004020202020204"/>
         <a:ea typeface=""/>
         <a:cs typeface=""/>
-        <a:font script="Jpan" typeface="ＭＳ Ｐゴシック"/>
+        <a:font script="Jpan" typeface="游ゴシック"/>
         <a:font script="Hang" typeface="맑은 고딕"/>
-        <a:font script="Hans" typeface="宋体"/>
+        <a:font script="Hans" typeface="等线"/>
         <a:font script="Hant" typeface="新細明體"/>
         <a:font script="Arab" typeface="Arial"/>
         <a:font script="Hebr" typeface="Arial"/>
@@ -8326,6 +8184,23 @@
         <a:font script="Viet" typeface="Arial"/>
         <a:font script="Uigh" typeface="Microsoft Uighur"/>
         <a:font script="Geor" typeface="Sylfaen"/>
+        <a:font script="Armn" typeface="Arial"/>
+        <a:font script="Bugi" typeface="Leelawadee UI"/>
+        <a:font script="Bopo" typeface="Microsoft JhengHei"/>
+        <a:font script="Java" typeface="Javanese Text"/>
+        <a:font script="Lisu" typeface="Segoe UI"/>
+        <a:font script="Mymr" typeface="Myanmar Text"/>
+        <a:font script="Nkoo" typeface="Ebrima"/>
+        <a:font script="Olck" typeface="Nirmala UI"/>
+        <a:font script="Osma" typeface="Ebrima"/>
+        <a:font script="Phag" typeface="Phagspa"/>
+        <a:font script="Syrn" typeface="Estrangelo Edessa"/>
+        <a:font script="Syrj" typeface="Estrangelo Edessa"/>
+        <a:font script="Syre" typeface="Estrangelo Edessa"/>
+        <a:font script="Sora" typeface="Nirmala UI"/>
+        <a:font script="Tale" typeface="Microsoft Tai Le"/>
+        <a:font script="Talu" typeface="Microsoft New Tai Lue"/>
+        <a:font script="Tfng" typeface="Ebrima"/>
       </a:minorFont>
     </a:fontScheme>
     <a:fmtScheme name="Office">
@@ -8337,180 +8212,136 @@
           <a:gsLst>
             <a:gs pos="0">
               <a:schemeClr val="phClr">
-                <a:tint val="50000"/>
-                <a:satMod val="300000"/>
+                <a:lumMod val="110000"/>
+                <a:satMod val="105000"/>
+                <a:tint val="67000"/>
               </a:schemeClr>
             </a:gs>
-            <a:gs pos="35000">
+            <a:gs pos="50000">
               <a:schemeClr val="phClr">
-                <a:tint val="37000"/>
-                <a:satMod val="300000"/>
+                <a:lumMod val="105000"/>
+                <a:satMod val="103000"/>
+                <a:tint val="73000"/>
               </a:schemeClr>
             </a:gs>
             <a:gs pos="100000">
               <a:schemeClr val="phClr">
-                <a:tint val="15000"/>
-                <a:satMod val="350000"/>
+                <a:lumMod val="105000"/>
+                <a:satMod val="109000"/>
+                <a:tint val="81000"/>
               </a:schemeClr>
             </a:gs>
           </a:gsLst>
-          <a:lin ang="16200000" scaled="1"/>
+          <a:lin ang="5400000" scaled="0"/>
         </a:gradFill>
         <a:gradFill rotWithShape="1">
           <a:gsLst>
             <a:gs pos="0">
               <a:schemeClr val="phClr">
-                <a:tint val="100000"/>
+                <a:satMod val="103000"/>
+                <a:lumMod val="102000"/>
+                <a:tint val="94000"/>
+              </a:schemeClr>
+            </a:gs>
+            <a:gs pos="50000">
+              <a:schemeClr val="phClr">
+                <a:satMod val="110000"/>
+                <a:lumMod val="100000"/>
                 <a:shade val="100000"/>
-                <a:satMod val="130000"/>
               </a:schemeClr>
             </a:gs>
             <a:gs pos="100000">
               <a:schemeClr val="phClr">
-                <a:tint val="50000"/>
-                <a:shade val="100000"/>
-                <a:satMod val="350000"/>
+                <a:lumMod val="99000"/>
+                <a:satMod val="120000"/>
+                <a:shade val="78000"/>
               </a:schemeClr>
             </a:gs>
           </a:gsLst>
-          <a:lin ang="16200000" scaled="0"/>
+          <a:lin ang="5400000" scaled="0"/>
         </a:gradFill>
       </a:fillStyleLst>
       <a:lnStyleLst>
-        <a:ln w="9525" cap="flat" cmpd="sng" algn="ctr">
+        <a:ln w="12700" cap="flat" cmpd="sng" algn="ctr">
           <a:solidFill>
-            <a:schemeClr val="phClr">
-              <a:shade val="95000"/>
-              <a:satMod val="105000"/>
-            </a:schemeClr>
+            <a:schemeClr val="phClr"/>
           </a:solidFill>
           <a:prstDash val="solid"/>
+          <a:miter lim="800000"/>
+        </a:ln>
+        <a:ln w="19050" cap="flat" cmpd="sng" algn="ctr">
+          <a:solidFill>
+            <a:schemeClr val="phClr"/>
+          </a:solidFill>
+          <a:prstDash val="solid"/>
+          <a:miter lim="800000"/>
         </a:ln>
         <a:ln w="25400" cap="flat" cmpd="sng" algn="ctr">
           <a:solidFill>
             <a:schemeClr val="phClr"/>
           </a:solidFill>
           <a:prstDash val="solid"/>
-        </a:ln>
-        <a:ln w="38100" cap="flat" cmpd="sng" algn="ctr">
-          <a:solidFill>
-            <a:schemeClr val="phClr"/>
-          </a:solidFill>
-          <a:prstDash val="solid"/>
+          <a:miter lim="800000"/>
         </a:ln>
       </a:lnStyleLst>
       <a:effectStyleLst>
         <a:effectStyle>
+          <a:effectLst/>
+        </a:effectStyle>
+        <a:effectStyle>
+          <a:effectLst/>
+        </a:effectStyle>
+        <a:effectStyle>
           <a:effectLst>
-            <a:outerShdw blurRad="40000" dist="20000" dir="5400000" rotWithShape="0">
+            <a:outerShdw blurRad="57150" dist="19050" dir="5400000" algn="ctr" rotWithShape="0">
               <a:srgbClr val="000000">
-                <a:alpha val="38000"/>
+                <a:alpha val="63000"/>
               </a:srgbClr>
             </a:outerShdw>
           </a:effectLst>
-        </a:effectStyle>
-        <a:effectStyle>
-          <a:effectLst>
-            <a:outerShdw blurRad="40000" dist="23000" dir="5400000" rotWithShape="0">
-              <a:srgbClr val="000000">
-                <a:alpha val="35000"/>
-              </a:srgbClr>
-            </a:outerShdw>
-          </a:effectLst>
-        </a:effectStyle>
-        <a:effectStyle>
-          <a:effectLst>
-            <a:outerShdw blurRad="40000" dist="23000" dir="5400000" rotWithShape="0">
-              <a:srgbClr val="000000">
-                <a:alpha val="35000"/>
-              </a:srgbClr>
-            </a:outerShdw>
-          </a:effectLst>
-          <a:scene3d>
-            <a:camera prst="orthographicFront">
-              <a:rot lat="0" lon="0" rev="0"/>
-            </a:camera>
-            <a:lightRig rig="threePt" dir="t">
-              <a:rot lat="0" lon="0" rev="1200000"/>
-            </a:lightRig>
-          </a:scene3d>
-          <a:sp3d>
-            <a:bevelT w="63500" h="25400"/>
-          </a:sp3d>
         </a:effectStyle>
       </a:effectStyleLst>
       <a:bgFillStyleLst>
         <a:solidFill>
           <a:schemeClr val="phClr"/>
         </a:solidFill>
+        <a:solidFill>
+          <a:schemeClr val="phClr">
+            <a:tint val="95000"/>
+            <a:satMod val="170000"/>
+          </a:schemeClr>
+        </a:solidFill>
         <a:gradFill rotWithShape="1">
           <a:gsLst>
             <a:gs pos="0">
               <a:schemeClr val="phClr">
-                <a:tint val="40000"/>
-                <a:satMod val="350000"/>
+                <a:tint val="93000"/>
+                <a:satMod val="150000"/>
+                <a:shade val="98000"/>
+                <a:lumMod val="102000"/>
               </a:schemeClr>
             </a:gs>
-            <a:gs pos="40000">
+            <a:gs pos="50000">
               <a:schemeClr val="phClr">
-                <a:tint val="45000"/>
-                <a:shade val="99000"/>
-                <a:satMod val="350000"/>
+                <a:tint val="98000"/>
+                <a:satMod val="130000"/>
+                <a:shade val="90000"/>
+                <a:lumMod val="103000"/>
               </a:schemeClr>
             </a:gs>
             <a:gs pos="100000">
               <a:schemeClr val="phClr">
-                <a:shade val="20000"/>
-                <a:satMod val="255000"/>
+                <a:shade val="63000"/>
+                <a:satMod val="120000"/>
               </a:schemeClr>
             </a:gs>
           </a:gsLst>
-          <a:path path="circle">
-            <a:fillToRect l="50000" t="-80000" r="50000" b="180000"/>
-          </a:path>
-        </a:gradFill>
-        <a:gradFill rotWithShape="1">
-          <a:gsLst>
-            <a:gs pos="0">
-              <a:schemeClr val="phClr">
-                <a:tint val="80000"/>
-                <a:satMod val="300000"/>
-              </a:schemeClr>
-            </a:gs>
-            <a:gs pos="100000">
-              <a:schemeClr val="phClr">
-                <a:shade val="30000"/>
-                <a:satMod val="200000"/>
-              </a:schemeClr>
-            </a:gs>
-          </a:gsLst>
-          <a:path path="circle">
-            <a:fillToRect l="50000" t="50000" r="50000" b="50000"/>
-          </a:path>
+          <a:lin ang="5400000" scaled="0"/>
         </a:gradFill>
       </a:bgFillStyleLst>
     </a:fmtScheme>
   </a:themeElements>
   <a:objectDefaults>
-    <a:spDef>
-      <a:spPr/>
-      <a:bodyPr/>
-      <a:lstStyle/>
-      <a:style>
-        <a:lnRef idx="1">
-          <a:schemeClr val="accent1"/>
-        </a:lnRef>
-        <a:fillRef idx="3">
-          <a:schemeClr val="accent1"/>
-        </a:fillRef>
-        <a:effectRef idx="2">
-          <a:schemeClr val="accent1"/>
-        </a:effectRef>
-        <a:fontRef idx="minor">
-          <a:schemeClr val="lt1"/>
-        </a:fontRef>
-      </a:style>
-    </a:spDef>
     <a:lnDef>
       <a:spPr/>
       <a:bodyPr/>
@@ -8532,5 +8363,10 @@
     </a:lnDef>
   </a:objectDefaults>
   <a:extraClrSchemeLst/>
+  <a:extLst>
+    <a:ext uri="{05A4C25C-085E-4340-85A3-A5531E510DB2}">
+      <thm15:themeFamily xmlns:thm15="http://schemas.microsoft.com/office/thememl/2012/main" name="Office Theme" id="{2E142A2C-CD16-42D6-873A-C26D2A0506FA}" vid="{1BDDFF52-6CD6-40A5-AB3C-68EB2F1E4D0A}"/>
+    </a:ext>
+  </a:extLst>
 </a:theme>
 </file>
</xml_diff>

<commit_message>
Update week4 PowerPoint deck with tinyurl.com/baysec-week4
</commit_message>
<xml_diff>
--- a/week4/BaySec_Week4_Kickoff.pptx
+++ b/week4/BaySec_Week4_Kickoff.pptx
@@ -4,20 +4,17 @@
   <p:sldMasterIdLst>
     <p:sldMasterId id="2147483648" r:id="rId1"/>
   </p:sldMasterIdLst>
-  <p:notesMasterIdLst>
-    <p:notesMasterId r:id="rId10"/>
-  </p:notesMasterIdLst>
   <p:sldIdLst>
-    <p:sldId id="256" r:id="rId2"/>
-    <p:sldId id="257" r:id="rId3"/>
-    <p:sldId id="258" r:id="rId4"/>
-    <p:sldId id="259" r:id="rId5"/>
-    <p:sldId id="260" r:id="rId6"/>
-    <p:sldId id="261" r:id="rId7"/>
-    <p:sldId id="262" r:id="rId8"/>
-    <p:sldId id="263" r:id="rId9"/>
+    <p:sldId id="256" r:id="rId7"/>
+    <p:sldId id="257" r:id="rId9"/>
+    <p:sldId id="258" r:id="rId10"/>
+    <p:sldId id="259" r:id="rId11"/>
+    <p:sldId id="260" r:id="rId12"/>
+    <p:sldId id="261" r:id="rId13"/>
+    <p:sldId id="262" r:id="rId14"/>
+    <p:sldId id="263" r:id="rId15"/>
   </p:sldIdLst>
-  <p:sldSz cx="12192000" cy="6858000"/>
+  <p:sldSz cx="12191695" cy="6858000" type="screen4x3"/>
   <p:notesSz cx="6858000" cy="9144000"/>
   <p:defaultTextStyle>
     <a:defPPr>
@@ -114,27 +111,11 @@
       </a:defRPr>
     </a:lvl9pPr>
   </p:defaultTextStyle>
-  <p:extLst>
-    <p:ext uri="{EFAFB233-063F-42B5-8137-9DF3F51BA10A}">
-      <p15:sldGuideLst xmlns:p15="http://schemas.microsoft.com/office/powerpoint/2012/main">
-        <p15:guide id="1" orient="horz" pos="2160">
-          <p15:clr>
-            <a:srgbClr val="A4A3A4"/>
-          </p15:clr>
-        </p15:guide>
-        <p15:guide id="2" pos="2880">
-          <p15:clr>
-            <a:srgbClr val="A4A3A4"/>
-          </p15:clr>
-        </p15:guide>
-      </p15:sldGuideLst>
-    </p:ext>
-  </p:extLst>
 </p:presentation>
 </file>
 
 <file path=ppt/notesMasters/notesMaster1.xml><?xml version="1.0" encoding="utf-8"?>
-<p:notesMaster xmlns:a="http://schemas.openxmlformats.org/drawingml/2006/main" xmlns:r="http://schemas.openxmlformats.org/officeDocument/2006/relationships" xmlns:p="http://schemas.openxmlformats.org/presentationml/2006/main">
+<p:notesMaster xmlns:a="http://schemas.openxmlformats.org/drawingml/2006/main" xmlns:p="http://schemas.openxmlformats.org/presentationml/2006/main" xmlns:r="http://schemas.openxmlformats.org/officeDocument/2006/relationships">
   <p:cSld>
     <p:bg>
       <p:bgRef idx="1001">
@@ -155,16 +136,241 @@
           <a:chExt cx="0" cy="0"/>
         </a:xfrm>
       </p:grpSpPr>
+      <p:sp>
+        <p:nvSpPr>
+          <p:cNvPr id="2" name="Header Placeholder 1"/>
+          <p:cNvSpPr>
+            <a:spLocks noGrp="1"/>
+          </p:cNvSpPr>
+          <p:nvPr>
+            <p:ph type="hdr" sz="quarter"/>
+          </p:nvPr>
+        </p:nvSpPr>
+        <p:spPr>
+          <a:xfrm>
+            <a:off x="0" y="0"/>
+            <a:ext cx="2971800" cy="457200"/>
+          </a:xfrm>
+          <a:prstGeom prst="rect">
+            <a:avLst/>
+          </a:prstGeom>
+        </p:spPr>
+        <p:txBody>
+          <a:bodyPr vert="horz" lIns="91440" tIns="45720" rIns="91440" bIns="45720" rtlCol="0"/>
+          <a:lstStyle>
+            <a:lvl1pPr algn="l">
+              <a:defRPr sz="1200"/>
+            </a:lvl1pPr>
+          </a:lstStyle>
+          <a:p>
+            <a:endParaRPr lang="en-US"/>
+          </a:p>
+        </p:txBody>
+      </p:sp>
+      <p:sp>
+        <p:nvSpPr>
+          <p:cNvPr id="3" name="Date Placeholder 2"/>
+          <p:cNvSpPr>
+            <a:spLocks noGrp="1"/>
+          </p:cNvSpPr>
+          <p:nvPr>
+            <p:ph type="dt" idx="1"/>
+          </p:nvPr>
+        </p:nvSpPr>
+        <p:spPr>
+          <a:xfrm>
+            <a:off x="3884613" y="0"/>
+            <a:ext cx="2971800" cy="457200"/>
+          </a:xfrm>
+          <a:prstGeom prst="rect">
+            <a:avLst/>
+          </a:prstGeom>
+        </p:spPr>
+        <p:txBody>
+          <a:bodyPr vert="horz" lIns="91440" tIns="45720" rIns="91440" bIns="45720" rtlCol="0"/>
+          <a:lstStyle>
+            <a:lvl1pPr algn="r">
+              <a:defRPr sz="1200"/>
+            </a:lvl1pPr>
+          </a:lstStyle>
+          <a:p>
+            <a:fld id="{0F89C1C7-3DCD-1040-A9CF-14679D8B5DDD}" type="datetimeFigureOut">
+              <a:rPr lang="en-US" smtClean="0"/>
+              <a:t>10/17/16</a:t>
+            </a:fld>
+            <a:endParaRPr lang="en-US"/>
+          </a:p>
+        </p:txBody>
+      </p:sp>
+      <p:sp>
+        <p:nvSpPr>
+          <p:cNvPr id="4" name="Slide Image Placeholder 3"/>
+          <p:cNvSpPr>
+            <a:spLocks noGrp="1" noRot="1" noChangeAspect="1"/>
+          </p:cNvSpPr>
+          <p:nvPr>
+            <p:ph type="sldImg" idx="2"/>
+          </p:nvPr>
+        </p:nvSpPr>
+        <p:spPr>
+          <a:xfrm>
+            <a:off x="1143000" y="685800"/>
+            <a:ext cx="4572000" cy="3429000"/>
+          </a:xfrm>
+          <a:prstGeom prst="rect">
+            <a:avLst/>
+          </a:prstGeom>
+          <a:noFill/>
+          <a:ln w="12700">
+            <a:solidFill>
+              <a:prstClr val="black"/>
+            </a:solidFill>
+          </a:ln>
+        </p:spPr>
+        <p:txBody>
+          <a:bodyPr vert="horz" lIns="91440" tIns="45720" rIns="91440" bIns="45720" rtlCol="0" anchor="ctr"/>
+          <a:lstStyle/>
+          <a:p>
+            <a:endParaRPr lang="en-US"/>
+          </a:p>
+        </p:txBody>
+      </p:sp>
+      <p:sp>
+        <p:nvSpPr>
+          <p:cNvPr id="5" name="Notes Placeholder 4"/>
+          <p:cNvSpPr>
+            <a:spLocks noGrp="1"/>
+          </p:cNvSpPr>
+          <p:nvPr>
+            <p:ph type="body" sz="quarter" idx="3"/>
+          </p:nvPr>
+        </p:nvSpPr>
+        <p:spPr>
+          <a:xfrm>
+            <a:off x="685800" y="4343400"/>
+            <a:ext cx="5486400" cy="4114800"/>
+          </a:xfrm>
+          <a:prstGeom prst="rect">
+            <a:avLst/>
+          </a:prstGeom>
+        </p:spPr>
+        <p:txBody>
+          <a:bodyPr vert="horz" lIns="91440" tIns="45720" rIns="91440" bIns="45720" rtlCol="0"/>
+          <a:lstStyle/>
+          <a:p>
+            <a:pPr lvl="0"/>
+            <a:r>
+              <a:rPr lang="en-US" smtClean="0"/>
+              <a:t>Click to edit Master text styles</a:t>
+            </a:r>
+          </a:p>
+          <a:p>
+            <a:pPr lvl="1"/>
+            <a:r>
+              <a:rPr lang="en-US" smtClean="0"/>
+              <a:t>Second level</a:t>
+            </a:r>
+          </a:p>
+          <a:p>
+            <a:pPr lvl="2"/>
+            <a:r>
+              <a:rPr lang="en-US" smtClean="0"/>
+              <a:t>Third level</a:t>
+            </a:r>
+          </a:p>
+          <a:p>
+            <a:pPr lvl="3"/>
+            <a:r>
+              <a:rPr lang="en-US" smtClean="0"/>
+              <a:t>Fourth level</a:t>
+            </a:r>
+          </a:p>
+          <a:p>
+            <a:pPr lvl="4"/>
+            <a:r>
+              <a:rPr lang="en-US" smtClean="0"/>
+              <a:t>Fifth level</a:t>
+            </a:r>
+            <a:endParaRPr lang="en-US"/>
+          </a:p>
+        </p:txBody>
+      </p:sp>
+      <p:sp>
+        <p:nvSpPr>
+          <p:cNvPr id="6" name="Footer Placeholder 5"/>
+          <p:cNvSpPr>
+            <a:spLocks noGrp="1"/>
+          </p:cNvSpPr>
+          <p:nvPr>
+            <p:ph type="ftr" sz="quarter" idx="4"/>
+          </p:nvPr>
+        </p:nvSpPr>
+        <p:spPr>
+          <a:xfrm>
+            <a:off x="0" y="8685213"/>
+            <a:ext cx="2971800" cy="457200"/>
+          </a:xfrm>
+          <a:prstGeom prst="rect">
+            <a:avLst/>
+          </a:prstGeom>
+        </p:spPr>
+        <p:txBody>
+          <a:bodyPr vert="horz" lIns="91440" tIns="45720" rIns="91440" bIns="45720" rtlCol="0" anchor="b"/>
+          <a:lstStyle>
+            <a:lvl1pPr algn="l">
+              <a:defRPr sz="1200"/>
+            </a:lvl1pPr>
+          </a:lstStyle>
+          <a:p>
+            <a:endParaRPr lang="en-US"/>
+          </a:p>
+        </p:txBody>
+      </p:sp>
+      <p:sp>
+        <p:nvSpPr>
+          <p:cNvPr id="7" name="Slide Number Placeholder 6"/>
+          <p:cNvSpPr>
+            <a:spLocks noGrp="1"/>
+          </p:cNvSpPr>
+          <p:nvPr>
+            <p:ph type="sldNum" sz="quarter" idx="5"/>
+          </p:nvPr>
+        </p:nvSpPr>
+        <p:spPr>
+          <a:xfrm>
+            <a:off x="3884613" y="8685213"/>
+            <a:ext cx="2971800" cy="457200"/>
+          </a:xfrm>
+          <a:prstGeom prst="rect">
+            <a:avLst/>
+          </a:prstGeom>
+        </p:spPr>
+        <p:txBody>
+          <a:bodyPr vert="horz" lIns="91440" tIns="45720" rIns="91440" bIns="45720" rtlCol="0" anchor="b"/>
+          <a:lstStyle>
+            <a:lvl1pPr algn="r">
+              <a:defRPr sz="1200"/>
+            </a:lvl1pPr>
+          </a:lstStyle>
+          <a:p>
+            <a:fld id="{BB5E49A5-4136-284D-997B-48E1D791AD67}" type="slidenum">
+              <a:rPr lang="en-US" smtClean="0"/>
+              <a:t>‹#›</a:t>
+            </a:fld>
+            <a:endParaRPr lang="en-US"/>
+          </a:p>
+        </p:txBody>
+      </p:sp>
     </p:spTree>
     <p:extLst>
       <p:ext uri="{BB962C8B-B14F-4D97-AF65-F5344CB8AC3E}">
-        <p14:creationId xmlns:p14="http://schemas.microsoft.com/office/powerpoint/2010/main" val="1366494735"/>
+        <p14:creationId xmlns:p14="http://schemas.microsoft.com/office/powerpoint/2010/main" val="2623252185"/>
       </p:ext>
     </p:extLst>
   </p:cSld>
   <p:clrMap bg1="lt1" tx1="dk1" bg2="lt2" tx2="dk2" accent1="accent1" accent2="accent2" accent3="accent3" accent4="accent4" accent5="accent5" accent6="accent6" hlink="hlink" folHlink="folHlink"/>
   <p:notesStyle>
-    <a:lvl1pPr marL="0" algn="l" defTabSz="914400" rtl="0" eaLnBrk="1" latinLnBrk="0" hangingPunct="1">
+    <a:lvl1pPr marL="0" algn="l" defTabSz="457200" rtl="0" eaLnBrk="1" latinLnBrk="0" hangingPunct="1">
       <a:defRPr sz="1200" kern="1200">
         <a:solidFill>
           <a:schemeClr val="tx1"/>
@@ -174,7 +380,7 @@
         <a:cs typeface="+mn-cs"/>
       </a:defRPr>
     </a:lvl1pPr>
-    <a:lvl2pPr marL="457200" algn="l" defTabSz="914400" rtl="0" eaLnBrk="1" latinLnBrk="0" hangingPunct="1">
+    <a:lvl2pPr marL="457200" algn="l" defTabSz="457200" rtl="0" eaLnBrk="1" latinLnBrk="0" hangingPunct="1">
       <a:defRPr sz="1200" kern="1200">
         <a:solidFill>
           <a:schemeClr val="tx1"/>
@@ -184,7 +390,7 @@
         <a:cs typeface="+mn-cs"/>
       </a:defRPr>
     </a:lvl2pPr>
-    <a:lvl3pPr marL="914400" algn="l" defTabSz="914400" rtl="0" eaLnBrk="1" latinLnBrk="0" hangingPunct="1">
+    <a:lvl3pPr marL="914400" algn="l" defTabSz="457200" rtl="0" eaLnBrk="1" latinLnBrk="0" hangingPunct="1">
       <a:defRPr sz="1200" kern="1200">
         <a:solidFill>
           <a:schemeClr val="tx1"/>
@@ -194,7 +400,7 @@
         <a:cs typeface="+mn-cs"/>
       </a:defRPr>
     </a:lvl3pPr>
-    <a:lvl4pPr marL="1371600" algn="l" defTabSz="914400" rtl="0" eaLnBrk="1" latinLnBrk="0" hangingPunct="1">
+    <a:lvl4pPr marL="1371600" algn="l" defTabSz="457200" rtl="0" eaLnBrk="1" latinLnBrk="0" hangingPunct="1">
       <a:defRPr sz="1200" kern="1200">
         <a:solidFill>
           <a:schemeClr val="tx1"/>
@@ -204,7 +410,7 @@
         <a:cs typeface="+mn-cs"/>
       </a:defRPr>
     </a:lvl4pPr>
-    <a:lvl5pPr marL="1828800" algn="l" defTabSz="914400" rtl="0" eaLnBrk="1" latinLnBrk="0" hangingPunct="1">
+    <a:lvl5pPr marL="1828800" algn="l" defTabSz="457200" rtl="0" eaLnBrk="1" latinLnBrk="0" hangingPunct="1">
       <a:defRPr sz="1200" kern="1200">
         <a:solidFill>
           <a:schemeClr val="tx1"/>
@@ -214,7 +420,7 @@
         <a:cs typeface="+mn-cs"/>
       </a:defRPr>
     </a:lvl5pPr>
-    <a:lvl6pPr marL="2286000" algn="l" defTabSz="914400" rtl="0" eaLnBrk="1" latinLnBrk="0" hangingPunct="1">
+    <a:lvl6pPr marL="2286000" algn="l" defTabSz="457200" rtl="0" eaLnBrk="1" latinLnBrk="0" hangingPunct="1">
       <a:defRPr sz="1200" kern="1200">
         <a:solidFill>
           <a:schemeClr val="tx1"/>
@@ -224,7 +430,7 @@
         <a:cs typeface="+mn-cs"/>
       </a:defRPr>
     </a:lvl6pPr>
-    <a:lvl7pPr marL="2743200" algn="l" defTabSz="914400" rtl="0" eaLnBrk="1" latinLnBrk="0" hangingPunct="1">
+    <a:lvl7pPr marL="2743200" algn="l" defTabSz="457200" rtl="0" eaLnBrk="1" latinLnBrk="0" hangingPunct="1">
       <a:defRPr sz="1200" kern="1200">
         <a:solidFill>
           <a:schemeClr val="tx1"/>
@@ -234,7 +440,7 @@
         <a:cs typeface="+mn-cs"/>
       </a:defRPr>
     </a:lvl7pPr>
-    <a:lvl8pPr marL="3200400" algn="l" defTabSz="914400" rtl="0" eaLnBrk="1" latinLnBrk="0" hangingPunct="1">
+    <a:lvl8pPr marL="3200400" algn="l" defTabSz="457200" rtl="0" eaLnBrk="1" latinLnBrk="0" hangingPunct="1">
       <a:defRPr sz="1200" kern="1200">
         <a:solidFill>
           <a:schemeClr val="tx1"/>
@@ -244,7 +450,7 @@
         <a:cs typeface="+mn-cs"/>
       </a:defRPr>
     </a:lvl8pPr>
-    <a:lvl9pPr marL="3657600" algn="l" defTabSz="914400" rtl="0" eaLnBrk="1" latinLnBrk="0" hangingPunct="1">
+    <a:lvl9pPr marL="3657600" algn="l" defTabSz="457200" rtl="0" eaLnBrk="1" latinLnBrk="0" hangingPunct="1">
       <a:defRPr sz="1200" kern="1200">
         <a:solidFill>
           <a:schemeClr val="tx1"/>
@@ -259,7 +465,7 @@
 </file>
 
 <file path=ppt/notesSlides/notesSlide1.xml><?xml version="1.0" encoding="utf-8"?>
-<p:notes xmlns:a="http://schemas.openxmlformats.org/drawingml/2006/main" xmlns:r="http://schemas.openxmlformats.org/officeDocument/2006/relationships" xmlns:p="http://schemas.openxmlformats.org/presentationml/2006/main">
+<p:notes xmlns:a="http://schemas.openxmlformats.org/drawingml/2006/main" xmlns:p="http://schemas.openxmlformats.org/presentationml/2006/main" xmlns:r="http://schemas.openxmlformats.org/officeDocument/2006/relationships">
   <p:cSld>
     <p:spTree>
       <p:nvGrpSpPr>
@@ -279,7 +485,7 @@
         <p:nvSpPr>
           <p:cNvPr id="2" name="Slide Image Placeholder 1"/>
           <p:cNvSpPr>
-            <a:spLocks noGrp="1" noRot="1" noChangeAspect="1"/>
+            <a:spLocks noGrp="1"/>
           </p:cNvSpPr>
           <p:nvPr>
             <p:ph type="sldImg" idx="2"/>
@@ -294,7 +500,7 @@
             <a:spLocks noGrp="1"/>
           </p:cNvSpPr>
           <p:nvPr>
-            <p:ph type="body" sz="quarter" idx="3"/>
+            <p:ph type="body" idx="3" sz="quarter"/>
           </p:nvPr>
         </p:nvSpPr>
         <p:spPr/>
@@ -315,7 +521,7 @@
             <a:spLocks noGrp="1"/>
           </p:cNvSpPr>
           <p:nvPr>
-            <p:ph type="sldNum" sz="quarter" idx="5"/>
+            <p:ph type="sldNum" idx="5" sz="quarter"/>
           </p:nvPr>
         </p:nvSpPr>
         <p:spPr/>
@@ -329,7 +535,7 @@
 </file>
 
 <file path=ppt/notesSlides/notesSlide2.xml><?xml version="1.0" encoding="utf-8"?>
-<p:notes xmlns:a="http://schemas.openxmlformats.org/drawingml/2006/main" xmlns:r="http://schemas.openxmlformats.org/officeDocument/2006/relationships" xmlns:p="http://schemas.openxmlformats.org/presentationml/2006/main">
+<p:notes xmlns:a="http://schemas.openxmlformats.org/drawingml/2006/main" xmlns:p="http://schemas.openxmlformats.org/presentationml/2006/main" xmlns:r="http://schemas.openxmlformats.org/officeDocument/2006/relationships">
   <p:cSld>
     <p:spTree>
       <p:nvGrpSpPr>
@@ -349,7 +555,7 @@
         <p:nvSpPr>
           <p:cNvPr id="2" name="Slide Image Placeholder 1"/>
           <p:cNvSpPr>
-            <a:spLocks noGrp="1" noRot="1" noChangeAspect="1"/>
+            <a:spLocks noGrp="1"/>
           </p:cNvSpPr>
           <p:nvPr>
             <p:ph type="sldImg" idx="2"/>
@@ -364,7 +570,7 @@
             <a:spLocks noGrp="1"/>
           </p:cNvSpPr>
           <p:nvPr>
-            <p:ph type="body" sz="quarter" idx="3"/>
+            <p:ph type="body" idx="3" sz="quarter"/>
           </p:nvPr>
         </p:nvSpPr>
         <p:spPr/>
@@ -385,7 +591,7 @@
             <a:spLocks noGrp="1"/>
           </p:cNvSpPr>
           <p:nvPr>
-            <p:ph type="sldNum" sz="quarter" idx="5"/>
+            <p:ph type="sldNum" idx="5" sz="quarter"/>
           </p:nvPr>
         </p:nvSpPr>
         <p:spPr/>
@@ -399,7 +605,7 @@
 </file>
 
 <file path=ppt/notesSlides/notesSlide3.xml><?xml version="1.0" encoding="utf-8"?>
-<p:notes xmlns:a="http://schemas.openxmlformats.org/drawingml/2006/main" xmlns:r="http://schemas.openxmlformats.org/officeDocument/2006/relationships" xmlns:p="http://schemas.openxmlformats.org/presentationml/2006/main">
+<p:notes xmlns:a="http://schemas.openxmlformats.org/drawingml/2006/main" xmlns:p="http://schemas.openxmlformats.org/presentationml/2006/main" xmlns:r="http://schemas.openxmlformats.org/officeDocument/2006/relationships">
   <p:cSld>
     <p:spTree>
       <p:nvGrpSpPr>
@@ -419,7 +625,7 @@
         <p:nvSpPr>
           <p:cNvPr id="2" name="Slide Image Placeholder 1"/>
           <p:cNvSpPr>
-            <a:spLocks noGrp="1" noRot="1" noChangeAspect="1"/>
+            <a:spLocks noGrp="1"/>
           </p:cNvSpPr>
           <p:nvPr>
             <p:ph type="sldImg" idx="2"/>
@@ -434,7 +640,7 @@
             <a:spLocks noGrp="1"/>
           </p:cNvSpPr>
           <p:nvPr>
-            <p:ph type="body" sz="quarter" idx="3"/>
+            <p:ph type="body" idx="3" sz="quarter"/>
           </p:nvPr>
         </p:nvSpPr>
         <p:spPr/>
@@ -455,7 +661,7 @@
             <a:spLocks noGrp="1"/>
           </p:cNvSpPr>
           <p:nvPr>
-            <p:ph type="sldNum" sz="quarter" idx="5"/>
+            <p:ph type="sldNum" idx="5" sz="quarter"/>
           </p:nvPr>
         </p:nvSpPr>
         <p:spPr/>
@@ -469,7 +675,7 @@
 </file>
 
 <file path=ppt/notesSlides/notesSlide4.xml><?xml version="1.0" encoding="utf-8"?>
-<p:notes xmlns:a="http://schemas.openxmlformats.org/drawingml/2006/main" xmlns:r="http://schemas.openxmlformats.org/officeDocument/2006/relationships" xmlns:p="http://schemas.openxmlformats.org/presentationml/2006/main">
+<p:notes xmlns:a="http://schemas.openxmlformats.org/drawingml/2006/main" xmlns:p="http://schemas.openxmlformats.org/presentationml/2006/main" xmlns:r="http://schemas.openxmlformats.org/officeDocument/2006/relationships">
   <p:cSld>
     <p:spTree>
       <p:nvGrpSpPr>
@@ -489,7 +695,7 @@
         <p:nvSpPr>
           <p:cNvPr id="2" name="Slide Image Placeholder 1"/>
           <p:cNvSpPr>
-            <a:spLocks noGrp="1" noRot="1" noChangeAspect="1"/>
+            <a:spLocks noGrp="1"/>
           </p:cNvSpPr>
           <p:nvPr>
             <p:ph type="sldImg" idx="2"/>
@@ -504,7 +710,7 @@
             <a:spLocks noGrp="1"/>
           </p:cNvSpPr>
           <p:nvPr>
-            <p:ph type="body" sz="quarter" idx="3"/>
+            <p:ph type="body" idx="3" sz="quarter"/>
           </p:nvPr>
         </p:nvSpPr>
         <p:spPr/>
@@ -525,7 +731,7 @@
             <a:spLocks noGrp="1"/>
           </p:cNvSpPr>
           <p:nvPr>
-            <p:ph type="sldNum" sz="quarter" idx="5"/>
+            <p:ph type="sldNum" idx="5" sz="quarter"/>
           </p:nvPr>
         </p:nvSpPr>
         <p:spPr/>
@@ -539,7 +745,7 @@
 </file>
 
 <file path=ppt/notesSlides/notesSlide5.xml><?xml version="1.0" encoding="utf-8"?>
-<p:notes xmlns:a="http://schemas.openxmlformats.org/drawingml/2006/main" xmlns:r="http://schemas.openxmlformats.org/officeDocument/2006/relationships" xmlns:p="http://schemas.openxmlformats.org/presentationml/2006/main">
+<p:notes xmlns:a="http://schemas.openxmlformats.org/drawingml/2006/main" xmlns:p="http://schemas.openxmlformats.org/presentationml/2006/main" xmlns:r="http://schemas.openxmlformats.org/officeDocument/2006/relationships">
   <p:cSld>
     <p:spTree>
       <p:nvGrpSpPr>
@@ -559,7 +765,7 @@
         <p:nvSpPr>
           <p:cNvPr id="2" name="Slide Image Placeholder 1"/>
           <p:cNvSpPr>
-            <a:spLocks noGrp="1" noRot="1" noChangeAspect="1"/>
+            <a:spLocks noGrp="1"/>
           </p:cNvSpPr>
           <p:nvPr>
             <p:ph type="sldImg" idx="2"/>
@@ -574,7 +780,7 @@
             <a:spLocks noGrp="1"/>
           </p:cNvSpPr>
           <p:nvPr>
-            <p:ph type="body" sz="quarter" idx="3"/>
+            <p:ph type="body" idx="3" sz="quarter"/>
           </p:nvPr>
         </p:nvSpPr>
         <p:spPr/>
@@ -595,7 +801,7 @@
             <a:spLocks noGrp="1"/>
           </p:cNvSpPr>
           <p:nvPr>
-            <p:ph type="sldNum" sz="quarter" idx="5"/>
+            <p:ph type="sldNum" idx="5" sz="quarter"/>
           </p:nvPr>
         </p:nvSpPr>
         <p:spPr/>
@@ -609,7 +815,7 @@
 </file>
 
 <file path=ppt/notesSlides/notesSlide6.xml><?xml version="1.0" encoding="utf-8"?>
-<p:notes xmlns:a="http://schemas.openxmlformats.org/drawingml/2006/main" xmlns:r="http://schemas.openxmlformats.org/officeDocument/2006/relationships" xmlns:p="http://schemas.openxmlformats.org/presentationml/2006/main">
+<p:notes xmlns:a="http://schemas.openxmlformats.org/drawingml/2006/main" xmlns:p="http://schemas.openxmlformats.org/presentationml/2006/main" xmlns:r="http://schemas.openxmlformats.org/officeDocument/2006/relationships">
   <p:cSld>
     <p:spTree>
       <p:nvGrpSpPr>
@@ -629,7 +835,7 @@
         <p:nvSpPr>
           <p:cNvPr id="2" name="Slide Image Placeholder 1"/>
           <p:cNvSpPr>
-            <a:spLocks noGrp="1" noRot="1" noChangeAspect="1"/>
+            <a:spLocks noGrp="1"/>
           </p:cNvSpPr>
           <p:nvPr>
             <p:ph type="sldImg" idx="2"/>
@@ -644,7 +850,7 @@
             <a:spLocks noGrp="1"/>
           </p:cNvSpPr>
           <p:nvPr>
-            <p:ph type="body" sz="quarter" idx="3"/>
+            <p:ph type="body" idx="3" sz="quarter"/>
           </p:nvPr>
         </p:nvSpPr>
         <p:spPr/>
@@ -665,7 +871,7 @@
             <a:spLocks noGrp="1"/>
           </p:cNvSpPr>
           <p:nvPr>
-            <p:ph type="sldNum" sz="quarter" idx="5"/>
+            <p:ph type="sldNum" idx="5" sz="quarter"/>
           </p:nvPr>
         </p:nvSpPr>
         <p:spPr/>
@@ -679,7 +885,7 @@
 </file>
 
 <file path=ppt/notesSlides/notesSlide7.xml><?xml version="1.0" encoding="utf-8"?>
-<p:notes xmlns:a="http://schemas.openxmlformats.org/drawingml/2006/main" xmlns:r="http://schemas.openxmlformats.org/officeDocument/2006/relationships" xmlns:p="http://schemas.openxmlformats.org/presentationml/2006/main">
+<p:notes xmlns:a="http://schemas.openxmlformats.org/drawingml/2006/main" xmlns:p="http://schemas.openxmlformats.org/presentationml/2006/main" xmlns:r="http://schemas.openxmlformats.org/officeDocument/2006/relationships">
   <p:cSld>
     <p:spTree>
       <p:nvGrpSpPr>
@@ -699,7 +905,7 @@
         <p:nvSpPr>
           <p:cNvPr id="2" name="Slide Image Placeholder 1"/>
           <p:cNvSpPr>
-            <a:spLocks noGrp="1" noRot="1" noChangeAspect="1"/>
+            <a:spLocks noGrp="1"/>
           </p:cNvSpPr>
           <p:nvPr>
             <p:ph type="sldImg" idx="2"/>
@@ -714,7 +920,7 @@
             <a:spLocks noGrp="1"/>
           </p:cNvSpPr>
           <p:nvPr>
-            <p:ph type="body" sz="quarter" idx="3"/>
+            <p:ph type="body" idx="3" sz="quarter"/>
           </p:nvPr>
         </p:nvSpPr>
         <p:spPr/>
@@ -735,7 +941,7 @@
             <a:spLocks noGrp="1"/>
           </p:cNvSpPr>
           <p:nvPr>
-            <p:ph type="sldNum" sz="quarter" idx="5"/>
+            <p:ph type="sldNum" idx="5" sz="quarter"/>
           </p:nvPr>
         </p:nvSpPr>
         <p:spPr/>
@@ -749,7 +955,7 @@
 </file>
 
 <file path=ppt/notesSlides/notesSlide8.xml><?xml version="1.0" encoding="utf-8"?>
-<p:notes xmlns:a="http://schemas.openxmlformats.org/drawingml/2006/main" xmlns:r="http://schemas.openxmlformats.org/officeDocument/2006/relationships" xmlns:p="http://schemas.openxmlformats.org/presentationml/2006/main">
+<p:notes xmlns:a="http://schemas.openxmlformats.org/drawingml/2006/main" xmlns:p="http://schemas.openxmlformats.org/presentationml/2006/main" xmlns:r="http://schemas.openxmlformats.org/officeDocument/2006/relationships">
   <p:cSld>
     <p:spTree>
       <p:nvGrpSpPr>
@@ -769,7 +975,7 @@
         <p:nvSpPr>
           <p:cNvPr id="2" name="Slide Image Placeholder 1"/>
           <p:cNvSpPr>
-            <a:spLocks noGrp="1" noRot="1" noChangeAspect="1"/>
+            <a:spLocks noGrp="1"/>
           </p:cNvSpPr>
           <p:nvPr>
             <p:ph type="sldImg" idx="2"/>
@@ -784,7 +990,7 @@
             <a:spLocks noGrp="1"/>
           </p:cNvSpPr>
           <p:nvPr>
-            <p:ph type="body" sz="quarter" idx="3"/>
+            <p:ph type="body" idx="3" sz="quarter"/>
           </p:nvPr>
         </p:nvSpPr>
         <p:spPr/>
@@ -805,7 +1011,7 @@
             <a:spLocks noGrp="1"/>
           </p:cNvSpPr>
           <p:nvPr>
-            <p:ph type="sldNum" sz="quarter" idx="5"/>
+            <p:ph type="sldNum" idx="5" sz="quarter"/>
           </p:nvPr>
         </p:nvSpPr>
         <p:spPr/>
@@ -856,9 +1062,10 @@
           <a:lstStyle/>
           <a:p>
             <a:r>
-              <a:rPr lang="en-US"/>
+              <a:rPr lang="en-US" smtClean="0"/>
               <a:t>Click to edit Master title style</a:t>
             </a:r>
+            <a:endParaRPr lang="en-US"/>
           </a:p>
         </p:txBody>
       </p:sp>
@@ -974,9 +1181,10 @@
           </a:lstStyle>
           <a:p>
             <a:r>
-              <a:rPr lang="en-US"/>
+              <a:rPr lang="en-US" smtClean="0"/>
               <a:t>Click to edit Master subtitle style</a:t>
             </a:r>
+            <a:endParaRPr lang="en-US"/>
           </a:p>
         </p:txBody>
       </p:sp>
@@ -997,7 +1205,7 @@
           <a:p>
             <a:fld id="{5BCAD085-E8A6-8845-BD4E-CB4CCA059FC4}" type="datetimeFigureOut">
               <a:rPr lang="en-US" smtClean="0"/>
-              <a:t>9/9/2026</a:t>
+              <a:t>1/27/13</a:t>
             </a:fld>
             <a:endParaRPr lang="en-US"/>
           </a:p>
@@ -1091,9 +1299,10 @@
           <a:lstStyle/>
           <a:p>
             <a:r>
-              <a:rPr lang="en-US"/>
+              <a:rPr lang="en-US" smtClean="0"/>
               <a:t>Click to edit Master title style</a:t>
             </a:r>
+            <a:endParaRPr lang="en-US"/>
           </a:p>
         </p:txBody>
       </p:sp>
@@ -1114,37 +1323,38 @@
           <a:p>
             <a:pPr lvl="0"/>
             <a:r>
-              <a:rPr lang="en-US"/>
+              <a:rPr lang="en-US" smtClean="0"/>
               <a:t>Click to edit Master text styles</a:t>
             </a:r>
           </a:p>
           <a:p>
             <a:pPr lvl="1"/>
             <a:r>
-              <a:rPr lang="en-US"/>
+              <a:rPr lang="en-US" smtClean="0"/>
               <a:t>Second level</a:t>
             </a:r>
           </a:p>
           <a:p>
             <a:pPr lvl="2"/>
             <a:r>
-              <a:rPr lang="en-US"/>
+              <a:rPr lang="en-US" smtClean="0"/>
               <a:t>Third level</a:t>
             </a:r>
           </a:p>
           <a:p>
             <a:pPr lvl="3"/>
             <a:r>
-              <a:rPr lang="en-US"/>
+              <a:rPr lang="en-US" smtClean="0"/>
               <a:t>Fourth level</a:t>
             </a:r>
           </a:p>
           <a:p>
             <a:pPr lvl="4"/>
             <a:r>
-              <a:rPr lang="en-US"/>
+              <a:rPr lang="en-US" smtClean="0"/>
               <a:t>Fifth level</a:t>
             </a:r>
+            <a:endParaRPr lang="en-US"/>
           </a:p>
         </p:txBody>
       </p:sp>
@@ -1165,7 +1375,7 @@
           <a:p>
             <a:fld id="{5BCAD085-E8A6-8845-BD4E-CB4CCA059FC4}" type="datetimeFigureOut">
               <a:rPr lang="en-US" smtClean="0"/>
-              <a:t>9/9/2026</a:t>
+              <a:t>1/27/13</a:t>
             </a:fld>
             <a:endParaRPr lang="en-US"/>
           </a:p>
@@ -1264,9 +1474,10 @@
           <a:lstStyle/>
           <a:p>
             <a:r>
-              <a:rPr lang="en-US"/>
+              <a:rPr lang="en-US" smtClean="0"/>
               <a:t>Click to edit Master title style</a:t>
             </a:r>
+            <a:endParaRPr lang="en-US"/>
           </a:p>
         </p:txBody>
       </p:sp>
@@ -1292,37 +1503,38 @@
           <a:p>
             <a:pPr lvl="0"/>
             <a:r>
-              <a:rPr lang="en-US"/>
+              <a:rPr lang="en-US" smtClean="0"/>
               <a:t>Click to edit Master text styles</a:t>
             </a:r>
           </a:p>
           <a:p>
             <a:pPr lvl="1"/>
             <a:r>
-              <a:rPr lang="en-US"/>
+              <a:rPr lang="en-US" smtClean="0"/>
               <a:t>Second level</a:t>
             </a:r>
           </a:p>
           <a:p>
             <a:pPr lvl="2"/>
             <a:r>
-              <a:rPr lang="en-US"/>
+              <a:rPr lang="en-US" smtClean="0"/>
               <a:t>Third level</a:t>
             </a:r>
           </a:p>
           <a:p>
             <a:pPr lvl="3"/>
             <a:r>
-              <a:rPr lang="en-US"/>
+              <a:rPr lang="en-US" smtClean="0"/>
               <a:t>Fourth level</a:t>
             </a:r>
           </a:p>
           <a:p>
             <a:pPr lvl="4"/>
             <a:r>
-              <a:rPr lang="en-US"/>
+              <a:rPr lang="en-US" smtClean="0"/>
               <a:t>Fifth level</a:t>
             </a:r>
+            <a:endParaRPr lang="en-US"/>
           </a:p>
         </p:txBody>
       </p:sp>
@@ -1343,7 +1555,7 @@
           <a:p>
             <a:fld id="{5BCAD085-E8A6-8845-BD4E-CB4CCA059FC4}" type="datetimeFigureOut">
               <a:rPr lang="en-US" smtClean="0"/>
-              <a:t>9/9/2026</a:t>
+              <a:t>1/27/13</a:t>
             </a:fld>
             <a:endParaRPr lang="en-US"/>
           </a:p>
@@ -1437,9 +1649,10 @@
           <a:lstStyle/>
           <a:p>
             <a:r>
-              <a:rPr lang="en-US"/>
+              <a:rPr lang="en-US" smtClean="0"/>
               <a:t>Click to edit Master title style</a:t>
             </a:r>
+            <a:endParaRPr lang="en-US"/>
           </a:p>
         </p:txBody>
       </p:sp>
@@ -1460,37 +1673,38 @@
           <a:p>
             <a:pPr lvl="0"/>
             <a:r>
-              <a:rPr lang="en-US"/>
+              <a:rPr lang="en-US" smtClean="0"/>
               <a:t>Click to edit Master text styles</a:t>
             </a:r>
           </a:p>
           <a:p>
             <a:pPr lvl="1"/>
             <a:r>
-              <a:rPr lang="en-US"/>
+              <a:rPr lang="en-US" smtClean="0"/>
               <a:t>Second level</a:t>
             </a:r>
           </a:p>
           <a:p>
             <a:pPr lvl="2"/>
             <a:r>
-              <a:rPr lang="en-US"/>
+              <a:rPr lang="en-US" smtClean="0"/>
               <a:t>Third level</a:t>
             </a:r>
           </a:p>
           <a:p>
             <a:pPr lvl="3"/>
             <a:r>
-              <a:rPr lang="en-US"/>
+              <a:rPr lang="en-US" smtClean="0"/>
               <a:t>Fourth level</a:t>
             </a:r>
           </a:p>
           <a:p>
             <a:pPr lvl="4"/>
             <a:r>
-              <a:rPr lang="en-US"/>
+              <a:rPr lang="en-US" smtClean="0"/>
               <a:t>Fifth level</a:t>
             </a:r>
+            <a:endParaRPr lang="en-US"/>
           </a:p>
         </p:txBody>
       </p:sp>
@@ -1511,7 +1725,7 @@
           <a:p>
             <a:fld id="{5BCAD085-E8A6-8845-BD4E-CB4CCA059FC4}" type="datetimeFigureOut">
               <a:rPr lang="en-US" smtClean="0"/>
-              <a:t>9/9/2026</a:t>
+              <a:t>1/27/13</a:t>
             </a:fld>
             <a:endParaRPr lang="en-US"/>
           </a:p>
@@ -1614,9 +1828,10 @@
           </a:lstStyle>
           <a:p>
             <a:r>
-              <a:rPr lang="en-US"/>
+              <a:rPr lang="en-US" smtClean="0"/>
               <a:t>Click to edit Master title style</a:t>
             </a:r>
+            <a:endParaRPr lang="en-US"/>
           </a:p>
         </p:txBody>
       </p:sp>
@@ -1733,7 +1948,7 @@
           <a:p>
             <a:pPr lvl="0"/>
             <a:r>
-              <a:rPr lang="en-US"/>
+              <a:rPr lang="en-US" smtClean="0"/>
               <a:t>Click to edit Master text styles</a:t>
             </a:r>
           </a:p>
@@ -1756,7 +1971,7 @@
           <a:p>
             <a:fld id="{5BCAD085-E8A6-8845-BD4E-CB4CCA059FC4}" type="datetimeFigureOut">
               <a:rPr lang="en-US" smtClean="0"/>
-              <a:t>9/9/2026</a:t>
+              <a:t>1/27/13</a:t>
             </a:fld>
             <a:endParaRPr lang="en-US"/>
           </a:p>
@@ -1850,9 +2065,10 @@
           <a:lstStyle/>
           <a:p>
             <a:r>
-              <a:rPr lang="en-US"/>
+              <a:rPr lang="en-US" smtClean="0"/>
               <a:t>Click to edit Master title style</a:t>
             </a:r>
+            <a:endParaRPr lang="en-US"/>
           </a:p>
         </p:txBody>
       </p:sp>
@@ -1906,37 +2122,38 @@
           <a:p>
             <a:pPr lvl="0"/>
             <a:r>
-              <a:rPr lang="en-US"/>
+              <a:rPr lang="en-US" smtClean="0"/>
               <a:t>Click to edit Master text styles</a:t>
             </a:r>
           </a:p>
           <a:p>
             <a:pPr lvl="1"/>
             <a:r>
-              <a:rPr lang="en-US"/>
+              <a:rPr lang="en-US" smtClean="0"/>
               <a:t>Second level</a:t>
             </a:r>
           </a:p>
           <a:p>
             <a:pPr lvl="2"/>
             <a:r>
-              <a:rPr lang="en-US"/>
+              <a:rPr lang="en-US" smtClean="0"/>
               <a:t>Third level</a:t>
             </a:r>
           </a:p>
           <a:p>
             <a:pPr lvl="3"/>
             <a:r>
-              <a:rPr lang="en-US"/>
+              <a:rPr lang="en-US" smtClean="0"/>
               <a:t>Fourth level</a:t>
             </a:r>
           </a:p>
           <a:p>
             <a:pPr lvl="4"/>
             <a:r>
-              <a:rPr lang="en-US"/>
+              <a:rPr lang="en-US" smtClean="0"/>
               <a:t>Fifth level</a:t>
             </a:r>
+            <a:endParaRPr lang="en-US"/>
           </a:p>
         </p:txBody>
       </p:sp>
@@ -1990,37 +2207,38 @@
           <a:p>
             <a:pPr lvl="0"/>
             <a:r>
-              <a:rPr lang="en-US"/>
+              <a:rPr lang="en-US" smtClean="0"/>
               <a:t>Click to edit Master text styles</a:t>
             </a:r>
           </a:p>
           <a:p>
             <a:pPr lvl="1"/>
             <a:r>
-              <a:rPr lang="en-US"/>
+              <a:rPr lang="en-US" smtClean="0"/>
               <a:t>Second level</a:t>
             </a:r>
           </a:p>
           <a:p>
             <a:pPr lvl="2"/>
             <a:r>
-              <a:rPr lang="en-US"/>
+              <a:rPr lang="en-US" smtClean="0"/>
               <a:t>Third level</a:t>
             </a:r>
           </a:p>
           <a:p>
             <a:pPr lvl="3"/>
             <a:r>
-              <a:rPr lang="en-US"/>
+              <a:rPr lang="en-US" smtClean="0"/>
               <a:t>Fourth level</a:t>
             </a:r>
           </a:p>
           <a:p>
             <a:pPr lvl="4"/>
             <a:r>
-              <a:rPr lang="en-US"/>
+              <a:rPr lang="en-US" smtClean="0"/>
               <a:t>Fifth level</a:t>
             </a:r>
+            <a:endParaRPr lang="en-US"/>
           </a:p>
         </p:txBody>
       </p:sp>
@@ -2041,7 +2259,7 @@
           <a:p>
             <a:fld id="{5BCAD085-E8A6-8845-BD4E-CB4CCA059FC4}" type="datetimeFigureOut">
               <a:rPr lang="en-US" smtClean="0"/>
-              <a:t>9/9/2026</a:t>
+              <a:t>1/27/13</a:t>
             </a:fld>
             <a:endParaRPr lang="en-US"/>
           </a:p>
@@ -2139,9 +2357,10 @@
           </a:lstStyle>
           <a:p>
             <a:r>
-              <a:rPr lang="en-US"/>
+              <a:rPr lang="en-US" smtClean="0"/>
               <a:t>Click to edit Master title style</a:t>
             </a:r>
+            <a:endParaRPr lang="en-US"/>
           </a:p>
         </p:txBody>
       </p:sp>
@@ -2204,7 +2423,7 @@
           <a:p>
             <a:pPr lvl="0"/>
             <a:r>
-              <a:rPr lang="en-US"/>
+              <a:rPr lang="en-US" smtClean="0"/>
               <a:t>Click to edit Master text styles</a:t>
             </a:r>
           </a:p>
@@ -2260,37 +2479,38 @@
           <a:p>
             <a:pPr lvl="0"/>
             <a:r>
-              <a:rPr lang="en-US"/>
+              <a:rPr lang="en-US" smtClean="0"/>
               <a:t>Click to edit Master text styles</a:t>
             </a:r>
           </a:p>
           <a:p>
             <a:pPr lvl="1"/>
             <a:r>
-              <a:rPr lang="en-US"/>
+              <a:rPr lang="en-US" smtClean="0"/>
               <a:t>Second level</a:t>
             </a:r>
           </a:p>
           <a:p>
             <a:pPr lvl="2"/>
             <a:r>
-              <a:rPr lang="en-US"/>
+              <a:rPr lang="en-US" smtClean="0"/>
               <a:t>Third level</a:t>
             </a:r>
           </a:p>
           <a:p>
             <a:pPr lvl="3"/>
             <a:r>
-              <a:rPr lang="en-US"/>
+              <a:rPr lang="en-US" smtClean="0"/>
               <a:t>Fourth level</a:t>
             </a:r>
           </a:p>
           <a:p>
             <a:pPr lvl="4"/>
             <a:r>
-              <a:rPr lang="en-US"/>
+              <a:rPr lang="en-US" smtClean="0"/>
               <a:t>Fifth level</a:t>
             </a:r>
+            <a:endParaRPr lang="en-US"/>
           </a:p>
         </p:txBody>
       </p:sp>
@@ -2353,7 +2573,7 @@
           <a:p>
             <a:pPr lvl="0"/>
             <a:r>
-              <a:rPr lang="en-US"/>
+              <a:rPr lang="en-US" smtClean="0"/>
               <a:t>Click to edit Master text styles</a:t>
             </a:r>
           </a:p>
@@ -2409,37 +2629,38 @@
           <a:p>
             <a:pPr lvl="0"/>
             <a:r>
-              <a:rPr lang="en-US"/>
+              <a:rPr lang="en-US" smtClean="0"/>
               <a:t>Click to edit Master text styles</a:t>
             </a:r>
           </a:p>
           <a:p>
             <a:pPr lvl="1"/>
             <a:r>
-              <a:rPr lang="en-US"/>
+              <a:rPr lang="en-US" smtClean="0"/>
               <a:t>Second level</a:t>
             </a:r>
           </a:p>
           <a:p>
             <a:pPr lvl="2"/>
             <a:r>
-              <a:rPr lang="en-US"/>
+              <a:rPr lang="en-US" smtClean="0"/>
               <a:t>Third level</a:t>
             </a:r>
           </a:p>
           <a:p>
             <a:pPr lvl="3"/>
             <a:r>
-              <a:rPr lang="en-US"/>
+              <a:rPr lang="en-US" smtClean="0"/>
               <a:t>Fourth level</a:t>
             </a:r>
           </a:p>
           <a:p>
             <a:pPr lvl="4"/>
             <a:r>
-              <a:rPr lang="en-US"/>
+              <a:rPr lang="en-US" smtClean="0"/>
               <a:t>Fifth level</a:t>
             </a:r>
+            <a:endParaRPr lang="en-US"/>
           </a:p>
         </p:txBody>
       </p:sp>
@@ -2460,7 +2681,7 @@
           <a:p>
             <a:fld id="{5BCAD085-E8A6-8845-BD4E-CB4CCA059FC4}" type="datetimeFigureOut">
               <a:rPr lang="en-US" smtClean="0"/>
-              <a:t>9/9/2026</a:t>
+              <a:t>1/27/13</a:t>
             </a:fld>
             <a:endParaRPr lang="en-US"/>
           </a:p>
@@ -2554,9 +2775,10 @@
           <a:lstStyle/>
           <a:p>
             <a:r>
-              <a:rPr lang="en-US"/>
+              <a:rPr lang="en-US" smtClean="0"/>
               <a:t>Click to edit Master title style</a:t>
             </a:r>
+            <a:endParaRPr lang="en-US"/>
           </a:p>
         </p:txBody>
       </p:sp>
@@ -2577,7 +2799,7 @@
           <a:p>
             <a:fld id="{5BCAD085-E8A6-8845-BD4E-CB4CCA059FC4}" type="datetimeFigureOut">
               <a:rPr lang="en-US" smtClean="0"/>
-              <a:t>9/9/2026</a:t>
+              <a:t>1/27/13</a:t>
             </a:fld>
             <a:endParaRPr lang="en-US"/>
           </a:p>
@@ -2672,7 +2894,7 @@
           <a:p>
             <a:fld id="{5BCAD085-E8A6-8845-BD4E-CB4CCA059FC4}" type="datetimeFigureOut">
               <a:rPr lang="en-US" smtClean="0"/>
-              <a:t>9/9/2026</a:t>
+              <a:t>1/27/13</a:t>
             </a:fld>
             <a:endParaRPr lang="en-US"/>
           </a:p>
@@ -2775,9 +2997,10 @@
           </a:lstStyle>
           <a:p>
             <a:r>
-              <a:rPr lang="en-US"/>
+              <a:rPr lang="en-US" smtClean="0"/>
               <a:t>Click to edit Master title style</a:t>
             </a:r>
+            <a:endParaRPr lang="en-US"/>
           </a:p>
         </p:txBody>
       </p:sp>
@@ -2831,37 +3054,38 @@
           <a:p>
             <a:pPr lvl="0"/>
             <a:r>
-              <a:rPr lang="en-US"/>
+              <a:rPr lang="en-US" smtClean="0"/>
               <a:t>Click to edit Master text styles</a:t>
             </a:r>
           </a:p>
           <a:p>
             <a:pPr lvl="1"/>
             <a:r>
-              <a:rPr lang="en-US"/>
+              <a:rPr lang="en-US" smtClean="0"/>
               <a:t>Second level</a:t>
             </a:r>
           </a:p>
           <a:p>
             <a:pPr lvl="2"/>
             <a:r>
-              <a:rPr lang="en-US"/>
+              <a:rPr lang="en-US" smtClean="0"/>
               <a:t>Third level</a:t>
             </a:r>
           </a:p>
           <a:p>
             <a:pPr lvl="3"/>
             <a:r>
-              <a:rPr lang="en-US"/>
+              <a:rPr lang="en-US" smtClean="0"/>
               <a:t>Fourth level</a:t>
             </a:r>
           </a:p>
           <a:p>
             <a:pPr lvl="4"/>
             <a:r>
-              <a:rPr lang="en-US"/>
+              <a:rPr lang="en-US" smtClean="0"/>
               <a:t>Fifth level</a:t>
             </a:r>
+            <a:endParaRPr lang="en-US"/>
           </a:p>
         </p:txBody>
       </p:sp>
@@ -2924,7 +3148,7 @@
           <a:p>
             <a:pPr lvl="0"/>
             <a:r>
-              <a:rPr lang="en-US"/>
+              <a:rPr lang="en-US" smtClean="0"/>
               <a:t>Click to edit Master text styles</a:t>
             </a:r>
           </a:p>
@@ -2947,7 +3171,7 @@
           <a:p>
             <a:fld id="{5BCAD085-E8A6-8845-BD4E-CB4CCA059FC4}" type="datetimeFigureOut">
               <a:rPr lang="en-US" smtClean="0"/>
-              <a:t>9/9/2026</a:t>
+              <a:t>1/27/13</a:t>
             </a:fld>
             <a:endParaRPr lang="en-US"/>
           </a:p>
@@ -3050,9 +3274,10 @@
           </a:lstStyle>
           <a:p>
             <a:r>
-              <a:rPr lang="en-US"/>
+              <a:rPr lang="en-US" smtClean="0"/>
               <a:t>Click to edit Master title style</a:t>
             </a:r>
+            <a:endParaRPr lang="en-US"/>
           </a:p>
         </p:txBody>
       </p:sp>
@@ -3176,7 +3401,7 @@
           <a:p>
             <a:pPr lvl="0"/>
             <a:r>
-              <a:rPr lang="en-US"/>
+              <a:rPr lang="en-US" smtClean="0"/>
               <a:t>Click to edit Master text styles</a:t>
             </a:r>
           </a:p>
@@ -3199,7 +3424,7 @@
           <a:p>
             <a:fld id="{5BCAD085-E8A6-8845-BD4E-CB4CCA059FC4}" type="datetimeFigureOut">
               <a:rPr lang="en-US" smtClean="0"/>
-              <a:t>9/9/2026</a:t>
+              <a:t>1/27/13</a:t>
             </a:fld>
             <a:endParaRPr lang="en-US"/>
           </a:p>
@@ -3308,9 +3533,10 @@
           <a:lstStyle/>
           <a:p>
             <a:r>
-              <a:rPr lang="en-US"/>
+              <a:rPr lang="en-US" smtClean="0"/>
               <a:t>Click to edit Master title style</a:t>
             </a:r>
+            <a:endParaRPr lang="en-US"/>
           </a:p>
         </p:txBody>
       </p:sp>
@@ -3341,37 +3567,38 @@
           <a:p>
             <a:pPr lvl="0"/>
             <a:r>
-              <a:rPr lang="en-US"/>
+              <a:rPr lang="en-US" smtClean="0"/>
               <a:t>Click to edit Master text styles</a:t>
             </a:r>
           </a:p>
           <a:p>
             <a:pPr lvl="1"/>
             <a:r>
-              <a:rPr lang="en-US"/>
+              <a:rPr lang="en-US" smtClean="0"/>
               <a:t>Second level</a:t>
             </a:r>
           </a:p>
           <a:p>
             <a:pPr lvl="2"/>
             <a:r>
-              <a:rPr lang="en-US"/>
+              <a:rPr lang="en-US" smtClean="0"/>
               <a:t>Third level</a:t>
             </a:r>
           </a:p>
           <a:p>
             <a:pPr lvl="3"/>
             <a:r>
-              <a:rPr lang="en-US"/>
+              <a:rPr lang="en-US" smtClean="0"/>
               <a:t>Fourth level</a:t>
             </a:r>
           </a:p>
           <a:p>
             <a:pPr lvl="4"/>
             <a:r>
-              <a:rPr lang="en-US"/>
+              <a:rPr lang="en-US" smtClean="0"/>
               <a:t>Fifth level</a:t>
             </a:r>
+            <a:endParaRPr lang="en-US"/>
           </a:p>
         </p:txBody>
       </p:sp>
@@ -3410,7 +3637,7 @@
           <a:p>
             <a:fld id="{5BCAD085-E8A6-8845-BD4E-CB4CCA059FC4}" type="datetimeFigureOut">
               <a:rPr lang="en-US" smtClean="0"/>
-              <a:t>9/9/2026</a:t>
+              <a:t>1/27/13</a:t>
             </a:fld>
             <a:endParaRPr lang="en-US"/>
           </a:p>
@@ -3769,7 +3996,7 @@
 </file>
 
 <file path=ppt/slides/slide1.xml><?xml version="1.0" encoding="utf-8"?>
-<p:sld xmlns:a="http://schemas.openxmlformats.org/drawingml/2006/main" xmlns:r="http://schemas.openxmlformats.org/officeDocument/2006/relationships" xmlns:p="http://schemas.openxmlformats.org/presentationml/2006/main">
+<p:sld xmlns:a="http://schemas.openxmlformats.org/drawingml/2006/main" xmlns:p="http://schemas.openxmlformats.org/presentationml/2006/main" xmlns:r="http://schemas.openxmlformats.org/officeDocument/2006/relationships">
   <p:cSld>
     <p:spTree>
       <p:nvGrpSpPr>
@@ -3777,14 +4004,7 @@
         <p:cNvGrpSpPr/>
         <p:nvPr/>
       </p:nvGrpSpPr>
-      <p:grpSpPr>
-        <a:xfrm>
-          <a:off x="0" y="0"/>
-          <a:ext cx="0" cy="0"/>
-          <a:chOff x="0" y="0"/>
-          <a:chExt cx="0" cy="0"/>
-        </a:xfrm>
-      </p:grpSpPr>
+      <p:grpSpPr/>
       <p:sp>
         <p:nvSpPr>
           <p:cNvPr id="2" name="Rectangle 1"/>
@@ -3825,7 +4045,6 @@
           <a:lstStyle/>
           <a:p>
             <a:pPr algn="ctr"/>
-            <a:endParaRPr/>
           </a:p>
         </p:txBody>
       </p:sp>
@@ -3965,6 +4184,30 @@
           <p:nvPr/>
         </p:nvPicPr>
         <p:blipFill>
+          <a:blip r:embed="rId2"/>
+          <a:stretch>
+            <a:fillRect/>
+          </a:stretch>
+        </p:blipFill>
+        <p:spPr>
+          <a:xfrm>
+            <a:off x="3947007" y="2743200"/>
+            <a:ext cx="2011680" cy="2011680"/>
+          </a:xfrm>
+          <a:prstGeom prst="rect">
+            <a:avLst/>
+          </a:prstGeom>
+        </p:spPr>
+      </p:pic>
+      <p:pic>
+        <p:nvPicPr>
+          <p:cNvPr id="7" name="Picture 6" descr="baysec-red.png"/>
+          <p:cNvPicPr>
+            <a:picLocks noChangeAspect="1"/>
+          </p:cNvPicPr>
+          <p:nvPr/>
+        </p:nvPicPr>
+        <p:blipFill>
           <a:blip r:embed="rId3"/>
           <a:stretch>
             <a:fillRect/>
@@ -3972,7 +4215,7 @@
         </p:blipFill>
         <p:spPr>
           <a:xfrm>
-            <a:off x="3947007" y="2743200"/>
+            <a:off x="6233007" y="2743200"/>
             <a:ext cx="2011680" cy="2011680"/>
           </a:xfrm>
           <a:prstGeom prst="rect">
@@ -3980,9 +4223,90 @@
           </a:prstGeom>
         </p:spPr>
       </p:pic>
+      <p:sp>
+        <p:nvSpPr>
+          <p:cNvPr id="8" name="TextBox 7"/>
+          <p:cNvSpPr txBox="1"/>
+          <p:nvPr/>
+        </p:nvSpPr>
+        <p:spPr>
+          <a:xfrm>
+            <a:off x="2286000" y="4892040"/>
+            <a:ext cx="7619695" cy="731520"/>
+          </a:xfrm>
+          <a:prstGeom prst="rect">
+            <a:avLst/>
+          </a:prstGeom>
+          <a:noFill/>
+        </p:spPr>
+        <p:txBody>
+          <a:bodyPr wrap="square">
+            <a:spAutoFit/>
+          </a:bodyPr>
+          <a:lstStyle/>
+          <a:p>
+            <a:pPr algn="ctr">
+              <a:defRPr sz="1400">
+                <a:solidFill>
+                  <a:srgbClr val="CBD5E1"/>
+                </a:solidFill>
+                <a:latin typeface="Segoe UI"/>
+              </a:defRPr>
+            </a:pPr>
+            <a:r>
+              <a:t>Welcome! Please scan the QR codes to check in and join our active channels while we set up.</a:t>
+            </a:r>
+          </a:p>
+        </p:txBody>
+      </p:sp>
+      <p:sp>
+        <p:nvSpPr>
+          <p:cNvPr id="9" name="Rounded Rectangle 8"/>
+          <p:cNvSpPr/>
+          <p:nvPr/>
+        </p:nvSpPr>
+        <p:spPr>
+          <a:xfrm>
+            <a:off x="731520" y="4480560"/>
+            <a:ext cx="2103120" cy="2011680"/>
+          </a:xfrm>
+          <a:prstGeom prst="roundRect">
+            <a:avLst/>
+          </a:prstGeom>
+          <a:solidFill>
+            <a:srgbClr val="111827"/>
+          </a:solidFill>
+          <a:ln w="12700">
+            <a:solidFill>
+              <a:srgbClr val="00F0FF"/>
+            </a:solidFill>
+          </a:ln>
+        </p:spPr>
+        <p:style>
+          <a:lnRef idx="1">
+            <a:schemeClr val="accent1"/>
+          </a:lnRef>
+          <a:fillRef idx="3">
+            <a:schemeClr val="accent1"/>
+          </a:fillRef>
+          <a:effectRef idx="2">
+            <a:schemeClr val="accent1"/>
+          </a:effectRef>
+          <a:fontRef idx="minor">
+            <a:schemeClr val="lt1"/>
+          </a:fontRef>
+        </p:style>
+        <p:txBody>
+          <a:bodyPr rtlCol="0" anchor="ctr"/>
+          <a:lstStyle/>
+          <a:p>
+            <a:pPr algn="ctr"/>
+          </a:p>
+        </p:txBody>
+      </p:sp>
       <p:pic>
         <p:nvPicPr>
-          <p:cNvPr id="7" name="Picture 6" descr="baysec-red.png"/>
+          <p:cNvPr id="10" name="Picture 9" descr="qr_attendance.png"/>
           <p:cNvPicPr>
             <a:picLocks noChangeAspect="1"/>
           </p:cNvPicPr>
@@ -3996,8 +4320,8 @@
         </p:blipFill>
         <p:spPr>
           <a:xfrm>
-            <a:off x="6233007" y="2743200"/>
-            <a:ext cx="2011680" cy="2011680"/>
+            <a:off x="1051560" y="4617720"/>
+            <a:ext cx="1463040" cy="1463040"/>
           </a:xfrm>
           <a:prstGeom prst="rect">
             <a:avLst/>
@@ -4006,14 +4330,14 @@
       </p:pic>
       <p:sp>
         <p:nvSpPr>
-          <p:cNvPr id="8" name="TextBox 7"/>
+          <p:cNvPr id="11" name="TextBox 10"/>
           <p:cNvSpPr txBox="1"/>
           <p:nvPr/>
         </p:nvSpPr>
         <p:spPr>
           <a:xfrm>
-            <a:off x="3333174" y="4846320"/>
-            <a:ext cx="5799666" cy="523220"/>
+            <a:off x="731520" y="6080760"/>
+            <a:ext cx="2103120" cy="365760"/>
           </a:xfrm>
           <a:prstGeom prst="rect">
             <a:avLst/>
@@ -4021,35 +4345,34 @@
           <a:noFill/>
         </p:spPr>
         <p:txBody>
-          <a:bodyPr wrap="square">
+          <a:bodyPr wrap="none">
             <a:spAutoFit/>
           </a:bodyPr>
           <a:lstStyle/>
           <a:p>
             <a:pPr algn="ctr">
-              <a:defRPr sz="1400">
-                <a:solidFill>
-                  <a:srgbClr val="CBD5E1"/>
+              <a:defRPr sz="1100" b="1">
+                <a:solidFill>
+                  <a:srgbClr val="00F0FF"/>
                 </a:solidFill>
                 <a:latin typeface="Segoe UI"/>
               </a:defRPr>
             </a:pPr>
             <a:r>
-              <a:rPr dirty="0"/>
-              <a:t>Welcome! Please scan the QR codes to check in and join our active channels while we set up.</a:t>
-            </a:r>
-          </a:p>
-        </p:txBody>
-      </p:sp>
-      <p:sp>
-        <p:nvSpPr>
-          <p:cNvPr id="9" name="Rounded Rectangle 8"/>
+              <a:t>Scan for Attendance</a:t>
+            </a:r>
+          </a:p>
+        </p:txBody>
+      </p:sp>
+      <p:sp>
+        <p:nvSpPr>
+          <p:cNvPr id="12" name="Rounded Rectangle 11"/>
           <p:cNvSpPr/>
           <p:nvPr/>
         </p:nvSpPr>
         <p:spPr>
           <a:xfrm>
-            <a:off x="731520" y="4480560"/>
+            <a:off x="9357055" y="4480560"/>
             <a:ext cx="2103120" cy="2011680"/>
           </a:xfrm>
           <a:prstGeom prst="roundRect">
@@ -4060,7 +4383,7 @@
           </a:solidFill>
           <a:ln w="12700">
             <a:solidFill>
-              <a:srgbClr val="00F0FF"/>
+              <a:srgbClr val="4ADE80"/>
             </a:solidFill>
           </a:ln>
         </p:spPr>
@@ -4083,13 +4406,12 @@
           <a:lstStyle/>
           <a:p>
             <a:pPr algn="ctr"/>
-            <a:endParaRPr/>
           </a:p>
         </p:txBody>
       </p:sp>
       <p:pic>
         <p:nvPicPr>
-          <p:cNvPr id="10" name="Picture 9" descr="qr_attendance.png"/>
+          <p:cNvPr id="13" name="Picture 12" descr="qr.png"/>
           <p:cNvPicPr>
             <a:picLocks noChangeAspect="1"/>
           </p:cNvPicPr>
@@ -4103,112 +4425,6 @@
         </p:blipFill>
         <p:spPr>
           <a:xfrm>
-            <a:off x="1051560" y="4617720"/>
-            <a:ext cx="1463040" cy="1463040"/>
-          </a:xfrm>
-          <a:prstGeom prst="rect">
-            <a:avLst/>
-          </a:prstGeom>
-        </p:spPr>
-      </p:pic>
-      <p:sp>
-        <p:nvSpPr>
-          <p:cNvPr id="11" name="TextBox 10"/>
-          <p:cNvSpPr txBox="1"/>
-          <p:nvPr/>
-        </p:nvSpPr>
-        <p:spPr>
-          <a:xfrm>
-            <a:off x="731520" y="6080760"/>
-            <a:ext cx="2103120" cy="365760"/>
-          </a:xfrm>
-          <a:prstGeom prst="rect">
-            <a:avLst/>
-          </a:prstGeom>
-          <a:noFill/>
-        </p:spPr>
-        <p:txBody>
-          <a:bodyPr wrap="none">
-            <a:spAutoFit/>
-          </a:bodyPr>
-          <a:lstStyle/>
-          <a:p>
-            <a:pPr algn="ctr">
-              <a:defRPr sz="1100" b="1">
-                <a:solidFill>
-                  <a:srgbClr val="00F0FF"/>
-                </a:solidFill>
-                <a:latin typeface="Segoe UI"/>
-              </a:defRPr>
-            </a:pPr>
-            <a:r>
-              <a:t>Scan for Attendance</a:t>
-            </a:r>
-          </a:p>
-        </p:txBody>
-      </p:sp>
-      <p:sp>
-        <p:nvSpPr>
-          <p:cNvPr id="12" name="Rounded Rectangle 11"/>
-          <p:cNvSpPr/>
-          <p:nvPr/>
-        </p:nvSpPr>
-        <p:spPr>
-          <a:xfrm>
-            <a:off x="9357055" y="4480560"/>
-            <a:ext cx="2103120" cy="2011680"/>
-          </a:xfrm>
-          <a:prstGeom prst="roundRect">
-            <a:avLst/>
-          </a:prstGeom>
-          <a:solidFill>
-            <a:srgbClr val="111827"/>
-          </a:solidFill>
-          <a:ln w="12700">
-            <a:solidFill>
-              <a:srgbClr val="4ADE80"/>
-            </a:solidFill>
-          </a:ln>
-        </p:spPr>
-        <p:style>
-          <a:lnRef idx="1">
-            <a:schemeClr val="accent1"/>
-          </a:lnRef>
-          <a:fillRef idx="3">
-            <a:schemeClr val="accent1"/>
-          </a:fillRef>
-          <a:effectRef idx="2">
-            <a:schemeClr val="accent1"/>
-          </a:effectRef>
-          <a:fontRef idx="minor">
-            <a:schemeClr val="lt1"/>
-          </a:fontRef>
-        </p:style>
-        <p:txBody>
-          <a:bodyPr rtlCol="0" anchor="ctr"/>
-          <a:lstStyle/>
-          <a:p>
-            <a:pPr algn="ctr"/>
-            <a:endParaRPr/>
-          </a:p>
-        </p:txBody>
-      </p:sp>
-      <p:pic>
-        <p:nvPicPr>
-          <p:cNvPr id="13" name="Picture 12" descr="qr.png"/>
-          <p:cNvPicPr>
-            <a:picLocks noChangeAspect="1"/>
-          </p:cNvPicPr>
-          <p:nvPr/>
-        </p:nvPicPr>
-        <p:blipFill>
-          <a:blip r:embed="rId6"/>
-          <a:stretch>
-            <a:fillRect/>
-          </a:stretch>
-        </p:blipFill>
-        <p:spPr>
-          <a:xfrm>
             <a:off x="9677095" y="4617720"/>
             <a:ext cx="1463040" cy="1463040"/>
           </a:xfrm>
@@ -4262,7 +4478,7 @@
 </file>
 
 <file path=ppt/slides/slide2.xml><?xml version="1.0" encoding="utf-8"?>
-<p:sld xmlns:a="http://schemas.openxmlformats.org/drawingml/2006/main" xmlns:r="http://schemas.openxmlformats.org/officeDocument/2006/relationships" xmlns:p="http://schemas.openxmlformats.org/presentationml/2006/main">
+<p:sld xmlns:a="http://schemas.openxmlformats.org/drawingml/2006/main" xmlns:p="http://schemas.openxmlformats.org/presentationml/2006/main" xmlns:r="http://schemas.openxmlformats.org/officeDocument/2006/relationships">
   <p:cSld>
     <p:spTree>
       <p:nvGrpSpPr>
@@ -4270,14 +4486,7 @@
         <p:cNvGrpSpPr/>
         <p:nvPr/>
       </p:nvGrpSpPr>
-      <p:grpSpPr>
-        <a:xfrm>
-          <a:off x="0" y="0"/>
-          <a:ext cx="0" cy="0"/>
-          <a:chOff x="0" y="0"/>
-          <a:chExt cx="0" cy="0"/>
-        </a:xfrm>
-      </p:grpSpPr>
+      <p:grpSpPr/>
       <p:sp>
         <p:nvSpPr>
           <p:cNvPr id="2" name="Rectangle 1"/>
@@ -4318,7 +4527,6 @@
           <a:lstStyle/>
           <a:p>
             <a:pPr algn="ctr"/>
-            <a:endParaRPr/>
           </a:p>
         </p:txBody>
       </p:sp>
@@ -4451,7 +4659,7 @@
           </a:fontRef>
         </p:style>
         <p:txBody>
-          <a:bodyPr wrap="square" lIns="365760" tIns="365760" rIns="365760" rtlCol="0" anchor="ctr"/>
+          <a:bodyPr rtlCol="0" anchor="ctr" wrap="square" lIns="365760" rIns="365760" tIns="365760"/>
           <a:lstStyle/>
           <a:p>
             <a:pPr algn="ctr">
@@ -4596,7 +4804,7 @@
           </a:fontRef>
         </p:style>
         <p:txBody>
-          <a:bodyPr wrap="square" lIns="365760" tIns="365760" rIns="365760" rtlCol="0" anchor="ctr"/>
+          <a:bodyPr rtlCol="0" anchor="ctr" wrap="square" lIns="365760" rIns="365760" tIns="365760"/>
           <a:lstStyle/>
           <a:p>
             <a:pPr algn="ctr">
@@ -4738,7 +4946,7 @@
 </file>
 
 <file path=ppt/slides/slide3.xml><?xml version="1.0" encoding="utf-8"?>
-<p:sld xmlns:a="http://schemas.openxmlformats.org/drawingml/2006/main" xmlns:r="http://schemas.openxmlformats.org/officeDocument/2006/relationships" xmlns:p="http://schemas.openxmlformats.org/presentationml/2006/main">
+<p:sld xmlns:a="http://schemas.openxmlformats.org/drawingml/2006/main" xmlns:p="http://schemas.openxmlformats.org/presentationml/2006/main" xmlns:r="http://schemas.openxmlformats.org/officeDocument/2006/relationships">
   <p:cSld>
     <p:spTree>
       <p:nvGrpSpPr>
@@ -4746,14 +4954,7 @@
         <p:cNvGrpSpPr/>
         <p:nvPr/>
       </p:nvGrpSpPr>
-      <p:grpSpPr>
-        <a:xfrm>
-          <a:off x="0" y="0"/>
-          <a:ext cx="0" cy="0"/>
-          <a:chOff x="0" y="0"/>
-          <a:chExt cx="0" cy="0"/>
-        </a:xfrm>
-      </p:grpSpPr>
+      <p:grpSpPr/>
       <p:sp>
         <p:nvSpPr>
           <p:cNvPr id="2" name="Rectangle 1"/>
@@ -4794,7 +4995,6 @@
           <a:lstStyle/>
           <a:p>
             <a:pPr algn="ctr"/>
-            <a:endParaRPr/>
           </a:p>
         </p:txBody>
       </p:sp>
@@ -4927,7 +5127,7 @@
           </a:fontRef>
         </p:style>
         <p:txBody>
-          <a:bodyPr wrap="square" lIns="274320" tIns="320040" rIns="274320" rtlCol="0" anchor="ctr"/>
+          <a:bodyPr rtlCol="0" anchor="ctr" wrap="square" lIns="274320" rIns="274320" tIns="320040"/>
           <a:lstStyle/>
           <a:p>
             <a:pPr algn="ctr">
@@ -5062,7 +5262,7 @@
           </a:fontRef>
         </p:style>
         <p:txBody>
-          <a:bodyPr wrap="square" lIns="274320" tIns="320040" rIns="274320" rtlCol="0" anchor="ctr"/>
+          <a:bodyPr rtlCol="0" anchor="ctr" wrap="square" lIns="274320" rIns="274320" tIns="320040"/>
           <a:lstStyle/>
           <a:p>
             <a:pPr algn="ctr">
@@ -5197,7 +5397,7 @@
           </a:fontRef>
         </p:style>
         <p:txBody>
-          <a:bodyPr wrap="square" lIns="274320" tIns="320040" rIns="274320" rtlCol="0" anchor="ctr"/>
+          <a:bodyPr rtlCol="0" anchor="ctr" wrap="square" lIns="274320" rIns="274320" tIns="320040"/>
           <a:lstStyle/>
           <a:p>
             <a:pPr algn="ctr">
@@ -5358,7 +5558,7 @@
 </file>
 
 <file path=ppt/slides/slide4.xml><?xml version="1.0" encoding="utf-8"?>
-<p:sld xmlns:a="http://schemas.openxmlformats.org/drawingml/2006/main" xmlns:r="http://schemas.openxmlformats.org/officeDocument/2006/relationships" xmlns:p="http://schemas.openxmlformats.org/presentationml/2006/main">
+<p:sld xmlns:a="http://schemas.openxmlformats.org/drawingml/2006/main" xmlns:p="http://schemas.openxmlformats.org/presentationml/2006/main" xmlns:r="http://schemas.openxmlformats.org/officeDocument/2006/relationships">
   <p:cSld>
     <p:spTree>
       <p:nvGrpSpPr>
@@ -5366,14 +5566,7 @@
         <p:cNvGrpSpPr/>
         <p:nvPr/>
       </p:nvGrpSpPr>
-      <p:grpSpPr>
-        <a:xfrm>
-          <a:off x="0" y="0"/>
-          <a:ext cx="0" cy="0"/>
-          <a:chOff x="0" y="0"/>
-          <a:chExt cx="0" cy="0"/>
-        </a:xfrm>
-      </p:grpSpPr>
+      <p:grpSpPr/>
       <p:sp>
         <p:nvSpPr>
           <p:cNvPr id="2" name="Rectangle 1"/>
@@ -5414,7 +5607,6 @@
           <a:lstStyle/>
           <a:p>
             <a:pPr algn="ctr"/>
-            <a:endParaRPr/>
           </a:p>
         </p:txBody>
       </p:sp>
@@ -5547,7 +5739,7 @@
           </a:fontRef>
         </p:style>
         <p:txBody>
-          <a:bodyPr wrap="square" lIns="320040" tIns="365760" rIns="320040" rtlCol="0" anchor="ctr"/>
+          <a:bodyPr rtlCol="0" anchor="ctr" wrap="square" lIns="320040" rIns="320040" tIns="365760"/>
           <a:lstStyle/>
           <a:p>
             <a:pPr algn="ctr">
@@ -5637,7 +5829,7 @@
           </a:fontRef>
         </p:style>
         <p:txBody>
-          <a:bodyPr wrap="square" lIns="320040" tIns="365760" rIns="320040" rtlCol="0" anchor="ctr"/>
+          <a:bodyPr rtlCol="0" anchor="ctr" wrap="square" lIns="320040" rIns="320040" tIns="365760"/>
           <a:lstStyle/>
           <a:p>
             <a:pPr algn="ctr">
@@ -5727,7 +5919,7 @@
           </a:fontRef>
         </p:style>
         <p:txBody>
-          <a:bodyPr wrap="square" lIns="320040" tIns="365760" rIns="320040" rtlCol="0" anchor="ctr"/>
+          <a:bodyPr rtlCol="0" anchor="ctr" wrap="square" lIns="320040" rIns="320040" tIns="365760"/>
           <a:lstStyle/>
           <a:p>
             <a:pPr algn="ctr">
@@ -5788,7 +5980,7 @@
 </file>
 
 <file path=ppt/slides/slide5.xml><?xml version="1.0" encoding="utf-8"?>
-<p:sld xmlns:a="http://schemas.openxmlformats.org/drawingml/2006/main" xmlns:r="http://schemas.openxmlformats.org/officeDocument/2006/relationships" xmlns:p="http://schemas.openxmlformats.org/presentationml/2006/main">
+<p:sld xmlns:a="http://schemas.openxmlformats.org/drawingml/2006/main" xmlns:p="http://schemas.openxmlformats.org/presentationml/2006/main" xmlns:r="http://schemas.openxmlformats.org/officeDocument/2006/relationships">
   <p:cSld>
     <p:spTree>
       <p:nvGrpSpPr>
@@ -5796,14 +5988,7 @@
         <p:cNvGrpSpPr/>
         <p:nvPr/>
       </p:nvGrpSpPr>
-      <p:grpSpPr>
-        <a:xfrm>
-          <a:off x="0" y="0"/>
-          <a:ext cx="0" cy="0"/>
-          <a:chOff x="0" y="0"/>
-          <a:chExt cx="0" cy="0"/>
-        </a:xfrm>
-      </p:grpSpPr>
+      <p:grpSpPr/>
       <p:sp>
         <p:nvSpPr>
           <p:cNvPr id="2" name="Rectangle 1"/>
@@ -5844,7 +6029,6 @@
           <a:lstStyle/>
           <a:p>
             <a:pPr algn="ctr"/>
-            <a:endParaRPr/>
           </a:p>
         </p:txBody>
       </p:sp>
@@ -6013,7 +6197,7 @@
           </a:fontRef>
         </p:style>
         <p:txBody>
-          <a:bodyPr wrap="square" lIns="274320" tIns="320040" rIns="274320" rtlCol="0" anchor="ctr"/>
+          <a:bodyPr rtlCol="0" anchor="ctr" wrap="square" lIns="274320" rIns="274320" tIns="320040"/>
           <a:lstStyle/>
           <a:p>
             <a:pPr algn="ctr">
@@ -6100,7 +6284,7 @@
           </a:fontRef>
         </p:style>
         <p:txBody>
-          <a:bodyPr wrap="square" lIns="274320" tIns="320040" rIns="274320" rtlCol="0" anchor="ctr"/>
+          <a:bodyPr rtlCol="0" anchor="ctr" wrap="square" lIns="274320" rIns="274320" tIns="320040"/>
           <a:lstStyle/>
           <a:p>
             <a:pPr algn="ctr">
@@ -6187,7 +6371,7 @@
           </a:fontRef>
         </p:style>
         <p:txBody>
-          <a:bodyPr wrap="square" lIns="274320" tIns="320040" rIns="274320" rtlCol="0" anchor="ctr"/>
+          <a:bodyPr rtlCol="0" anchor="ctr" wrap="square" lIns="274320" rIns="274320" tIns="320040"/>
           <a:lstStyle/>
           <a:p>
             <a:pPr algn="ctr">
@@ -6300,7 +6484,7 @@
 </file>
 
 <file path=ppt/slides/slide6.xml><?xml version="1.0" encoding="utf-8"?>
-<p:sld xmlns:a="http://schemas.openxmlformats.org/drawingml/2006/main" xmlns:r="http://schemas.openxmlformats.org/officeDocument/2006/relationships" xmlns:p="http://schemas.openxmlformats.org/presentationml/2006/main">
+<p:sld xmlns:a="http://schemas.openxmlformats.org/drawingml/2006/main" xmlns:p="http://schemas.openxmlformats.org/presentationml/2006/main" xmlns:r="http://schemas.openxmlformats.org/officeDocument/2006/relationships">
   <p:cSld>
     <p:spTree>
       <p:nvGrpSpPr>
@@ -6308,14 +6492,7 @@
         <p:cNvGrpSpPr/>
         <p:nvPr/>
       </p:nvGrpSpPr>
-      <p:grpSpPr>
-        <a:xfrm>
-          <a:off x="0" y="0"/>
-          <a:ext cx="0" cy="0"/>
-          <a:chOff x="0" y="0"/>
-          <a:chExt cx="0" cy="0"/>
-        </a:xfrm>
-      </p:grpSpPr>
+      <p:grpSpPr/>
       <p:sp>
         <p:nvSpPr>
           <p:cNvPr id="2" name="Rectangle 1"/>
@@ -6356,7 +6533,6 @@
           <a:lstStyle/>
           <a:p>
             <a:pPr algn="ctr"/>
-            <a:endParaRPr/>
           </a:p>
         </p:txBody>
       </p:sp>
@@ -6489,7 +6665,7 @@
           </a:fontRef>
         </p:style>
         <p:txBody>
-          <a:bodyPr wrap="square" lIns="411480" tIns="320040" rIns="411480" rtlCol="0" anchor="ctr"/>
+          <a:bodyPr rtlCol="0" anchor="ctr" wrap="square" lIns="411480" rIns="411480" tIns="320040"/>
           <a:lstStyle/>
           <a:p>
             <a:pPr algn="ctr">
@@ -6644,7 +6820,6 @@
           <a:lstStyle/>
           <a:p>
             <a:pPr algn="ctr"/>
-            <a:endParaRPr/>
           </a:p>
         </p:txBody>
       </p:sp>
@@ -6725,7 +6900,7 @@
           <p:nvPr/>
         </p:nvPicPr>
         <p:blipFill>
-          <a:blip r:embed="rId3"/>
+          <a:blip r:embed="rId2"/>
           <a:stretch>
             <a:fillRect/>
           </a:stretch>
@@ -6784,7 +6959,7 @@
               </a:defRPr>
             </a:pPr>
             <a:r>
-              <a:t>or visit tinyurl.com/baysec-portal</a:t>
+              <a:t>or visit tinyurl.com/baysec-week4</a:t>
             </a:r>
           </a:p>
         </p:txBody>
@@ -6798,7 +6973,7 @@
 </file>
 
 <file path=ppt/slides/slide7.xml><?xml version="1.0" encoding="utf-8"?>
-<p:sld xmlns:a="http://schemas.openxmlformats.org/drawingml/2006/main" xmlns:r="http://schemas.openxmlformats.org/officeDocument/2006/relationships" xmlns:p="http://schemas.openxmlformats.org/presentationml/2006/main">
+<p:sld xmlns:a="http://schemas.openxmlformats.org/drawingml/2006/main" xmlns:p="http://schemas.openxmlformats.org/presentationml/2006/main" xmlns:r="http://schemas.openxmlformats.org/officeDocument/2006/relationships">
   <p:cSld>
     <p:spTree>
       <p:nvGrpSpPr>
@@ -6806,14 +6981,7 @@
         <p:cNvGrpSpPr/>
         <p:nvPr/>
       </p:nvGrpSpPr>
-      <p:grpSpPr>
-        <a:xfrm>
-          <a:off x="0" y="0"/>
-          <a:ext cx="0" cy="0"/>
-          <a:chOff x="0" y="0"/>
-          <a:chExt cx="0" cy="0"/>
-        </a:xfrm>
-      </p:grpSpPr>
+      <p:grpSpPr/>
       <p:sp>
         <p:nvSpPr>
           <p:cNvPr id="2" name="Rectangle 1"/>
@@ -6854,7 +7022,6 @@
           <a:lstStyle/>
           <a:p>
             <a:pPr algn="ctr"/>
-            <a:endParaRPr/>
           </a:p>
         </p:txBody>
       </p:sp>
@@ -6987,7 +7154,7 @@
           </a:fontRef>
         </p:style>
         <p:txBody>
-          <a:bodyPr wrap="square" lIns="365760" tIns="320040" rIns="365760" rtlCol="0" anchor="ctr"/>
+          <a:bodyPr rtlCol="0" anchor="ctr" wrap="square" lIns="365760" rIns="365760" tIns="320040"/>
           <a:lstStyle/>
           <a:p>
             <a:pPr algn="ctr">
@@ -7110,7 +7277,7 @@
           </a:fontRef>
         </p:style>
         <p:txBody>
-          <a:bodyPr wrap="square" lIns="365760" tIns="320040" rIns="365760" rtlCol="0" anchor="ctr"/>
+          <a:bodyPr rtlCol="0" anchor="ctr" wrap="square" lIns="365760" rIns="365760" tIns="320040"/>
           <a:lstStyle/>
           <a:p>
             <a:pPr algn="ctr">
@@ -7278,7 +7445,7 @@
 </file>
 
 <file path=ppt/slides/slide8.xml><?xml version="1.0" encoding="utf-8"?>
-<p:sld xmlns:a="http://schemas.openxmlformats.org/drawingml/2006/main" xmlns:r="http://schemas.openxmlformats.org/officeDocument/2006/relationships" xmlns:p="http://schemas.openxmlformats.org/presentationml/2006/main">
+<p:sld xmlns:a="http://schemas.openxmlformats.org/drawingml/2006/main" xmlns:p="http://schemas.openxmlformats.org/presentationml/2006/main" xmlns:r="http://schemas.openxmlformats.org/officeDocument/2006/relationships">
   <p:cSld>
     <p:spTree>
       <p:nvGrpSpPr>
@@ -7286,14 +7453,7 @@
         <p:cNvGrpSpPr/>
         <p:nvPr/>
       </p:nvGrpSpPr>
-      <p:grpSpPr>
-        <a:xfrm>
-          <a:off x="0" y="0"/>
-          <a:ext cx="0" cy="0"/>
-          <a:chOff x="0" y="0"/>
-          <a:chExt cx="0" cy="0"/>
-        </a:xfrm>
-      </p:grpSpPr>
+      <p:grpSpPr/>
       <p:sp>
         <p:nvSpPr>
           <p:cNvPr id="2" name="Rectangle 1"/>
@@ -7334,7 +7494,6 @@
           <a:lstStyle/>
           <a:p>
             <a:pPr algn="ctr"/>
-            <a:endParaRPr/>
           </a:p>
         </p:txBody>
       </p:sp>
@@ -7467,7 +7626,7 @@
           </a:fontRef>
         </p:style>
         <p:txBody>
-          <a:bodyPr wrap="square" lIns="365760" tIns="320040" rIns="365760" rtlCol="0" anchor="ctr"/>
+          <a:bodyPr rtlCol="0" anchor="ctr" wrap="square" lIns="365760" rIns="365760" tIns="320040"/>
           <a:lstStyle/>
           <a:p>
             <a:pPr algn="ctr">
@@ -7638,7 +7797,7 @@
           </a:fontRef>
         </p:style>
         <p:txBody>
-          <a:bodyPr wrap="square" tIns="320040" rtlCol="0" anchor="ctr"/>
+          <a:bodyPr rtlCol="0" anchor="ctr" wrap="square" tIns="320040"/>
           <a:lstStyle/>
           <a:p>
             <a:pPr algn="ctr">
@@ -7664,7 +7823,7 @@
           <p:nvPr/>
         </p:nvPicPr>
         <p:blipFill>
-          <a:blip r:embed="rId3"/>
+          <a:blip r:embed="rId2"/>
           <a:stretch>
             <a:fillRect/>
           </a:stretch>
@@ -8067,44 +8226,44 @@
         <a:sysClr val="window" lastClr="FFFFFF"/>
       </a:lt1>
       <a:dk2>
-        <a:srgbClr val="0E2841"/>
+        <a:srgbClr val="1F497D"/>
       </a:dk2>
       <a:lt2>
-        <a:srgbClr val="E8E8E8"/>
+        <a:srgbClr val="EEECE1"/>
       </a:lt2>
       <a:accent1>
-        <a:srgbClr val="156082"/>
+        <a:srgbClr val="4F81BD"/>
       </a:accent1>
       <a:accent2>
-        <a:srgbClr val="E97132"/>
+        <a:srgbClr val="C0504D"/>
       </a:accent2>
       <a:accent3>
-        <a:srgbClr val="196B24"/>
+        <a:srgbClr val="9BBB59"/>
       </a:accent3>
       <a:accent4>
-        <a:srgbClr val="0F9ED5"/>
+        <a:srgbClr val="8064A2"/>
       </a:accent4>
       <a:accent5>
-        <a:srgbClr val="A02B93"/>
+        <a:srgbClr val="4BACC6"/>
       </a:accent5>
       <a:accent6>
-        <a:srgbClr val="4EA72E"/>
+        <a:srgbClr val="F79646"/>
       </a:accent6>
       <a:hlink>
-        <a:srgbClr val="467886"/>
+        <a:srgbClr val="0000FF"/>
       </a:hlink>
       <a:folHlink>
-        <a:srgbClr val="96607D"/>
+        <a:srgbClr val="800080"/>
       </a:folHlink>
     </a:clrScheme>
     <a:fontScheme name="Office">
       <a:majorFont>
-        <a:latin typeface="Aptos Display" panose="02110004020202020204"/>
+        <a:latin typeface="Calibri"/>
         <a:ea typeface=""/>
         <a:cs typeface=""/>
-        <a:font script="Jpan" typeface="游ゴシック Light"/>
+        <a:font script="Jpan" typeface="ＭＳ Ｐゴシック"/>
         <a:font script="Hang" typeface="맑은 고딕"/>
-        <a:font script="Hans" typeface="等线 Light"/>
+        <a:font script="Hans" typeface="宋体"/>
         <a:font script="Hant" typeface="新細明體"/>
         <a:font script="Arab" typeface="Times New Roman"/>
         <a:font script="Hebr" typeface="Times New Roman"/>
@@ -8132,31 +8291,14 @@
         <a:font script="Viet" typeface="Times New Roman"/>
         <a:font script="Uigh" typeface="Microsoft Uighur"/>
         <a:font script="Geor" typeface="Sylfaen"/>
-        <a:font script="Armn" typeface="Arial"/>
-        <a:font script="Bugi" typeface="Leelawadee UI"/>
-        <a:font script="Bopo" typeface="Microsoft JhengHei"/>
-        <a:font script="Java" typeface="Javanese Text"/>
-        <a:font script="Lisu" typeface="Segoe UI"/>
-        <a:font script="Mymr" typeface="Myanmar Text"/>
-        <a:font script="Nkoo" typeface="Ebrima"/>
-        <a:font script="Olck" typeface="Nirmala UI"/>
-        <a:font script="Osma" typeface="Ebrima"/>
-        <a:font script="Phag" typeface="Phagspa"/>
-        <a:font script="Syrn" typeface="Estrangelo Edessa"/>
-        <a:font script="Syrj" typeface="Estrangelo Edessa"/>
-        <a:font script="Syre" typeface="Estrangelo Edessa"/>
-        <a:font script="Sora" typeface="Nirmala UI"/>
-        <a:font script="Tale" typeface="Microsoft Tai Le"/>
-        <a:font script="Talu" typeface="Microsoft New Tai Lue"/>
-        <a:font script="Tfng" typeface="Ebrima"/>
       </a:majorFont>
       <a:minorFont>
-        <a:latin typeface="Aptos" panose="02110004020202020204"/>
+        <a:latin typeface="Calibri"/>
         <a:ea typeface=""/>
         <a:cs typeface=""/>
-        <a:font script="Jpan" typeface="游ゴシック"/>
+        <a:font script="Jpan" typeface="ＭＳ Ｐゴシック"/>
         <a:font script="Hang" typeface="맑은 고딕"/>
-        <a:font script="Hans" typeface="等线"/>
+        <a:font script="Hans" typeface="宋体"/>
         <a:font script="Hant" typeface="新細明體"/>
         <a:font script="Arab" typeface="Arial"/>
         <a:font script="Hebr" typeface="Arial"/>
@@ -8184,23 +8326,6 @@
         <a:font script="Viet" typeface="Arial"/>
         <a:font script="Uigh" typeface="Microsoft Uighur"/>
         <a:font script="Geor" typeface="Sylfaen"/>
-        <a:font script="Armn" typeface="Arial"/>
-        <a:font script="Bugi" typeface="Leelawadee UI"/>
-        <a:font script="Bopo" typeface="Microsoft JhengHei"/>
-        <a:font script="Java" typeface="Javanese Text"/>
-        <a:font script="Lisu" typeface="Segoe UI"/>
-        <a:font script="Mymr" typeface="Myanmar Text"/>
-        <a:font script="Nkoo" typeface="Ebrima"/>
-        <a:font script="Olck" typeface="Nirmala UI"/>
-        <a:font script="Osma" typeface="Ebrima"/>
-        <a:font script="Phag" typeface="Phagspa"/>
-        <a:font script="Syrn" typeface="Estrangelo Edessa"/>
-        <a:font script="Syrj" typeface="Estrangelo Edessa"/>
-        <a:font script="Syre" typeface="Estrangelo Edessa"/>
-        <a:font script="Sora" typeface="Nirmala UI"/>
-        <a:font script="Tale" typeface="Microsoft Tai Le"/>
-        <a:font script="Talu" typeface="Microsoft New Tai Lue"/>
-        <a:font script="Tfng" typeface="Ebrima"/>
       </a:minorFont>
     </a:fontScheme>
     <a:fmtScheme name="Office">
@@ -8212,136 +8337,180 @@
           <a:gsLst>
             <a:gs pos="0">
               <a:schemeClr val="phClr">
-                <a:lumMod val="110000"/>
-                <a:satMod val="105000"/>
-                <a:tint val="67000"/>
+                <a:tint val="50000"/>
+                <a:satMod val="300000"/>
               </a:schemeClr>
             </a:gs>
-            <a:gs pos="50000">
+            <a:gs pos="35000">
               <a:schemeClr val="phClr">
-                <a:lumMod val="105000"/>
-                <a:satMod val="103000"/>
-                <a:tint val="73000"/>
+                <a:tint val="37000"/>
+                <a:satMod val="300000"/>
               </a:schemeClr>
             </a:gs>
             <a:gs pos="100000">
               <a:schemeClr val="phClr">
-                <a:lumMod val="105000"/>
-                <a:satMod val="109000"/>
-                <a:tint val="81000"/>
+                <a:tint val="15000"/>
+                <a:satMod val="350000"/>
               </a:schemeClr>
             </a:gs>
           </a:gsLst>
-          <a:lin ang="5400000" scaled="0"/>
+          <a:lin ang="16200000" scaled="1"/>
         </a:gradFill>
         <a:gradFill rotWithShape="1">
           <a:gsLst>
             <a:gs pos="0">
               <a:schemeClr val="phClr">
-                <a:satMod val="103000"/>
-                <a:lumMod val="102000"/>
-                <a:tint val="94000"/>
-              </a:schemeClr>
-            </a:gs>
-            <a:gs pos="50000">
-              <a:schemeClr val="phClr">
-                <a:satMod val="110000"/>
-                <a:lumMod val="100000"/>
+                <a:tint val="100000"/>
                 <a:shade val="100000"/>
+                <a:satMod val="130000"/>
               </a:schemeClr>
             </a:gs>
             <a:gs pos="100000">
               <a:schemeClr val="phClr">
-                <a:lumMod val="99000"/>
-                <a:satMod val="120000"/>
-                <a:shade val="78000"/>
+                <a:tint val="50000"/>
+                <a:shade val="100000"/>
+                <a:satMod val="350000"/>
               </a:schemeClr>
             </a:gs>
           </a:gsLst>
-          <a:lin ang="5400000" scaled="0"/>
+          <a:lin ang="16200000" scaled="0"/>
         </a:gradFill>
       </a:fillStyleLst>
       <a:lnStyleLst>
-        <a:ln w="12700" cap="flat" cmpd="sng" algn="ctr">
+        <a:ln w="9525" cap="flat" cmpd="sng" algn="ctr">
           <a:solidFill>
-            <a:schemeClr val="phClr"/>
+            <a:schemeClr val="phClr">
+              <a:shade val="95000"/>
+              <a:satMod val="105000"/>
+            </a:schemeClr>
           </a:solidFill>
           <a:prstDash val="solid"/>
-          <a:miter lim="800000"/>
-        </a:ln>
-        <a:ln w="19050" cap="flat" cmpd="sng" algn="ctr">
-          <a:solidFill>
-            <a:schemeClr val="phClr"/>
-          </a:solidFill>
-          <a:prstDash val="solid"/>
-          <a:miter lim="800000"/>
         </a:ln>
         <a:ln w="25400" cap="flat" cmpd="sng" algn="ctr">
           <a:solidFill>
             <a:schemeClr val="phClr"/>
           </a:solidFill>
           <a:prstDash val="solid"/>
-          <a:miter lim="800000"/>
+        </a:ln>
+        <a:ln w="38100" cap="flat" cmpd="sng" algn="ctr">
+          <a:solidFill>
+            <a:schemeClr val="phClr"/>
+          </a:solidFill>
+          <a:prstDash val="solid"/>
         </a:ln>
       </a:lnStyleLst>
       <a:effectStyleLst>
         <a:effectStyle>
-          <a:effectLst/>
-        </a:effectStyle>
-        <a:effectStyle>
-          <a:effectLst/>
+          <a:effectLst>
+            <a:outerShdw blurRad="40000" dist="20000" dir="5400000" rotWithShape="0">
+              <a:srgbClr val="000000">
+                <a:alpha val="38000"/>
+              </a:srgbClr>
+            </a:outerShdw>
+          </a:effectLst>
         </a:effectStyle>
         <a:effectStyle>
           <a:effectLst>
-            <a:outerShdw blurRad="57150" dist="19050" dir="5400000" algn="ctr" rotWithShape="0">
+            <a:outerShdw blurRad="40000" dist="23000" dir="5400000" rotWithShape="0">
               <a:srgbClr val="000000">
-                <a:alpha val="63000"/>
+                <a:alpha val="35000"/>
               </a:srgbClr>
             </a:outerShdw>
           </a:effectLst>
+        </a:effectStyle>
+        <a:effectStyle>
+          <a:effectLst>
+            <a:outerShdw blurRad="40000" dist="23000" dir="5400000" rotWithShape="0">
+              <a:srgbClr val="000000">
+                <a:alpha val="35000"/>
+              </a:srgbClr>
+            </a:outerShdw>
+          </a:effectLst>
+          <a:scene3d>
+            <a:camera prst="orthographicFront">
+              <a:rot lat="0" lon="0" rev="0"/>
+            </a:camera>
+            <a:lightRig rig="threePt" dir="t">
+              <a:rot lat="0" lon="0" rev="1200000"/>
+            </a:lightRig>
+          </a:scene3d>
+          <a:sp3d>
+            <a:bevelT w="63500" h="25400"/>
+          </a:sp3d>
         </a:effectStyle>
       </a:effectStyleLst>
       <a:bgFillStyleLst>
         <a:solidFill>
           <a:schemeClr val="phClr"/>
         </a:solidFill>
-        <a:solidFill>
-          <a:schemeClr val="phClr">
-            <a:tint val="95000"/>
-            <a:satMod val="170000"/>
-          </a:schemeClr>
-        </a:solidFill>
         <a:gradFill rotWithShape="1">
           <a:gsLst>
             <a:gs pos="0">
               <a:schemeClr val="phClr">
-                <a:tint val="93000"/>
-                <a:satMod val="150000"/>
-                <a:shade val="98000"/>
-                <a:lumMod val="102000"/>
+                <a:tint val="40000"/>
+                <a:satMod val="350000"/>
               </a:schemeClr>
             </a:gs>
-            <a:gs pos="50000">
+            <a:gs pos="40000">
               <a:schemeClr val="phClr">
-                <a:tint val="98000"/>
-                <a:satMod val="130000"/>
-                <a:shade val="90000"/>
-                <a:lumMod val="103000"/>
+                <a:tint val="45000"/>
+                <a:shade val="99000"/>
+                <a:satMod val="350000"/>
               </a:schemeClr>
             </a:gs>
             <a:gs pos="100000">
               <a:schemeClr val="phClr">
-                <a:shade val="63000"/>
-                <a:satMod val="120000"/>
+                <a:shade val="20000"/>
+                <a:satMod val="255000"/>
               </a:schemeClr>
             </a:gs>
           </a:gsLst>
-          <a:lin ang="5400000" scaled="0"/>
+          <a:path path="circle">
+            <a:fillToRect l="50000" t="-80000" r="50000" b="180000"/>
+          </a:path>
+        </a:gradFill>
+        <a:gradFill rotWithShape="1">
+          <a:gsLst>
+            <a:gs pos="0">
+              <a:schemeClr val="phClr">
+                <a:tint val="80000"/>
+                <a:satMod val="300000"/>
+              </a:schemeClr>
+            </a:gs>
+            <a:gs pos="100000">
+              <a:schemeClr val="phClr">
+                <a:shade val="30000"/>
+                <a:satMod val="200000"/>
+              </a:schemeClr>
+            </a:gs>
+          </a:gsLst>
+          <a:path path="circle">
+            <a:fillToRect l="50000" t="50000" r="50000" b="50000"/>
+          </a:path>
         </a:gradFill>
       </a:bgFillStyleLst>
     </a:fmtScheme>
   </a:themeElements>
   <a:objectDefaults>
+    <a:spDef>
+      <a:spPr/>
+      <a:bodyPr/>
+      <a:lstStyle/>
+      <a:style>
+        <a:lnRef idx="1">
+          <a:schemeClr val="accent1"/>
+        </a:lnRef>
+        <a:fillRef idx="3">
+          <a:schemeClr val="accent1"/>
+        </a:fillRef>
+        <a:effectRef idx="2">
+          <a:schemeClr val="accent1"/>
+        </a:effectRef>
+        <a:fontRef idx="minor">
+          <a:schemeClr val="lt1"/>
+        </a:fontRef>
+      </a:style>
+    </a:spDef>
     <a:lnDef>
       <a:spPr/>
       <a:bodyPr/>
@@ -8363,10 +8532,5 @@
     </a:lnDef>
   </a:objectDefaults>
   <a:extraClrSchemeLst/>
-  <a:extLst>
-    <a:ext uri="{05A4C25C-085E-4340-85A3-A5531E510DB2}">
-      <thm15:themeFamily xmlns:thm15="http://schemas.microsoft.com/office/thememl/2012/main" name="Office Theme" id="{2E142A2C-CD16-42D6-873A-C26D2A0506FA}" vid="{1BDDFF52-6CD6-40A5-AB3C-68EB2F1E4D0A}"/>
-    </a:ext>
-  </a:extLst>
 </a:theme>
 </file>
</xml_diff>

<commit_message>
Postpone challenge solution slides to subsequent week debriefs (Week 4 solution in Week 5, Week 5 solution in Week 6)
</commit_message>
<xml_diff>
--- a/week4/BaySec_Week4_Kickoff.pptx
+++ b/week4/BaySec_Week4_Kickoff.pptx
@@ -929,7 +929,7 @@
           <a:lstStyle/>
           <a:p>
             <a:r>
-              <a:t>Great job to everyone who caught that! The core flaw here is trusting the client side. If it ships to the user's browser—even inside an HTML comment—it’s public knowledge. Base64 is encoding, not encryption.</a:t>
+              <a:t>If you solved Challenge 0x01, submit your token on the portal to secure your 100 points! If you haven't cracked it yet, you have all week until our next meeting. We will reveal and walk through the complete step-by-step solution at the start of Week 5.</a:t>
             </a:r>
           </a:p>
         </p:txBody>
@@ -7075,7 +7075,7 @@
               </a:defRPr>
             </a:pPr>
             <a:r>
-              <a:t>DEBRIEF &amp; WALKTHROUGH</a:t>
+              <a:t>LEAGUE COMPETITION</a:t>
             </a:r>
           </a:p>
         </p:txBody>
@@ -7111,7 +7111,7 @@
               </a:defRPr>
             </a:pPr>
             <a:r>
-              <a:t>0x01 Solution: Client-Side Exposure</a:t>
+              <a:t>Challenge 0x01: Rules &amp; Submission</a:t>
             </a:r>
           </a:p>
         </p:txBody>
@@ -7166,15 +7166,31 @@
               </a:defRPr>
             </a:pPr>
             <a:r>
-              <a:t>STEP 1: INSPECT THE DOM</a:t>
+              <a:t>🚩 EARN LEAGUE POINTS</a:t>
             </a:r>
           </a:p>
           <a:p>
             <a:pPr>
               <a:spcBef>
-                <a:spcPts val="1000"/>
+                <a:spcPts val="1200"/>
               </a:spcBef>
-              <a:defRPr sz="1350">
+              <a:defRPr sz="1350" b="1">
+                <a:solidFill>
+                  <a:srgbClr val="4ADE80"/>
+                </a:solidFill>
+                <a:latin typeface="Segoe UI"/>
+              </a:defRPr>
+            </a:pPr>
+            <a:r>
+              <a:t>• Point Value: +100 Points on Master Leaderboard</a:t>
+            </a:r>
+          </a:p>
+          <a:p>
+            <a:pPr>
+              <a:spcBef>
+                <a:spcPts val="800"/>
+              </a:spcBef>
+              <a:defRPr sz="1300">
                 <a:solidFill>
                   <a:srgbClr val="F8FAFC"/>
                 </a:solidFill>
@@ -7182,7 +7198,23 @@
               </a:defRPr>
             </a:pPr>
             <a:r>
-              <a:t>• Press F12 or Right-Click ➔ Inspect Element</a:t>
+              <a:t>• Flag Format: sfbu{...}</a:t>
+            </a:r>
+          </a:p>
+          <a:p>
+            <a:pPr>
+              <a:spcBef>
+                <a:spcPts val="800"/>
+              </a:spcBef>
+              <a:defRPr sz="1300">
+                <a:solidFill>
+                  <a:srgbClr val="F8FAFC"/>
+                </a:solidFill>
+                <a:latin typeface="Segoe UI"/>
+              </a:defRPr>
+            </a:pPr>
+            <a:r>
+              <a:t>• Challenge Portal: tinyurl.com/baysec-week4</a:t>
             </a:r>
           </a:p>
           <a:p>
@@ -7191,37 +7223,17 @@
                 <a:spcPts val="800"/>
               </a:spcBef>
               <a:spcAft>
-                <a:spcPts val="1000"/>
-              </a:spcAft>
-              <a:defRPr sz="1350">
-                <a:solidFill>
-                  <a:srgbClr val="F8FAFC"/>
-                </a:solidFill>
-                <a:latin typeface="Segoe UI"/>
-              </a:defRPr>
-            </a:pPr>
-            <a:r>
-              <a:t>• Examine HTML comments inside &lt;body&gt;:</a:t>
-            </a:r>
-          </a:p>
-          <a:p>
-            <a:pPr>
-              <a:spcAft>
                 <a:spcPts val="1600"/>
               </a:spcAft>
-              <a:defRPr sz="1150">
-                <a:solidFill>
-                  <a:srgbClr val="4ADE80"/>
-                </a:solidFill>
-                <a:latin typeface="Consolas"/>
-              </a:defRPr>
-            </a:pPr>
-            <a:r>
-              <a:t>&lt;!-- The flag is here:</a:t>
-            </a:r>
-            <a:br/>
-            <a:r>
-              <a:t>c2ZidXt3M2xjMG0zX3QwX2I0eXMzY18yMDI2fQ== --&gt;</a:t>
+              <a:defRPr sz="1300">
+                <a:solidFill>
+                  <a:srgbClr val="F8FAFC"/>
+                </a:solidFill>
+                <a:latin typeface="Segoe UI"/>
+              </a:defRPr>
+            </a:pPr>
+            <a:r>
+              <a:t>• Submission Window: Open 24/7 until Week 5 Kickoff</a:t>
             </a:r>
           </a:p>
           <a:p>
@@ -7234,7 +7246,7 @@
               </a:defRPr>
             </a:pPr>
             <a:r>
-              <a:t>Notice the trailing '==' padding — the classic tell of Base64 encoding!</a:t>
+              <a:t>💡 Hint: Inspect client-side source code carefully. Encoding is not encryption!</a:t>
             </a:r>
           </a:p>
         </p:txBody>
@@ -7289,13 +7301,13 @@
               </a:defRPr>
             </a:pPr>
             <a:r>
-              <a:t>STEP 2: DECODE BASE64</a:t>
+              <a:t>⏳ SOLUTION REVEAL &amp; DEBRIEF</a:t>
             </a:r>
           </a:p>
           <a:p>
             <a:pPr>
               <a:spcBef>
-                <a:spcPts val="1000"/>
+                <a:spcPts val="1200"/>
               </a:spcBef>
               <a:defRPr sz="1200" b="1">
                 <a:solidFill>
@@ -7305,23 +7317,26 @@
               </a:defRPr>
             </a:pPr>
             <a:r>
-              <a:t>METHOD A: BASH CLI</a:t>
+              <a:t>• Full Walkthrough Next Week:</a:t>
             </a:r>
           </a:p>
           <a:p>
             <a:pPr>
+              <a:spcBef>
+                <a:spcPts val="400"/>
+              </a:spcBef>
               <a:spcAft>
                 <a:spcPts val="1400"/>
               </a:spcAft>
-              <a:defRPr sz="1050">
+              <a:defRPr sz="1250">
                 <a:solidFill>
                   <a:srgbClr val="F8FAFC"/>
                 </a:solidFill>
-                <a:latin typeface="Consolas"/>
-              </a:defRPr>
-            </a:pPr>
-            <a:r>
-              <a:t>$ echo "c2ZidXt3M2xjMG0zX3QwX2I0eXMzY18yMDI2fQ==" | base64 -d</a:t>
+                <a:latin typeface="Segoe UI"/>
+              </a:defRPr>
+            </a:pPr>
+            <a:r>
+              <a:t>The complete step-by-step exploit breakdown and source inspection solution will be revealed at the START OF NEXT WEEK'S SESSION (Week 5)!</a:t>
             </a:r>
           </a:p>
           <a:p>
@@ -7334,15 +7349,18 @@
               </a:defRPr>
             </a:pPr>
             <a:r>
-              <a:t>METHOD B: CYBERCHEF</a:t>
+              <a:t>• Lock In Your Points:</a:t>
             </a:r>
           </a:p>
           <a:p>
             <a:pPr>
+              <a:spcBef>
+                <a:spcPts val="400"/>
+              </a:spcBef>
               <a:spcAft>
-                <a:spcPts val="1600"/>
+                <a:spcPts val="1400"/>
               </a:spcAft>
-              <a:defRPr sz="1300">
+              <a:defRPr sz="1250">
                 <a:solidFill>
                   <a:srgbClr val="F8FAFC"/>
                 </a:solidFill>
@@ -7350,33 +7368,20 @@
               </a:defRPr>
             </a:pPr>
             <a:r>
-              <a:t>Paste into CyberChef ➔ Add recipe 'From Base64'</a:t>
+              <a:t>Submit before next week to claim your points and advance your tier ranking.</a:t>
             </a:r>
           </a:p>
           <a:p>
             <a:pPr>
-              <a:defRPr sz="1200">
-                <a:solidFill>
-                  <a:srgbClr val="94A3B8"/>
+              <a:defRPr sz="1150" b="1">
+                <a:solidFill>
+                  <a:srgbClr val="00F0FF"/>
                 </a:solidFill>
                 <a:latin typeface="Consolas"/>
               </a:defRPr>
             </a:pPr>
             <a:r>
-              <a:t>FLAG RECOVERED:</a:t>
-            </a:r>
-          </a:p>
-          <a:p>
-            <a:pPr>
-              <a:defRPr sz="1500" b="1">
-                <a:solidFill>
-                  <a:srgbClr val="4ADE80"/>
-                </a:solidFill>
-                <a:latin typeface="Consolas"/>
-              </a:defRPr>
-            </a:pPr>
-            <a:r>
-              <a:t>sfbu{w3lc0m3_t0_b4ys3c_2026}</a:t>
+              <a:t>TRACK LIVE STANDINGS: baysec/leaderboard.html</a:t>
             </a:r>
           </a:p>
         </p:txBody>
@@ -7400,7 +7405,7 @@
           </a:solidFill>
           <a:ln w="19050">
             <a:solidFill>
-              <a:srgbClr val="EF4444"/>
+              <a:srgbClr val="00F0FF"/>
             </a:solidFill>
           </a:ln>
         </p:spPr>
@@ -7431,7 +7436,7 @@
               </a:defRPr>
             </a:pPr>
             <a:r>
-              <a:t>⚠️ KEY TAKEAWAY: Never store secrets, comments, or sensitive auth logic inside client-rendered markup.</a:t>
+              <a:t>🏆 Every challenge solved earns points toward end-of-semester Sentinel &amp; Grandmaster prizes!</a:t>
             </a:r>
           </a:p>
         </p:txBody>

</xml_diff>